<commit_message>
oct 31 liwei create skeleton for pre ppt
</commit_message>
<xml_diff>
--- a/pre.pptx
+++ b/pre.pptx
@@ -7,6 +7,12 @@
   <p:sldIdLst>
     <p:sldId id="256" r:id="rId2"/>
     <p:sldId id="257" r:id="rId3"/>
+    <p:sldId id="258" r:id="rId4"/>
+    <p:sldId id="259" r:id="rId5"/>
+    <p:sldId id="260" r:id="rId6"/>
+    <p:sldId id="261" r:id="rId7"/>
+    <p:sldId id="262" r:id="rId8"/>
+    <p:sldId id="263" r:id="rId9"/>
   </p:sldIdLst>
   <p:sldSz cx="12192000" cy="6858000"/>
   <p:notesSz cx="6858000" cy="9144000"/>
@@ -105,6 +111,11 @@
       </a:defRPr>
     </a:lvl9pPr>
   </p:defaultTextStyle>
+  <p:extLst>
+    <p:ext uri="{EFAFB233-063F-42B5-8137-9DF3F51BA10A}">
+      <p15:sldGuideLst xmlns:p15="http://schemas.microsoft.com/office/powerpoint/2012/main"/>
+    </p:ext>
+  </p:extLst>
 </p:presentation>
 </file>
 
@@ -3394,10 +3405,10 @@
           <a:lstStyle/>
           <a:p>
             <a:r>
-              <a:rPr kumimoji="1" lang="en-US" altLang="zh-CN"/>
+              <a:rPr kumimoji="1" lang="en-US" altLang="zh-CN" dirty="0"/>
               <a:t>Liwei Mei, Qi Guo</a:t>
             </a:r>
-            <a:endParaRPr kumimoji="1" lang="zh-CN" altLang="en-US"/>
+            <a:endParaRPr kumimoji="1" lang="zh-CN" altLang="en-US" dirty="0"/>
           </a:p>
         </p:txBody>
       </p:sp>
@@ -3431,10 +3442,3343 @@
           <a:chExt cx="0" cy="0"/>
         </a:xfrm>
       </p:grpSpPr>
+      <mc:AlternateContent xmlns:mc="http://schemas.openxmlformats.org/markup-compatibility/2006">
+        <mc:Choice xmlns:a14="http://schemas.microsoft.com/office/drawing/2010/main" Requires="a14">
+          <p:sp>
+            <p:nvSpPr>
+              <p:cNvPr id="2" name="文本框 1">
+                <a:extLst>
+                  <a:ext uri="{FF2B5EF4-FFF2-40B4-BE49-F238E27FC236}">
+                    <a16:creationId xmlns:a16="http://schemas.microsoft.com/office/drawing/2014/main" id="{3A95E442-36D0-88A8-A099-53143233BDC4}"/>
+                  </a:ext>
+                </a:extLst>
+              </p:cNvPr>
+              <p:cNvSpPr txBox="1"/>
+              <p:nvPr/>
+            </p:nvSpPr>
+            <p:spPr>
+              <a:xfrm>
+                <a:off x="2529683" y="1370636"/>
+                <a:ext cx="1517531" cy="276999"/>
+              </a:xfrm>
+              <a:prstGeom prst="rect">
+                <a:avLst/>
+              </a:prstGeom>
+              <a:noFill/>
+            </p:spPr>
+            <p:txBody>
+              <a:bodyPr wrap="none" lIns="0" tIns="0" rIns="0" bIns="0" rtlCol="0">
+                <a:spAutoFit/>
+              </a:bodyPr>
+              <a:lstStyle/>
+              <a:p>
+                <a14:m>
+                  <m:oMathPara xmlns:m="http://schemas.openxmlformats.org/officeDocument/2006/math">
+                    <m:oMath>
+                      <m:r>
+                        <a:rPr lang="en-US" altLang="zh-CN" b="0" i="1" smtClean="0">
+                          <a:latin typeface="Cambria Math" panose="02040503050406030204" pitchFamily="18" charset="0"/>
+                        </a:rPr>
+                        <m:t>𝑥</m:t>
+                      </m:r>
+                      <m:r>
+                        <a:rPr lang="en-US" altLang="zh-CN" b="0" i="1" smtClean="0">
+                          <a:latin typeface="Cambria Math" panose="02040503050406030204" pitchFamily="18" charset="0"/>
+                        </a:rPr>
+                        <m:t>=(</m:t>
+                      </m:r>
+                      <m:r>
+                        <a:rPr lang="en-US" altLang="zh-CN" b="0" i="1" smtClean="0">
+                          <a:latin typeface="Cambria Math" panose="02040503050406030204" pitchFamily="18" charset="0"/>
+                        </a:rPr>
+                        <m:t>𝜃</m:t>
+                      </m:r>
+                      <m:r>
+                        <a:rPr lang="en-US" altLang="zh-CN" b="0" i="1" smtClean="0">
+                          <a:latin typeface="Cambria Math" panose="02040503050406030204" pitchFamily="18" charset="0"/>
+                        </a:rPr>
+                        <m:t>,</m:t>
+                      </m:r>
+                      <m:r>
+                        <a:rPr lang="en-US" altLang="zh-CN" b="0" i="1" smtClean="0">
+                          <a:latin typeface="Cambria Math" panose="02040503050406030204" pitchFamily="18" charset="0"/>
+                        </a:rPr>
+                        <m:t>𝑝</m:t>
+                      </m:r>
+                      <m:r>
+                        <a:rPr lang="en-US" altLang="zh-CN" b="0" i="1" smtClean="0">
+                          <a:latin typeface="Cambria Math" panose="02040503050406030204" pitchFamily="18" charset="0"/>
+                        </a:rPr>
+                        <m:t>,</m:t>
+                      </m:r>
+                      <m:r>
+                        <a:rPr lang="en-US" altLang="zh-CN" b="0" i="1" smtClean="0">
+                          <a:latin typeface="Cambria Math" panose="02040503050406030204" pitchFamily="18" charset="0"/>
+                        </a:rPr>
+                        <m:t>𝜔</m:t>
+                      </m:r>
+                      <m:r>
+                        <a:rPr lang="en-US" altLang="zh-CN" b="0" i="1" smtClean="0">
+                          <a:latin typeface="Cambria Math" panose="02040503050406030204" pitchFamily="18" charset="0"/>
+                        </a:rPr>
+                        <m:t>,</m:t>
+                      </m:r>
+                      <m:r>
+                        <a:rPr lang="en-US" altLang="zh-CN" b="0" i="1" smtClean="0">
+                          <a:latin typeface="Cambria Math" panose="02040503050406030204" pitchFamily="18" charset="0"/>
+                        </a:rPr>
+                        <m:t>𝑣</m:t>
+                      </m:r>
+                      <m:r>
+                        <a:rPr lang="en-US" altLang="zh-CN" b="0" i="1" smtClean="0">
+                          <a:latin typeface="Cambria Math" panose="02040503050406030204" pitchFamily="18" charset="0"/>
+                        </a:rPr>
+                        <m:t>)</m:t>
+                      </m:r>
+                    </m:oMath>
+                  </m:oMathPara>
+                </a14:m>
+                <a:endParaRPr lang="zh-CN" altLang="en-US" dirty="0"/>
+              </a:p>
+            </p:txBody>
+          </p:sp>
+        </mc:Choice>
+        <mc:Fallback>
+          <p:sp>
+            <p:nvSpPr>
+              <p:cNvPr id="2" name="文本框 1">
+                <a:extLst>
+                  <a:ext uri="{FF2B5EF4-FFF2-40B4-BE49-F238E27FC236}">
+                    <a16:creationId xmlns:a16="http://schemas.microsoft.com/office/drawing/2014/main" id="{3A95E442-36D0-88A8-A099-53143233BDC4}"/>
+                  </a:ext>
+                </a:extLst>
+              </p:cNvPr>
+              <p:cNvSpPr txBox="1">
+                <a:spLocks noRot="1" noChangeAspect="1" noMove="1" noResize="1" noEditPoints="1" noAdjustHandles="1" noChangeArrowheads="1" noChangeShapeType="1" noTextEdit="1"/>
+              </p:cNvSpPr>
+              <p:nvPr/>
+            </p:nvSpPr>
+            <p:spPr>
+              <a:xfrm>
+                <a:off x="2529683" y="1370636"/>
+                <a:ext cx="1517531" cy="276999"/>
+              </a:xfrm>
+              <a:prstGeom prst="rect">
+                <a:avLst/>
+              </a:prstGeom>
+              <a:blipFill>
+                <a:blip r:embed="rId2"/>
+                <a:stretch>
+                  <a:fillRect l="-1606" t="-2222" r="-4819" b="-35556"/>
+                </a:stretch>
+              </a:blipFill>
+            </p:spPr>
+            <p:txBody>
+              <a:bodyPr/>
+              <a:lstStyle/>
+              <a:p>
+                <a:r>
+                  <a:rPr lang="zh-CN" altLang="en-US">
+                    <a:noFill/>
+                  </a:rPr>
+                  <a:t> </a:t>
+                </a:r>
+              </a:p>
+            </p:txBody>
+          </p:sp>
+        </mc:Fallback>
+      </mc:AlternateContent>
+      <p:sp>
+        <p:nvSpPr>
+          <p:cNvPr id="9" name="文本框 8">
+            <a:extLst>
+              <a:ext uri="{FF2B5EF4-FFF2-40B4-BE49-F238E27FC236}">
+                <a16:creationId xmlns:a16="http://schemas.microsoft.com/office/drawing/2014/main" id="{AE06144B-072F-C2DD-CDA7-82A0D67AA3BC}"/>
+              </a:ext>
+            </a:extLst>
+          </p:cNvPr>
+          <p:cNvSpPr txBox="1"/>
+          <p:nvPr/>
+        </p:nvSpPr>
+        <p:spPr>
+          <a:xfrm>
+            <a:off x="185420" y="242570"/>
+            <a:ext cx="1446230" cy="369332"/>
+          </a:xfrm>
+          <a:prstGeom prst="rect">
+            <a:avLst/>
+          </a:prstGeom>
+          <a:noFill/>
+        </p:spPr>
+        <p:txBody>
+          <a:bodyPr wrap="none" rtlCol="0">
+            <a:spAutoFit/>
+          </a:bodyPr>
+          <a:lstStyle/>
+          <a:p>
+            <a:r>
+              <a:rPr lang="en-US" altLang="zh-CN" b="1" dirty="0"/>
+              <a:t>Background</a:t>
+            </a:r>
+            <a:endParaRPr lang="zh-CN" altLang="en-US" b="1" dirty="0"/>
+          </a:p>
+        </p:txBody>
+      </p:sp>
+      <p:sp>
+        <p:nvSpPr>
+          <p:cNvPr id="10" name="文本框 9">
+            <a:extLst>
+              <a:ext uri="{FF2B5EF4-FFF2-40B4-BE49-F238E27FC236}">
+                <a16:creationId xmlns:a16="http://schemas.microsoft.com/office/drawing/2014/main" id="{ED2B6F3F-EB1C-AEB2-D06B-0FE50C66750F}"/>
+              </a:ext>
+            </a:extLst>
+          </p:cNvPr>
+          <p:cNvSpPr txBox="1"/>
+          <p:nvPr/>
+        </p:nvSpPr>
+        <p:spPr>
+          <a:xfrm>
+            <a:off x="185420" y="790853"/>
+            <a:ext cx="7723589" cy="369332"/>
+          </a:xfrm>
+          <a:prstGeom prst="rect">
+            <a:avLst/>
+          </a:prstGeom>
+          <a:noFill/>
+        </p:spPr>
+        <p:txBody>
+          <a:bodyPr wrap="none" rtlCol="0">
+            <a:spAutoFit/>
+          </a:bodyPr>
+          <a:lstStyle/>
+          <a:p>
+            <a:r>
+              <a:rPr lang="en-US" altLang="zh-CN" dirty="0"/>
+              <a:t>Model </a:t>
+            </a:r>
+            <a:r>
+              <a:rPr lang="en-US" altLang="zh-CN" dirty="0" err="1"/>
+              <a:t>Simplication</a:t>
+            </a:r>
+            <a:r>
+              <a:rPr lang="en-US" altLang="zh-CN" dirty="0"/>
+              <a:t>: Torso (move in generalized coordinates) + massless legs</a:t>
+            </a:r>
+            <a:endParaRPr lang="zh-CN" altLang="en-US" dirty="0"/>
+          </a:p>
+        </p:txBody>
+      </p:sp>
+      <p:sp>
+        <p:nvSpPr>
+          <p:cNvPr id="12" name="文本框 11">
+            <a:extLst>
+              <a:ext uri="{FF2B5EF4-FFF2-40B4-BE49-F238E27FC236}">
+                <a16:creationId xmlns:a16="http://schemas.microsoft.com/office/drawing/2014/main" id="{39A87ADF-0FE0-464C-9FEA-562893E40C22}"/>
+              </a:ext>
+            </a:extLst>
+          </p:cNvPr>
+          <p:cNvSpPr txBox="1"/>
+          <p:nvPr/>
+        </p:nvSpPr>
+        <p:spPr>
+          <a:xfrm>
+            <a:off x="185420" y="1324470"/>
+            <a:ext cx="684803" cy="369332"/>
+          </a:xfrm>
+          <a:prstGeom prst="rect">
+            <a:avLst/>
+          </a:prstGeom>
+          <a:noFill/>
+        </p:spPr>
+        <p:txBody>
+          <a:bodyPr wrap="none" rtlCol="0">
+            <a:spAutoFit/>
+          </a:bodyPr>
+          <a:lstStyle/>
+          <a:p>
+            <a:r>
+              <a:rPr lang="en-US" altLang="zh-CN" dirty="0"/>
+              <a:t>State</a:t>
+            </a:r>
+            <a:endParaRPr lang="zh-CN" altLang="en-US" dirty="0"/>
+          </a:p>
+        </p:txBody>
+      </p:sp>
+      <mc:AlternateContent xmlns:mc="http://schemas.openxmlformats.org/markup-compatibility/2006">
+        <mc:Choice xmlns:a14="http://schemas.microsoft.com/office/drawing/2010/main" Requires="a14">
+          <p:sp>
+            <p:nvSpPr>
+              <p:cNvPr id="13" name="文本框 12">
+                <a:extLst>
+                  <a:ext uri="{FF2B5EF4-FFF2-40B4-BE49-F238E27FC236}">
+                    <a16:creationId xmlns:a16="http://schemas.microsoft.com/office/drawing/2014/main" id="{772488BA-EA37-8D8E-A263-F075B1499C3C}"/>
+                  </a:ext>
+                </a:extLst>
+              </p:cNvPr>
+              <p:cNvSpPr txBox="1"/>
+              <p:nvPr/>
+            </p:nvSpPr>
+            <p:spPr>
+              <a:xfrm>
+                <a:off x="2529683" y="1752600"/>
+                <a:ext cx="1817997" cy="672235"/>
+              </a:xfrm>
+              <a:prstGeom prst="rect">
+                <a:avLst/>
+              </a:prstGeom>
+              <a:noFill/>
+            </p:spPr>
+            <p:txBody>
+              <a:bodyPr wrap="none" lIns="0" tIns="0" rIns="0" bIns="0" rtlCol="0">
+                <a:spAutoFit/>
+              </a:bodyPr>
+              <a:lstStyle/>
+              <a:p>
+                <a14:m>
+                  <m:oMathPara xmlns:m="http://schemas.openxmlformats.org/officeDocument/2006/math">
+                    <m:oMath>
+                      <m:r>
+                        <a:rPr lang="en-US" altLang="zh-CN" b="0" i="1" smtClean="0">
+                          <a:latin typeface="Cambria Math" panose="02040503050406030204" pitchFamily="18" charset="0"/>
+                        </a:rPr>
+                        <m:t>𝑚</m:t>
+                      </m:r>
+                      <m:acc>
+                        <m:accPr>
+                          <m:chr m:val="̇"/>
+                          <m:ctrlPr>
+                            <a:rPr lang="en-US" altLang="zh-CN" b="0" i="1" smtClean="0">
+                              <a:latin typeface="Cambria Math" panose="02040503050406030204" pitchFamily="18" charset="0"/>
+                            </a:rPr>
+                          </m:ctrlPr>
+                        </m:accPr>
+                        <m:e>
+                          <m:r>
+                            <a:rPr lang="en-US" altLang="zh-CN" b="0" i="1" smtClean="0">
+                              <a:latin typeface="Cambria Math" panose="02040503050406030204" pitchFamily="18" charset="0"/>
+                            </a:rPr>
+                            <m:t>𝑣</m:t>
+                          </m:r>
+                        </m:e>
+                      </m:acc>
+                      <m:r>
+                        <a:rPr lang="en-US" altLang="zh-CN" b="0" i="1" smtClean="0">
+                          <a:latin typeface="Cambria Math" panose="02040503050406030204" pitchFamily="18" charset="0"/>
+                        </a:rPr>
+                        <m:t>=</m:t>
+                      </m:r>
+                      <m:nary>
+                        <m:naryPr>
+                          <m:chr m:val="∑"/>
+                          <m:supHide m:val="on"/>
+                          <m:ctrlPr>
+                            <a:rPr lang="en-US" altLang="zh-CN" b="0" i="1" smtClean="0">
+                              <a:latin typeface="Cambria Math" panose="02040503050406030204" pitchFamily="18" charset="0"/>
+                            </a:rPr>
+                          </m:ctrlPr>
+                        </m:naryPr>
+                        <m:sub>
+                          <m:r>
+                            <a:rPr lang="en-US" altLang="zh-CN" b="0" i="1" smtClean="0">
+                              <a:latin typeface="Cambria Math" panose="02040503050406030204" pitchFamily="18" charset="0"/>
+                            </a:rPr>
+                            <m:t>𝑖</m:t>
+                          </m:r>
+                          <m:r>
+                            <a:rPr lang="en-US" altLang="zh-CN" b="0" i="1" smtClean="0">
+                              <a:latin typeface="Cambria Math" panose="02040503050406030204" pitchFamily="18" charset="0"/>
+                            </a:rPr>
+                            <m:t>∈</m:t>
+                          </m:r>
+                          <m:r>
+                            <a:rPr lang="en-US" altLang="zh-CN" b="0" i="1" smtClean="0">
+                              <a:latin typeface="Cambria Math" panose="02040503050406030204" pitchFamily="18" charset="0"/>
+                            </a:rPr>
+                            <m:t>𝑆</m:t>
+                          </m:r>
+                        </m:sub>
+                        <m:sup/>
+                        <m:e>
+                          <m:sSub>
+                            <m:sSubPr>
+                              <m:ctrlPr>
+                                <a:rPr lang="en-US" altLang="zh-CN" b="0" i="1" smtClean="0">
+                                  <a:latin typeface="Cambria Math" panose="02040503050406030204" pitchFamily="18" charset="0"/>
+                                </a:rPr>
+                              </m:ctrlPr>
+                            </m:sSubPr>
+                            <m:e>
+                              <m:r>
+                                <a:rPr lang="en-US" altLang="zh-CN" b="0" i="1" smtClean="0">
+                                  <a:latin typeface="Cambria Math" panose="02040503050406030204" pitchFamily="18" charset="0"/>
+                                </a:rPr>
+                                <m:t>𝑓</m:t>
+                              </m:r>
+                            </m:e>
+                            <m:sub>
+                              <m:r>
+                                <a:rPr lang="en-US" altLang="zh-CN" b="0" i="1" smtClean="0">
+                                  <a:latin typeface="Cambria Math" panose="02040503050406030204" pitchFamily="18" charset="0"/>
+                                </a:rPr>
+                                <m:t>𝑖</m:t>
+                              </m:r>
+                            </m:sub>
+                          </m:sSub>
+                        </m:e>
+                      </m:nary>
+                      <m:r>
+                        <a:rPr lang="en-US" altLang="zh-CN" b="0" i="1" smtClean="0">
+                          <a:latin typeface="Cambria Math" panose="02040503050406030204" pitchFamily="18" charset="0"/>
+                        </a:rPr>
+                        <m:t>−</m:t>
+                      </m:r>
+                      <m:r>
+                        <a:rPr lang="en-US" altLang="zh-CN" b="0" i="1" smtClean="0">
+                          <a:latin typeface="Cambria Math" panose="02040503050406030204" pitchFamily="18" charset="0"/>
+                        </a:rPr>
+                        <m:t>𝑚𝑔</m:t>
+                      </m:r>
+                    </m:oMath>
+                  </m:oMathPara>
+                </a14:m>
+                <a:endParaRPr lang="zh-CN" altLang="en-US" dirty="0"/>
+              </a:p>
+            </p:txBody>
+          </p:sp>
+        </mc:Choice>
+        <mc:Fallback>
+          <p:sp>
+            <p:nvSpPr>
+              <p:cNvPr id="13" name="文本框 12">
+                <a:extLst>
+                  <a:ext uri="{FF2B5EF4-FFF2-40B4-BE49-F238E27FC236}">
+                    <a16:creationId xmlns:a16="http://schemas.microsoft.com/office/drawing/2014/main" id="{772488BA-EA37-8D8E-A263-F075B1499C3C}"/>
+                  </a:ext>
+                </a:extLst>
+              </p:cNvPr>
+              <p:cNvSpPr txBox="1">
+                <a:spLocks noRot="1" noChangeAspect="1" noMove="1" noResize="1" noEditPoints="1" noAdjustHandles="1" noChangeArrowheads="1" noChangeShapeType="1" noTextEdit="1"/>
+              </p:cNvSpPr>
+              <p:nvPr/>
+            </p:nvSpPr>
+            <p:spPr>
+              <a:xfrm>
+                <a:off x="2529683" y="1752600"/>
+                <a:ext cx="1817997" cy="672235"/>
+              </a:xfrm>
+              <a:prstGeom prst="rect">
+                <a:avLst/>
+              </a:prstGeom>
+              <a:blipFill>
+                <a:blip r:embed="rId3"/>
+                <a:stretch>
+                  <a:fillRect/>
+                </a:stretch>
+              </a:blipFill>
+            </p:spPr>
+            <p:txBody>
+              <a:bodyPr/>
+              <a:lstStyle/>
+              <a:p>
+                <a:r>
+                  <a:rPr lang="zh-CN" altLang="en-US">
+                    <a:noFill/>
+                  </a:rPr>
+                  <a:t> </a:t>
+                </a:r>
+              </a:p>
+            </p:txBody>
+          </p:sp>
+        </mc:Fallback>
+      </mc:AlternateContent>
+      <p:sp>
+        <p:nvSpPr>
+          <p:cNvPr id="14" name="文本框 13">
+            <a:extLst>
+              <a:ext uri="{FF2B5EF4-FFF2-40B4-BE49-F238E27FC236}">
+                <a16:creationId xmlns:a16="http://schemas.microsoft.com/office/drawing/2014/main" id="{8CB0D970-00ED-D257-F235-C36F570256BE}"/>
+              </a:ext>
+            </a:extLst>
+          </p:cNvPr>
+          <p:cNvSpPr txBox="1"/>
+          <p:nvPr/>
+        </p:nvSpPr>
+        <p:spPr>
+          <a:xfrm>
+            <a:off x="185420" y="1858086"/>
+            <a:ext cx="1829347" cy="369332"/>
+          </a:xfrm>
+          <a:prstGeom prst="rect">
+            <a:avLst/>
+          </a:prstGeom>
+          <a:noFill/>
+        </p:spPr>
+        <p:txBody>
+          <a:bodyPr wrap="none" rtlCol="0">
+            <a:spAutoFit/>
+          </a:bodyPr>
+          <a:lstStyle/>
+          <a:p>
+            <a:r>
+              <a:rPr lang="en-US" altLang="zh-CN" dirty="0"/>
+              <a:t>Dynamics model</a:t>
+            </a:r>
+            <a:endParaRPr lang="zh-CN" altLang="en-US" dirty="0"/>
+          </a:p>
+        </p:txBody>
+      </p:sp>
+      <mc:AlternateContent xmlns:mc="http://schemas.openxmlformats.org/markup-compatibility/2006">
+        <mc:Choice xmlns:a14="http://schemas.microsoft.com/office/drawing/2010/main" Requires="a14">
+          <p:sp>
+            <p:nvSpPr>
+              <p:cNvPr id="16" name="文本框 15">
+                <a:extLst>
+                  <a:ext uri="{FF2B5EF4-FFF2-40B4-BE49-F238E27FC236}">
+                    <a16:creationId xmlns:a16="http://schemas.microsoft.com/office/drawing/2014/main" id="{FCE1296F-3E54-7B8E-4995-6964789A741D}"/>
+                  </a:ext>
+                </a:extLst>
+              </p:cNvPr>
+              <p:cNvSpPr txBox="1"/>
+              <p:nvPr/>
+            </p:nvSpPr>
+            <p:spPr>
+              <a:xfrm>
+                <a:off x="4923633" y="1752600"/>
+                <a:ext cx="1460976" cy="672235"/>
+              </a:xfrm>
+              <a:prstGeom prst="rect">
+                <a:avLst/>
+              </a:prstGeom>
+              <a:noFill/>
+            </p:spPr>
+            <p:txBody>
+              <a:bodyPr wrap="none" lIns="0" tIns="0" rIns="0" bIns="0" rtlCol="0">
+                <a:spAutoFit/>
+              </a:bodyPr>
+              <a:lstStyle/>
+              <a:p>
+                <a14:m>
+                  <m:oMathPara xmlns:m="http://schemas.openxmlformats.org/officeDocument/2006/math">
+                    <m:oMath>
+                      <m:r>
+                        <a:rPr lang="en-US" altLang="zh-CN" b="0" i="1" smtClean="0">
+                          <a:latin typeface="Cambria Math" panose="02040503050406030204" pitchFamily="18" charset="0"/>
+                        </a:rPr>
+                        <m:t>𝐼</m:t>
+                      </m:r>
+                      <m:acc>
+                        <m:accPr>
+                          <m:chr m:val="̇"/>
+                          <m:ctrlPr>
+                            <a:rPr lang="en-US" altLang="zh-CN" b="0" i="1" smtClean="0">
+                              <a:latin typeface="Cambria Math" panose="02040503050406030204" pitchFamily="18" charset="0"/>
+                            </a:rPr>
+                          </m:ctrlPr>
+                        </m:accPr>
+                        <m:e>
+                          <m:r>
+                            <a:rPr lang="en-US" altLang="zh-CN" b="0" i="1" smtClean="0">
+                              <a:latin typeface="Cambria Math" panose="02040503050406030204" pitchFamily="18" charset="0"/>
+                            </a:rPr>
+                            <m:t>𝜔</m:t>
+                          </m:r>
+                        </m:e>
+                      </m:acc>
+                      <m:r>
+                        <a:rPr lang="en-US" altLang="zh-CN" b="0" i="1" smtClean="0">
+                          <a:latin typeface="Cambria Math" panose="02040503050406030204" pitchFamily="18" charset="0"/>
+                        </a:rPr>
+                        <m:t>≈</m:t>
+                      </m:r>
+                      <m:nary>
+                        <m:naryPr>
+                          <m:chr m:val="∑"/>
+                          <m:supHide m:val="on"/>
+                          <m:ctrlPr>
+                            <a:rPr lang="en-US" altLang="zh-CN" b="0" i="1" smtClean="0">
+                              <a:latin typeface="Cambria Math" panose="02040503050406030204" pitchFamily="18" charset="0"/>
+                            </a:rPr>
+                          </m:ctrlPr>
+                        </m:naryPr>
+                        <m:sub>
+                          <m:r>
+                            <a:rPr lang="en-US" altLang="zh-CN" b="0" i="1" smtClean="0">
+                              <a:latin typeface="Cambria Math" panose="02040503050406030204" pitchFamily="18" charset="0"/>
+                            </a:rPr>
+                            <m:t>𝑖</m:t>
+                          </m:r>
+                          <m:r>
+                            <a:rPr lang="en-US" altLang="zh-CN" b="0" i="1" smtClean="0">
+                              <a:latin typeface="Cambria Math" panose="02040503050406030204" pitchFamily="18" charset="0"/>
+                            </a:rPr>
+                            <m:t>∈</m:t>
+                          </m:r>
+                          <m:r>
+                            <a:rPr lang="en-US" altLang="zh-CN" b="0" i="1" smtClean="0">
+                              <a:latin typeface="Cambria Math" panose="02040503050406030204" pitchFamily="18" charset="0"/>
+                            </a:rPr>
+                            <m:t>𝑆</m:t>
+                          </m:r>
+                        </m:sub>
+                        <m:sup/>
+                        <m:e>
+                          <m:sSub>
+                            <m:sSubPr>
+                              <m:ctrlPr>
+                                <a:rPr lang="en-US" altLang="zh-CN" b="0" i="1" smtClean="0">
+                                  <a:latin typeface="Cambria Math" panose="02040503050406030204" pitchFamily="18" charset="0"/>
+                                </a:rPr>
+                              </m:ctrlPr>
+                            </m:sSubPr>
+                            <m:e>
+                              <m:r>
+                                <a:rPr lang="en-US" altLang="zh-CN" b="0" i="1" smtClean="0">
+                                  <a:latin typeface="Cambria Math" panose="02040503050406030204" pitchFamily="18" charset="0"/>
+                                </a:rPr>
+                                <m:t>𝑟</m:t>
+                              </m:r>
+                            </m:e>
+                            <m:sub>
+                              <m:r>
+                                <a:rPr lang="en-US" altLang="zh-CN" b="0" i="1" smtClean="0">
+                                  <a:latin typeface="Cambria Math" panose="02040503050406030204" pitchFamily="18" charset="0"/>
+                                </a:rPr>
+                                <m:t>𝑖</m:t>
+                              </m:r>
+                            </m:sub>
+                          </m:sSub>
+                          <m:r>
+                            <a:rPr lang="en-US" altLang="zh-CN" b="0" i="1" smtClean="0">
+                              <a:latin typeface="Cambria Math" panose="02040503050406030204" pitchFamily="18" charset="0"/>
+                            </a:rPr>
+                            <m:t>×</m:t>
+                          </m:r>
+                          <m:sSub>
+                            <m:sSubPr>
+                              <m:ctrlPr>
+                                <a:rPr lang="en-US" altLang="zh-CN" b="0" i="1" smtClean="0">
+                                  <a:latin typeface="Cambria Math" panose="02040503050406030204" pitchFamily="18" charset="0"/>
+                                </a:rPr>
+                              </m:ctrlPr>
+                            </m:sSubPr>
+                            <m:e>
+                              <m:r>
+                                <a:rPr lang="en-US" altLang="zh-CN" b="0" i="1" smtClean="0">
+                                  <a:latin typeface="Cambria Math" panose="02040503050406030204" pitchFamily="18" charset="0"/>
+                                </a:rPr>
+                                <m:t>𝑓</m:t>
+                              </m:r>
+                            </m:e>
+                            <m:sub>
+                              <m:r>
+                                <a:rPr lang="en-US" altLang="zh-CN" b="0" i="1" smtClean="0">
+                                  <a:latin typeface="Cambria Math" panose="02040503050406030204" pitchFamily="18" charset="0"/>
+                                </a:rPr>
+                                <m:t>𝑖</m:t>
+                              </m:r>
+                            </m:sub>
+                          </m:sSub>
+                        </m:e>
+                      </m:nary>
+                    </m:oMath>
+                  </m:oMathPara>
+                </a14:m>
+                <a:endParaRPr lang="zh-CN" altLang="en-US" dirty="0"/>
+              </a:p>
+            </p:txBody>
+          </p:sp>
+        </mc:Choice>
+        <mc:Fallback>
+          <p:sp>
+            <p:nvSpPr>
+              <p:cNvPr id="16" name="文本框 15">
+                <a:extLst>
+                  <a:ext uri="{FF2B5EF4-FFF2-40B4-BE49-F238E27FC236}">
+                    <a16:creationId xmlns:a16="http://schemas.microsoft.com/office/drawing/2014/main" id="{FCE1296F-3E54-7B8E-4995-6964789A741D}"/>
+                  </a:ext>
+                </a:extLst>
+              </p:cNvPr>
+              <p:cNvSpPr txBox="1">
+                <a:spLocks noRot="1" noChangeAspect="1" noMove="1" noResize="1" noEditPoints="1" noAdjustHandles="1" noChangeArrowheads="1" noChangeShapeType="1" noTextEdit="1"/>
+              </p:cNvSpPr>
+              <p:nvPr/>
+            </p:nvSpPr>
+            <p:spPr>
+              <a:xfrm>
+                <a:off x="4923633" y="1752600"/>
+                <a:ext cx="1460976" cy="672235"/>
+              </a:xfrm>
+              <a:prstGeom prst="rect">
+                <a:avLst/>
+              </a:prstGeom>
+              <a:blipFill>
+                <a:blip r:embed="rId4"/>
+                <a:stretch>
+                  <a:fillRect/>
+                </a:stretch>
+              </a:blipFill>
+            </p:spPr>
+            <p:txBody>
+              <a:bodyPr/>
+              <a:lstStyle/>
+              <a:p>
+                <a:r>
+                  <a:rPr lang="zh-CN" altLang="en-US">
+                    <a:noFill/>
+                  </a:rPr>
+                  <a:t> </a:t>
+                </a:r>
+              </a:p>
+            </p:txBody>
+          </p:sp>
+        </mc:Fallback>
+      </mc:AlternateContent>
+      <mc:AlternateContent xmlns:mc="http://schemas.openxmlformats.org/markup-compatibility/2006">
+        <mc:Choice xmlns:a14="http://schemas.microsoft.com/office/drawing/2010/main" Requires="a14">
+          <p:sp>
+            <p:nvSpPr>
+              <p:cNvPr id="17" name="文本框 16">
+                <a:extLst>
+                  <a:ext uri="{FF2B5EF4-FFF2-40B4-BE49-F238E27FC236}">
+                    <a16:creationId xmlns:a16="http://schemas.microsoft.com/office/drawing/2014/main" id="{1F7F4401-1AC9-077E-365F-219603796C58}"/>
+                  </a:ext>
+                </a:extLst>
+              </p:cNvPr>
+              <p:cNvSpPr txBox="1"/>
+              <p:nvPr/>
+            </p:nvSpPr>
+            <p:spPr>
+              <a:xfrm>
+                <a:off x="6960562" y="1950217"/>
+                <a:ext cx="1456809" cy="276999"/>
+              </a:xfrm>
+              <a:prstGeom prst="rect">
+                <a:avLst/>
+              </a:prstGeom>
+              <a:noFill/>
+            </p:spPr>
+            <p:txBody>
+              <a:bodyPr wrap="none" lIns="0" tIns="0" rIns="0" bIns="0" rtlCol="0">
+                <a:spAutoFit/>
+              </a:bodyPr>
+              <a:lstStyle/>
+              <a:p>
+                <a14:m>
+                  <m:oMath xmlns:m="http://schemas.openxmlformats.org/officeDocument/2006/math">
+                    <m:r>
+                      <a:rPr lang="en-US" altLang="zh-CN" b="0" i="1" smtClean="0">
+                        <a:latin typeface="Cambria Math" panose="02040503050406030204" pitchFamily="18" charset="0"/>
+                      </a:rPr>
+                      <m:t>𝑆</m:t>
+                    </m:r>
+                    <m:r>
+                      <a:rPr lang="en-US" altLang="zh-CN" b="0" i="1" smtClean="0">
+                        <a:latin typeface="Cambria Math" panose="02040503050406030204" pitchFamily="18" charset="0"/>
+                      </a:rPr>
+                      <m:t>=</m:t>
+                    </m:r>
+                  </m:oMath>
+                </a14:m>
+                <a:r>
+                  <a:rPr lang="en-US" altLang="zh-CN" dirty="0"/>
+                  <a:t>stance legs</a:t>
+                </a:r>
+                <a:endParaRPr lang="zh-CN" altLang="en-US" dirty="0"/>
+              </a:p>
+            </p:txBody>
+          </p:sp>
+        </mc:Choice>
+        <mc:Fallback>
+          <p:sp>
+            <p:nvSpPr>
+              <p:cNvPr id="17" name="文本框 16">
+                <a:extLst>
+                  <a:ext uri="{FF2B5EF4-FFF2-40B4-BE49-F238E27FC236}">
+                    <a16:creationId xmlns:a16="http://schemas.microsoft.com/office/drawing/2014/main" id="{1F7F4401-1AC9-077E-365F-219603796C58}"/>
+                  </a:ext>
+                </a:extLst>
+              </p:cNvPr>
+              <p:cNvSpPr txBox="1">
+                <a:spLocks noRot="1" noChangeAspect="1" noMove="1" noResize="1" noEditPoints="1" noAdjustHandles="1" noChangeArrowheads="1" noChangeShapeType="1" noTextEdit="1"/>
+              </p:cNvSpPr>
+              <p:nvPr/>
+            </p:nvSpPr>
+            <p:spPr>
+              <a:xfrm>
+                <a:off x="6960562" y="1950217"/>
+                <a:ext cx="1456809" cy="276999"/>
+              </a:xfrm>
+              <a:prstGeom prst="rect">
+                <a:avLst/>
+              </a:prstGeom>
+              <a:blipFill>
+                <a:blip r:embed="rId5"/>
+                <a:stretch>
+                  <a:fillRect l="-5858" t="-28889" r="-9205" b="-51111"/>
+                </a:stretch>
+              </a:blipFill>
+            </p:spPr>
+            <p:txBody>
+              <a:bodyPr/>
+              <a:lstStyle/>
+              <a:p>
+                <a:r>
+                  <a:rPr lang="zh-CN" altLang="en-US">
+                    <a:noFill/>
+                  </a:rPr>
+                  <a:t> </a:t>
+                </a:r>
+              </a:p>
+            </p:txBody>
+          </p:sp>
+        </mc:Fallback>
+      </mc:AlternateContent>
+      <p:sp>
+        <p:nvSpPr>
+          <p:cNvPr id="19" name="文本框 18">
+            <a:extLst>
+              <a:ext uri="{FF2B5EF4-FFF2-40B4-BE49-F238E27FC236}">
+                <a16:creationId xmlns:a16="http://schemas.microsoft.com/office/drawing/2014/main" id="{84E35AC0-19CA-772B-3D88-651896C13FDE}"/>
+              </a:ext>
+            </a:extLst>
+          </p:cNvPr>
+          <p:cNvSpPr txBox="1"/>
+          <p:nvPr/>
+        </p:nvSpPr>
+        <p:spPr>
+          <a:xfrm>
+            <a:off x="185420" y="3178886"/>
+            <a:ext cx="1172116" cy="369332"/>
+          </a:xfrm>
+          <a:prstGeom prst="rect">
+            <a:avLst/>
+          </a:prstGeom>
+          <a:noFill/>
+        </p:spPr>
+        <p:txBody>
+          <a:bodyPr wrap="none" rtlCol="0">
+            <a:spAutoFit/>
+          </a:bodyPr>
+          <a:lstStyle/>
+          <a:p>
+            <a:r>
+              <a:rPr lang="en-US" altLang="zh-CN" dirty="0"/>
+              <a:t>Controller</a:t>
+            </a:r>
+            <a:endParaRPr lang="zh-CN" altLang="en-US" dirty="0"/>
+          </a:p>
+        </p:txBody>
+      </p:sp>
+      <p:sp>
+        <p:nvSpPr>
+          <p:cNvPr id="20" name="矩形 19">
+            <a:extLst>
+              <a:ext uri="{FF2B5EF4-FFF2-40B4-BE49-F238E27FC236}">
+                <a16:creationId xmlns:a16="http://schemas.microsoft.com/office/drawing/2014/main" id="{97E03EA7-9881-8568-0D0B-F252878C4445}"/>
+              </a:ext>
+            </a:extLst>
+          </p:cNvPr>
+          <p:cNvSpPr/>
+          <p:nvPr/>
+        </p:nvSpPr>
+        <p:spPr>
+          <a:xfrm>
+            <a:off x="1799433" y="2963502"/>
+            <a:ext cx="1350733" cy="800100"/>
+          </a:xfrm>
+          <a:prstGeom prst="rect">
+            <a:avLst/>
+          </a:prstGeom>
+        </p:spPr>
+        <p:style>
+          <a:lnRef idx="2">
+            <a:schemeClr val="accent1">
+              <a:shade val="15000"/>
+            </a:schemeClr>
+          </a:lnRef>
+          <a:fillRef idx="1">
+            <a:schemeClr val="accent1"/>
+          </a:fillRef>
+          <a:effectRef idx="0">
+            <a:schemeClr val="accent1"/>
+          </a:effectRef>
+          <a:fontRef idx="minor">
+            <a:schemeClr val="lt1"/>
+          </a:fontRef>
+        </p:style>
+        <p:txBody>
+          <a:bodyPr rtlCol="0" anchor="ctr"/>
+          <a:lstStyle/>
+          <a:p>
+            <a:pPr algn="ctr"/>
+            <a:r>
+              <a:rPr lang="en-US" altLang="zh-CN" dirty="0"/>
+              <a:t>MPC</a:t>
+            </a:r>
+            <a:endParaRPr lang="zh-CN" altLang="en-US" dirty="0"/>
+          </a:p>
+        </p:txBody>
+      </p:sp>
+      <p:sp>
+        <p:nvSpPr>
+          <p:cNvPr id="21" name="文本框 20">
+            <a:extLst>
+              <a:ext uri="{FF2B5EF4-FFF2-40B4-BE49-F238E27FC236}">
+                <a16:creationId xmlns:a16="http://schemas.microsoft.com/office/drawing/2014/main" id="{D6F29E9A-90FF-9CDD-DDB0-106FFFEA8E9E}"/>
+              </a:ext>
+            </a:extLst>
+          </p:cNvPr>
+          <p:cNvSpPr txBox="1"/>
+          <p:nvPr/>
+        </p:nvSpPr>
+        <p:spPr>
+          <a:xfrm>
+            <a:off x="4667250" y="3244334"/>
+            <a:ext cx="4196983" cy="369332"/>
+          </a:xfrm>
+          <a:prstGeom prst="rect">
+            <a:avLst/>
+          </a:prstGeom>
+          <a:noFill/>
+        </p:spPr>
+        <p:txBody>
+          <a:bodyPr wrap="none" rtlCol="0">
+            <a:spAutoFit/>
+          </a:bodyPr>
+          <a:lstStyle/>
+          <a:p>
+            <a:r>
+              <a:rPr lang="en-US" altLang="zh-CN" dirty="0"/>
+              <a:t>Torso motion in generalized coordinates</a:t>
+            </a:r>
+            <a:endParaRPr lang="zh-CN" altLang="en-US" dirty="0"/>
+          </a:p>
+        </p:txBody>
+      </p:sp>
+      <p:sp>
+        <p:nvSpPr>
+          <p:cNvPr id="23" name="矩形 22">
+            <a:extLst>
+              <a:ext uri="{FF2B5EF4-FFF2-40B4-BE49-F238E27FC236}">
+                <a16:creationId xmlns:a16="http://schemas.microsoft.com/office/drawing/2014/main" id="{0FDEE4B9-5CB7-F6E9-A4A7-8A4C05D7236A}"/>
+              </a:ext>
+            </a:extLst>
+          </p:cNvPr>
+          <p:cNvSpPr/>
+          <p:nvPr/>
+        </p:nvSpPr>
+        <p:spPr>
+          <a:xfrm>
+            <a:off x="1799433" y="4302269"/>
+            <a:ext cx="1350733" cy="800100"/>
+          </a:xfrm>
+          <a:prstGeom prst="rect">
+            <a:avLst/>
+          </a:prstGeom>
+        </p:spPr>
+        <p:style>
+          <a:lnRef idx="2">
+            <a:schemeClr val="accent1">
+              <a:shade val="15000"/>
+            </a:schemeClr>
+          </a:lnRef>
+          <a:fillRef idx="1">
+            <a:schemeClr val="accent1"/>
+          </a:fillRef>
+          <a:effectRef idx="0">
+            <a:schemeClr val="accent1"/>
+          </a:effectRef>
+          <a:fontRef idx="minor">
+            <a:schemeClr val="lt1"/>
+          </a:fontRef>
+        </p:style>
+        <p:txBody>
+          <a:bodyPr rtlCol="0" anchor="ctr"/>
+          <a:lstStyle/>
+          <a:p>
+            <a:pPr algn="ctr"/>
+            <a:r>
+              <a:rPr lang="en-US" altLang="zh-CN" dirty="0"/>
+              <a:t>Gait Scheduler</a:t>
+            </a:r>
+            <a:endParaRPr lang="zh-CN" altLang="en-US" dirty="0"/>
+          </a:p>
+        </p:txBody>
+      </p:sp>
+      <p:sp>
+        <p:nvSpPr>
+          <p:cNvPr id="25" name="文本框 24">
+            <a:extLst>
+              <a:ext uri="{FF2B5EF4-FFF2-40B4-BE49-F238E27FC236}">
+                <a16:creationId xmlns:a16="http://schemas.microsoft.com/office/drawing/2014/main" id="{456F2E3D-7EA6-9691-8EB2-451CE9BC5C77}"/>
+              </a:ext>
+            </a:extLst>
+          </p:cNvPr>
+          <p:cNvSpPr txBox="1"/>
+          <p:nvPr/>
+        </p:nvSpPr>
+        <p:spPr>
+          <a:xfrm>
+            <a:off x="4978706" y="4379153"/>
+            <a:ext cx="3323347" cy="646331"/>
+          </a:xfrm>
+          <a:prstGeom prst="rect">
+            <a:avLst/>
+          </a:prstGeom>
+          <a:noFill/>
+        </p:spPr>
+        <p:txBody>
+          <a:bodyPr wrap="none" rtlCol="0">
+            <a:spAutoFit/>
+          </a:bodyPr>
+          <a:lstStyle/>
+          <a:p>
+            <a:pPr algn="ctr"/>
+            <a:r>
+              <a:rPr lang="en-US" altLang="zh-CN" dirty="0"/>
+              <a:t>Foot placement + Stance/swing</a:t>
+            </a:r>
+          </a:p>
+          <a:p>
+            <a:pPr algn="ctr"/>
+            <a:r>
+              <a:rPr lang="en-US" altLang="zh-CN" dirty="0"/>
+              <a:t> phase planning</a:t>
+            </a:r>
+            <a:endParaRPr lang="zh-CN" altLang="en-US" dirty="0"/>
+          </a:p>
+        </p:txBody>
+      </p:sp>
+      <p:sp>
+        <p:nvSpPr>
+          <p:cNvPr id="27" name="矩形 26">
+            <a:extLst>
+              <a:ext uri="{FF2B5EF4-FFF2-40B4-BE49-F238E27FC236}">
+                <a16:creationId xmlns:a16="http://schemas.microsoft.com/office/drawing/2014/main" id="{1B9527F5-D015-6FB9-30E1-1D9520694C36}"/>
+              </a:ext>
+            </a:extLst>
+          </p:cNvPr>
+          <p:cNvSpPr/>
+          <p:nvPr/>
+        </p:nvSpPr>
+        <p:spPr>
+          <a:xfrm>
+            <a:off x="1799432" y="5641036"/>
+            <a:ext cx="1350733" cy="800100"/>
+          </a:xfrm>
+          <a:prstGeom prst="rect">
+            <a:avLst/>
+          </a:prstGeom>
+        </p:spPr>
+        <p:style>
+          <a:lnRef idx="2">
+            <a:schemeClr val="accent1">
+              <a:shade val="15000"/>
+            </a:schemeClr>
+          </a:lnRef>
+          <a:fillRef idx="1">
+            <a:schemeClr val="accent1"/>
+          </a:fillRef>
+          <a:effectRef idx="0">
+            <a:schemeClr val="accent1"/>
+          </a:effectRef>
+          <a:fontRef idx="minor">
+            <a:schemeClr val="lt1"/>
+          </a:fontRef>
+        </p:style>
+        <p:txBody>
+          <a:bodyPr rtlCol="0" anchor="ctr"/>
+          <a:lstStyle/>
+          <a:p>
+            <a:pPr algn="ctr"/>
+            <a:r>
+              <a:rPr lang="en-US" altLang="zh-CN" dirty="0"/>
+              <a:t>Joint</a:t>
+            </a:r>
+          </a:p>
+          <a:p>
+            <a:pPr algn="ctr"/>
+            <a:r>
+              <a:rPr lang="en-US" altLang="zh-CN" dirty="0"/>
+              <a:t>Controller</a:t>
+            </a:r>
+            <a:endParaRPr lang="zh-CN" altLang="en-US" dirty="0"/>
+          </a:p>
+        </p:txBody>
+      </p:sp>
+      <p:sp>
+        <p:nvSpPr>
+          <p:cNvPr id="29" name="文本框 28">
+            <a:extLst>
+              <a:ext uri="{FF2B5EF4-FFF2-40B4-BE49-F238E27FC236}">
+                <a16:creationId xmlns:a16="http://schemas.microsoft.com/office/drawing/2014/main" id="{B9607ECC-8E7D-3BDD-1F7F-3B3D1AAA0593}"/>
+              </a:ext>
+            </a:extLst>
+          </p:cNvPr>
+          <p:cNvSpPr txBox="1"/>
+          <p:nvPr/>
+        </p:nvSpPr>
+        <p:spPr>
+          <a:xfrm>
+            <a:off x="5029199" y="5856419"/>
+            <a:ext cx="3451587" cy="369332"/>
+          </a:xfrm>
+          <a:prstGeom prst="rect">
+            <a:avLst/>
+          </a:prstGeom>
+          <a:noFill/>
+        </p:spPr>
+        <p:txBody>
+          <a:bodyPr wrap="none" rtlCol="0">
+            <a:spAutoFit/>
+          </a:bodyPr>
+          <a:lstStyle/>
+          <a:p>
+            <a:pPr algn="ctr"/>
+            <a:r>
+              <a:rPr lang="en-US" altLang="zh-CN" dirty="0"/>
+              <a:t>PD controller + Inverse dynamics</a:t>
+            </a:r>
+            <a:endParaRPr lang="zh-CN" altLang="en-US" dirty="0"/>
+          </a:p>
+        </p:txBody>
+      </p:sp>
+      <mc:AlternateContent xmlns:mc="http://schemas.openxmlformats.org/markup-compatibility/2006">
+        <mc:Choice xmlns:a14="http://schemas.microsoft.com/office/drawing/2010/main" Requires="a14">
+          <p:sp>
+            <p:nvSpPr>
+              <p:cNvPr id="31" name="文本框 30">
+                <a:extLst>
+                  <a:ext uri="{FF2B5EF4-FFF2-40B4-BE49-F238E27FC236}">
+                    <a16:creationId xmlns:a16="http://schemas.microsoft.com/office/drawing/2014/main" id="{A7AFA2D2-2502-CBD7-B930-B207A5063CE4}"/>
+                  </a:ext>
+                </a:extLst>
+              </p:cNvPr>
+              <p:cNvSpPr txBox="1"/>
+              <p:nvPr/>
+            </p:nvSpPr>
+            <p:spPr>
+              <a:xfrm>
+                <a:off x="3778690" y="4433166"/>
+                <a:ext cx="409023" cy="518604"/>
+              </a:xfrm>
+              <a:prstGeom prst="rect">
+                <a:avLst/>
+              </a:prstGeom>
+              <a:noFill/>
+            </p:spPr>
+            <p:txBody>
+              <a:bodyPr wrap="none" lIns="0" tIns="0" rIns="0" bIns="0" rtlCol="0">
+                <a:spAutoFit/>
+              </a:bodyPr>
+              <a:lstStyle/>
+              <a:p>
+                <a14:m>
+                  <m:oMathPara xmlns:m="http://schemas.openxmlformats.org/officeDocument/2006/math">
+                    <m:oMath>
+                      <m:r>
+                        <a:rPr lang="en-US" altLang="zh-CN" b="0" i="1" smtClean="0">
+                          <a:latin typeface="Cambria Math" panose="02040503050406030204" pitchFamily="18" charset="0"/>
+                        </a:rPr>
+                        <m:t>~</m:t>
+                      </m:r>
+                      <m:f>
+                        <m:fPr>
+                          <m:ctrlPr>
+                            <a:rPr lang="en-US" altLang="zh-CN" b="0" i="1" smtClean="0">
+                              <a:latin typeface="Cambria Math" panose="02040503050406030204" pitchFamily="18" charset="0"/>
+                            </a:rPr>
+                          </m:ctrlPr>
+                        </m:fPr>
+                        <m:num>
+                          <m:r>
+                            <a:rPr lang="en-US" altLang="zh-CN" b="0" i="1" smtClean="0">
+                              <a:latin typeface="Cambria Math" panose="02040503050406030204" pitchFamily="18" charset="0"/>
+                            </a:rPr>
+                            <m:t>1</m:t>
+                          </m:r>
+                        </m:num>
+                        <m:den>
+                          <m:r>
+                            <a:rPr lang="en-US" altLang="zh-CN" b="0" i="1" smtClean="0">
+                              <a:latin typeface="Cambria Math" panose="02040503050406030204" pitchFamily="18" charset="0"/>
+                            </a:rPr>
+                            <m:t>𝑇</m:t>
+                          </m:r>
+                        </m:den>
+                      </m:f>
+                    </m:oMath>
+                  </m:oMathPara>
+                </a14:m>
+                <a:endParaRPr lang="zh-CN" altLang="en-US" dirty="0"/>
+              </a:p>
+            </p:txBody>
+          </p:sp>
+        </mc:Choice>
+        <mc:Fallback>
+          <p:sp>
+            <p:nvSpPr>
+              <p:cNvPr id="31" name="文本框 30">
+                <a:extLst>
+                  <a:ext uri="{FF2B5EF4-FFF2-40B4-BE49-F238E27FC236}">
+                    <a16:creationId xmlns:a16="http://schemas.microsoft.com/office/drawing/2014/main" id="{A7AFA2D2-2502-CBD7-B930-B207A5063CE4}"/>
+                  </a:ext>
+                </a:extLst>
+              </p:cNvPr>
+              <p:cNvSpPr txBox="1">
+                <a:spLocks noRot="1" noChangeAspect="1" noMove="1" noResize="1" noEditPoints="1" noAdjustHandles="1" noChangeArrowheads="1" noChangeShapeType="1" noTextEdit="1"/>
+              </p:cNvSpPr>
+              <p:nvPr/>
+            </p:nvSpPr>
+            <p:spPr>
+              <a:xfrm>
+                <a:off x="3778690" y="4433166"/>
+                <a:ext cx="409023" cy="518604"/>
+              </a:xfrm>
+              <a:prstGeom prst="rect">
+                <a:avLst/>
+              </a:prstGeom>
+              <a:blipFill>
+                <a:blip r:embed="rId6"/>
+                <a:stretch>
+                  <a:fillRect/>
+                </a:stretch>
+              </a:blipFill>
+            </p:spPr>
+            <p:txBody>
+              <a:bodyPr/>
+              <a:lstStyle/>
+              <a:p>
+                <a:r>
+                  <a:rPr lang="zh-CN" altLang="en-US">
+                    <a:noFill/>
+                  </a:rPr>
+                  <a:t> </a:t>
+                </a:r>
+              </a:p>
+            </p:txBody>
+          </p:sp>
+        </mc:Fallback>
+      </mc:AlternateContent>
+      <mc:AlternateContent xmlns:mc="http://schemas.openxmlformats.org/markup-compatibility/2006">
+        <mc:Choice xmlns:a14="http://schemas.microsoft.com/office/drawing/2010/main" Requires="a14">
+          <p:sp>
+            <p:nvSpPr>
+              <p:cNvPr id="33" name="文本框 32">
+                <a:extLst>
+                  <a:ext uri="{FF2B5EF4-FFF2-40B4-BE49-F238E27FC236}">
+                    <a16:creationId xmlns:a16="http://schemas.microsoft.com/office/drawing/2014/main" id="{FC65D6C8-4A18-65AE-5DAA-675F7124D2B7}"/>
+                  </a:ext>
+                </a:extLst>
+              </p:cNvPr>
+              <p:cNvSpPr txBox="1"/>
+              <p:nvPr/>
+            </p:nvSpPr>
+            <p:spPr>
+              <a:xfrm>
+                <a:off x="3609043" y="3290501"/>
+                <a:ext cx="768608" cy="276999"/>
+              </a:xfrm>
+              <a:prstGeom prst="rect">
+                <a:avLst/>
+              </a:prstGeom>
+              <a:noFill/>
+            </p:spPr>
+            <p:txBody>
+              <a:bodyPr wrap="none" lIns="0" tIns="0" rIns="0" bIns="0" rtlCol="0">
+                <a:spAutoFit/>
+              </a:bodyPr>
+              <a:lstStyle/>
+              <a:p>
+                <a:pPr/>
+                <a14:m>
+                  <m:oMathPara xmlns:m="http://schemas.openxmlformats.org/officeDocument/2006/math">
+                    <m:oMath>
+                      <m:r>
+                        <a:rPr lang="en-US" altLang="zh-CN" b="0" i="1" smtClean="0">
+                          <a:latin typeface="Cambria Math" panose="02040503050406030204" pitchFamily="18" charset="0"/>
+                        </a:rPr>
+                        <m:t>~</m:t>
+                      </m:r>
+                      <m:r>
+                        <a:rPr lang="en-US" altLang="zh-CN" i="1" smtClean="0">
+                          <a:latin typeface="Cambria Math" panose="02040503050406030204" pitchFamily="18" charset="0"/>
+                        </a:rPr>
+                        <m:t>5</m:t>
+                      </m:r>
+                      <m:r>
+                        <a:rPr lang="en-US" altLang="zh-CN" b="0" i="1" smtClean="0">
+                          <a:latin typeface="Cambria Math" panose="02040503050406030204" pitchFamily="18" charset="0"/>
+                        </a:rPr>
+                        <m:t>0</m:t>
+                      </m:r>
+                      <m:r>
+                        <a:rPr lang="en-US" altLang="zh-CN" b="0" i="1" smtClean="0">
+                          <a:latin typeface="Cambria Math" panose="02040503050406030204" pitchFamily="18" charset="0"/>
+                        </a:rPr>
+                        <m:t>𝐻𝑧</m:t>
+                      </m:r>
+                    </m:oMath>
+                  </m:oMathPara>
+                </a14:m>
+                <a:endParaRPr lang="zh-CN" altLang="en-US" dirty="0"/>
+              </a:p>
+            </p:txBody>
+          </p:sp>
+        </mc:Choice>
+        <mc:Fallback>
+          <p:sp>
+            <p:nvSpPr>
+              <p:cNvPr id="33" name="文本框 32">
+                <a:extLst>
+                  <a:ext uri="{FF2B5EF4-FFF2-40B4-BE49-F238E27FC236}">
+                    <a16:creationId xmlns:a16="http://schemas.microsoft.com/office/drawing/2014/main" id="{FC65D6C8-4A18-65AE-5DAA-675F7124D2B7}"/>
+                  </a:ext>
+                </a:extLst>
+              </p:cNvPr>
+              <p:cNvSpPr txBox="1">
+                <a:spLocks noRot="1" noChangeAspect="1" noMove="1" noResize="1" noEditPoints="1" noAdjustHandles="1" noChangeArrowheads="1" noChangeShapeType="1" noTextEdit="1"/>
+              </p:cNvSpPr>
+              <p:nvPr/>
+            </p:nvSpPr>
+            <p:spPr>
+              <a:xfrm>
+                <a:off x="3609043" y="3290501"/>
+                <a:ext cx="768608" cy="276999"/>
+              </a:xfrm>
+              <a:prstGeom prst="rect">
+                <a:avLst/>
+              </a:prstGeom>
+              <a:blipFill>
+                <a:blip r:embed="rId7"/>
+                <a:stretch>
+                  <a:fillRect l="-794" r="-7143" b="-8889"/>
+                </a:stretch>
+              </a:blipFill>
+            </p:spPr>
+            <p:txBody>
+              <a:bodyPr/>
+              <a:lstStyle/>
+              <a:p>
+                <a:r>
+                  <a:rPr lang="zh-CN" altLang="en-US">
+                    <a:noFill/>
+                  </a:rPr>
+                  <a:t> </a:t>
+                </a:r>
+              </a:p>
+            </p:txBody>
+          </p:sp>
+        </mc:Fallback>
+      </mc:AlternateContent>
+      <mc:AlternateContent xmlns:mc="http://schemas.openxmlformats.org/markup-compatibility/2006">
+        <mc:Choice xmlns:a14="http://schemas.microsoft.com/office/drawing/2010/main" Requires="a14">
+          <p:sp>
+            <p:nvSpPr>
+              <p:cNvPr id="35" name="文本框 34">
+                <a:extLst>
+                  <a:ext uri="{FF2B5EF4-FFF2-40B4-BE49-F238E27FC236}">
+                    <a16:creationId xmlns:a16="http://schemas.microsoft.com/office/drawing/2014/main" id="{401C735D-79A0-878F-56D2-76D4EBE4E919}"/>
+                  </a:ext>
+                </a:extLst>
+              </p:cNvPr>
+              <p:cNvSpPr txBox="1"/>
+              <p:nvPr/>
+            </p:nvSpPr>
+            <p:spPr>
+              <a:xfrm>
+                <a:off x="3598897" y="5902586"/>
+                <a:ext cx="767005" cy="276999"/>
+              </a:xfrm>
+              <a:prstGeom prst="rect">
+                <a:avLst/>
+              </a:prstGeom>
+              <a:noFill/>
+            </p:spPr>
+            <p:txBody>
+              <a:bodyPr wrap="none" lIns="0" tIns="0" rIns="0" bIns="0" rtlCol="0">
+                <a:spAutoFit/>
+              </a:bodyPr>
+              <a:lstStyle/>
+              <a:p>
+                <a:pPr/>
+                <a14:m>
+                  <m:oMathPara xmlns:m="http://schemas.openxmlformats.org/officeDocument/2006/math">
+                    <m:oMath>
+                      <m:r>
+                        <a:rPr lang="en-US" altLang="zh-CN" b="0" i="1" smtClean="0">
+                          <a:latin typeface="Cambria Math" panose="02040503050406030204" pitchFamily="18" charset="0"/>
+                        </a:rPr>
+                        <m:t>~</m:t>
+                      </m:r>
+                      <m:r>
+                        <a:rPr lang="en-US" altLang="zh-CN" i="1" smtClean="0">
+                          <a:latin typeface="Cambria Math" panose="02040503050406030204" pitchFamily="18" charset="0"/>
+                        </a:rPr>
+                        <m:t>1</m:t>
+                      </m:r>
+                      <m:r>
+                        <a:rPr lang="en-US" altLang="zh-CN" b="0" i="1" smtClean="0">
+                          <a:latin typeface="Cambria Math" panose="02040503050406030204" pitchFamily="18" charset="0"/>
+                        </a:rPr>
+                        <m:t>𝑘</m:t>
+                      </m:r>
+                      <m:r>
+                        <a:rPr lang="en-US" altLang="zh-CN" b="0" i="1" smtClean="0">
+                          <a:latin typeface="Cambria Math" panose="02040503050406030204" pitchFamily="18" charset="0"/>
+                        </a:rPr>
+                        <m:t>𝐻𝑧</m:t>
+                      </m:r>
+                    </m:oMath>
+                  </m:oMathPara>
+                </a14:m>
+                <a:endParaRPr lang="zh-CN" altLang="en-US" dirty="0"/>
+              </a:p>
+            </p:txBody>
+          </p:sp>
+        </mc:Choice>
+        <mc:Fallback>
+          <p:sp>
+            <p:nvSpPr>
+              <p:cNvPr id="35" name="文本框 34">
+                <a:extLst>
+                  <a:ext uri="{FF2B5EF4-FFF2-40B4-BE49-F238E27FC236}">
+                    <a16:creationId xmlns:a16="http://schemas.microsoft.com/office/drawing/2014/main" id="{401C735D-79A0-878F-56D2-76D4EBE4E919}"/>
+                  </a:ext>
+                </a:extLst>
+              </p:cNvPr>
+              <p:cNvSpPr txBox="1">
+                <a:spLocks noRot="1" noChangeAspect="1" noMove="1" noResize="1" noEditPoints="1" noAdjustHandles="1" noChangeArrowheads="1" noChangeShapeType="1" noTextEdit="1"/>
+              </p:cNvSpPr>
+              <p:nvPr/>
+            </p:nvSpPr>
+            <p:spPr>
+              <a:xfrm>
+                <a:off x="3598897" y="5902586"/>
+                <a:ext cx="767005" cy="276999"/>
+              </a:xfrm>
+              <a:prstGeom prst="rect">
+                <a:avLst/>
+              </a:prstGeom>
+              <a:blipFill>
+                <a:blip r:embed="rId8"/>
+                <a:stretch>
+                  <a:fillRect l="-794" r="-6349" b="-6522"/>
+                </a:stretch>
+              </a:blipFill>
+            </p:spPr>
+            <p:txBody>
+              <a:bodyPr/>
+              <a:lstStyle/>
+              <a:p>
+                <a:r>
+                  <a:rPr lang="zh-CN" altLang="en-US">
+                    <a:noFill/>
+                  </a:rPr>
+                  <a:t> </a:t>
+                </a:r>
+              </a:p>
+            </p:txBody>
+          </p:sp>
+        </mc:Fallback>
+      </mc:AlternateContent>
     </p:spTree>
     <p:extLst>
       <p:ext uri="{BB962C8B-B14F-4D97-AF65-F5344CB8AC3E}">
         <p14:creationId xmlns:p14="http://schemas.microsoft.com/office/powerpoint/2010/main" val="1377766313"/>
+      </p:ext>
+    </p:extLst>
+  </p:cSld>
+  <p:clrMapOvr>
+    <a:masterClrMapping/>
+  </p:clrMapOvr>
+</p:sld>
+</file>
+
+<file path=ppt/slides/slide3.xml><?xml version="1.0" encoding="utf-8"?>
+<p:sld xmlns:a="http://schemas.openxmlformats.org/drawingml/2006/main" xmlns:r="http://schemas.openxmlformats.org/officeDocument/2006/relationships" xmlns:p="http://schemas.openxmlformats.org/presentationml/2006/main">
+  <p:cSld>
+    <p:spTree>
+      <p:nvGrpSpPr>
+        <p:cNvPr id="1" name="">
+          <a:extLst>
+            <a:ext uri="{FF2B5EF4-FFF2-40B4-BE49-F238E27FC236}">
+              <a16:creationId xmlns:a16="http://schemas.microsoft.com/office/drawing/2014/main" id="{C3B1FAB6-CAAE-38E7-1535-4637C824963E}"/>
+            </a:ext>
+          </a:extLst>
+        </p:cNvPr>
+        <p:cNvGrpSpPr/>
+        <p:nvPr/>
+      </p:nvGrpSpPr>
+      <p:grpSpPr>
+        <a:xfrm>
+          <a:off x="0" y="0"/>
+          <a:ext cx="0" cy="0"/>
+          <a:chOff x="0" y="0"/>
+          <a:chExt cx="0" cy="0"/>
+        </a:xfrm>
+      </p:grpSpPr>
+      <p:sp>
+        <p:nvSpPr>
+          <p:cNvPr id="9" name="文本框 8">
+            <a:extLst>
+              <a:ext uri="{FF2B5EF4-FFF2-40B4-BE49-F238E27FC236}">
+                <a16:creationId xmlns:a16="http://schemas.microsoft.com/office/drawing/2014/main" id="{60F819B1-FF07-1AE9-B113-9C23028DB5F8}"/>
+              </a:ext>
+            </a:extLst>
+          </p:cNvPr>
+          <p:cNvSpPr txBox="1"/>
+          <p:nvPr/>
+        </p:nvSpPr>
+        <p:spPr>
+          <a:xfrm>
+            <a:off x="185420" y="242570"/>
+            <a:ext cx="1334020" cy="369332"/>
+          </a:xfrm>
+          <a:prstGeom prst="rect">
+            <a:avLst/>
+          </a:prstGeom>
+          <a:noFill/>
+        </p:spPr>
+        <p:txBody>
+          <a:bodyPr wrap="none" rtlCol="0">
+            <a:spAutoFit/>
+          </a:bodyPr>
+          <a:lstStyle/>
+          <a:p>
+            <a:r>
+              <a:rPr lang="en-US" altLang="zh-CN" b="1" dirty="0"/>
+              <a:t>Motivation</a:t>
+            </a:r>
+            <a:endParaRPr lang="zh-CN" altLang="en-US" b="1" dirty="0"/>
+          </a:p>
+        </p:txBody>
+      </p:sp>
+      <p:sp>
+        <p:nvSpPr>
+          <p:cNvPr id="10" name="文本框 9">
+            <a:extLst>
+              <a:ext uri="{FF2B5EF4-FFF2-40B4-BE49-F238E27FC236}">
+                <a16:creationId xmlns:a16="http://schemas.microsoft.com/office/drawing/2014/main" id="{F1AFA4A2-BD2A-2577-930C-417A5EBA9671}"/>
+              </a:ext>
+            </a:extLst>
+          </p:cNvPr>
+          <p:cNvSpPr txBox="1"/>
+          <p:nvPr/>
+        </p:nvSpPr>
+        <p:spPr>
+          <a:xfrm>
+            <a:off x="185420" y="790853"/>
+            <a:ext cx="2848857" cy="923330"/>
+          </a:xfrm>
+          <a:prstGeom prst="rect">
+            <a:avLst/>
+          </a:prstGeom>
+          <a:noFill/>
+        </p:spPr>
+        <p:txBody>
+          <a:bodyPr wrap="none" rtlCol="0">
+            <a:spAutoFit/>
+          </a:bodyPr>
+          <a:lstStyle/>
+          <a:p>
+            <a:pPr marL="342900" indent="-342900">
+              <a:buAutoNum type="arabicPeriod"/>
+            </a:pPr>
+            <a:r>
+              <a:rPr lang="en-US" altLang="zh-CN" dirty="0"/>
+              <a:t>Foot placement</a:t>
+            </a:r>
+          </a:p>
+          <a:p>
+            <a:pPr marL="342900" indent="-342900">
+              <a:buAutoNum type="arabicPeriod"/>
+            </a:pPr>
+            <a:r>
+              <a:rPr lang="en-US" altLang="zh-CN" dirty="0"/>
+              <a:t>Phase ?</a:t>
+            </a:r>
+          </a:p>
+          <a:p>
+            <a:pPr marL="342900" indent="-342900">
+              <a:buAutoNum type="arabicPeriod"/>
+            </a:pPr>
+            <a:r>
+              <a:rPr lang="en-US" altLang="zh-CN" dirty="0"/>
+              <a:t>Compatible with MPC ?</a:t>
+            </a:r>
+            <a:endParaRPr lang="zh-CN" altLang="en-US" dirty="0"/>
+          </a:p>
+        </p:txBody>
+      </p:sp>
+      <p:sp>
+        <p:nvSpPr>
+          <p:cNvPr id="5" name="文本框 4">
+            <a:extLst>
+              <a:ext uri="{FF2B5EF4-FFF2-40B4-BE49-F238E27FC236}">
+                <a16:creationId xmlns:a16="http://schemas.microsoft.com/office/drawing/2014/main" id="{83CF1CC3-39AF-17B0-C8F7-4AE33316CF0E}"/>
+              </a:ext>
+            </a:extLst>
+          </p:cNvPr>
+          <p:cNvSpPr txBox="1"/>
+          <p:nvPr/>
+        </p:nvSpPr>
+        <p:spPr>
+          <a:xfrm>
+            <a:off x="2256904" y="6272879"/>
+            <a:ext cx="4725672" cy="261610"/>
+          </a:xfrm>
+          <a:prstGeom prst="rect">
+            <a:avLst/>
+          </a:prstGeom>
+          <a:noFill/>
+        </p:spPr>
+        <p:txBody>
+          <a:bodyPr wrap="square">
+            <a:spAutoFit/>
+          </a:bodyPr>
+          <a:lstStyle/>
+          <a:p>
+            <a:r>
+              <a:rPr lang="zh-CN" altLang="zh-CN" sz="1100" b="0" i="0" spc="29" dirty="0">
+                <a:solidFill>
+                  <a:schemeClr val="tx1"/>
+                </a:solidFill>
+                <a:effectLst/>
+                <a:latin typeface="+mn-lt"/>
+              </a:rPr>
+              <a:t>Source: </a:t>
+            </a:r>
+            <a:r>
+              <a:rPr lang="en-US" altLang="zh-CN" sz="1100" spc="29" dirty="0"/>
+              <a:t>https://www.animatornotebook.com/learn/quadrupeds-gaits</a:t>
+            </a:r>
+            <a:endParaRPr lang="zh-CN" altLang="en-US" sz="1100" dirty="0"/>
+          </a:p>
+        </p:txBody>
+      </p:sp>
+      <p:pic>
+        <p:nvPicPr>
+          <p:cNvPr id="6" name="图片 5" descr="Footfall_trot.png">
+            <a:extLst>
+              <a:ext uri="{FF2B5EF4-FFF2-40B4-BE49-F238E27FC236}">
+                <a16:creationId xmlns:a16="http://schemas.microsoft.com/office/drawing/2014/main" id="{F8FDEAC9-88F4-1798-1E46-573E5C5DA6EB}"/>
+              </a:ext>
+            </a:extLst>
+          </p:cNvPr>
+          <p:cNvPicPr>
+            <a:picLocks noChangeAspect="1"/>
+          </p:cNvPicPr>
+          <p:nvPr/>
+        </p:nvPicPr>
+        <p:blipFill>
+          <a:blip r:embed="rId2"/>
+          <a:stretch>
+            <a:fillRect/>
+          </a:stretch>
+        </p:blipFill>
+        <p:spPr>
+          <a:xfrm>
+            <a:off x="2106139" y="4254274"/>
+            <a:ext cx="7116339" cy="1779085"/>
+          </a:xfrm>
+          <a:prstGeom prst="rect">
+            <a:avLst/>
+          </a:prstGeom>
+        </p:spPr>
+      </p:pic>
+      <p:sp>
+        <p:nvSpPr>
+          <p:cNvPr id="8" name="文本框 7">
+            <a:extLst>
+              <a:ext uri="{FF2B5EF4-FFF2-40B4-BE49-F238E27FC236}">
+                <a16:creationId xmlns:a16="http://schemas.microsoft.com/office/drawing/2014/main" id="{ABE01369-B902-EF4D-B180-D55C3863A337}"/>
+              </a:ext>
+            </a:extLst>
+          </p:cNvPr>
+          <p:cNvSpPr txBox="1"/>
+          <p:nvPr/>
+        </p:nvSpPr>
+        <p:spPr>
+          <a:xfrm>
+            <a:off x="185420" y="2103120"/>
+            <a:ext cx="1920719" cy="369332"/>
+          </a:xfrm>
+          <a:prstGeom prst="rect">
+            <a:avLst/>
+          </a:prstGeom>
+          <a:noFill/>
+        </p:spPr>
+        <p:txBody>
+          <a:bodyPr wrap="none" rtlCol="0">
+            <a:spAutoFit/>
+          </a:bodyPr>
+          <a:lstStyle/>
+          <a:p>
+            <a:r>
+              <a:rPr lang="en-US" altLang="zh-CN" b="1" dirty="0"/>
+              <a:t>Objects of Study</a:t>
+            </a:r>
+            <a:endParaRPr lang="zh-CN" altLang="en-US" b="1" dirty="0"/>
+          </a:p>
+        </p:txBody>
+      </p:sp>
+      <p:sp>
+        <p:nvSpPr>
+          <p:cNvPr id="11" name="文本框 10">
+            <a:extLst>
+              <a:ext uri="{FF2B5EF4-FFF2-40B4-BE49-F238E27FC236}">
+                <a16:creationId xmlns:a16="http://schemas.microsoft.com/office/drawing/2014/main" id="{C9AF6D05-D90D-82A4-3237-BCE0B4496297}"/>
+              </a:ext>
+            </a:extLst>
+          </p:cNvPr>
+          <p:cNvSpPr txBox="1"/>
+          <p:nvPr/>
+        </p:nvSpPr>
+        <p:spPr>
+          <a:xfrm>
+            <a:off x="185420" y="2676723"/>
+            <a:ext cx="2202847" cy="369332"/>
+          </a:xfrm>
+          <a:prstGeom prst="rect">
+            <a:avLst/>
+          </a:prstGeom>
+          <a:noFill/>
+        </p:spPr>
+        <p:txBody>
+          <a:bodyPr wrap="none" rtlCol="0">
+            <a:spAutoFit/>
+          </a:bodyPr>
+          <a:lstStyle/>
+          <a:p>
+            <a:r>
+              <a:rPr lang="en-US" altLang="zh-CN" dirty="0"/>
+              <a:t>Unitree Quadrupeds</a:t>
+            </a:r>
+            <a:endParaRPr lang="zh-CN" altLang="en-US" dirty="0"/>
+          </a:p>
+        </p:txBody>
+      </p:sp>
+      <p:sp>
+        <p:nvSpPr>
+          <p:cNvPr id="18" name="文本框 17">
+            <a:extLst>
+              <a:ext uri="{FF2B5EF4-FFF2-40B4-BE49-F238E27FC236}">
+                <a16:creationId xmlns:a16="http://schemas.microsoft.com/office/drawing/2014/main" id="{E4EEBBD8-1E6B-363F-87BD-2A89DFC30FF9}"/>
+              </a:ext>
+            </a:extLst>
+          </p:cNvPr>
+          <p:cNvSpPr txBox="1"/>
+          <p:nvPr/>
+        </p:nvSpPr>
+        <p:spPr>
+          <a:xfrm>
+            <a:off x="185419" y="4057746"/>
+            <a:ext cx="974947" cy="369332"/>
+          </a:xfrm>
+          <a:prstGeom prst="rect">
+            <a:avLst/>
+          </a:prstGeom>
+          <a:noFill/>
+        </p:spPr>
+        <p:txBody>
+          <a:bodyPr wrap="none" rtlCol="0">
+            <a:spAutoFit/>
+          </a:bodyPr>
+          <a:lstStyle/>
+          <a:p>
+            <a:r>
+              <a:rPr lang="en-US" altLang="zh-CN" dirty="0"/>
+              <a:t>Trotting</a:t>
+            </a:r>
+            <a:endParaRPr lang="zh-CN" altLang="en-US" dirty="0"/>
+          </a:p>
+        </p:txBody>
+      </p:sp>
+      <p:pic>
+        <p:nvPicPr>
+          <p:cNvPr id="22" name="图片 21" descr="Robot Dog Go2_Quadruped_Robot Dog Company | Unitree Robotics">
+            <a:extLst>
+              <a:ext uri="{FF2B5EF4-FFF2-40B4-BE49-F238E27FC236}">
+                <a16:creationId xmlns:a16="http://schemas.microsoft.com/office/drawing/2014/main" id="{ACEC7929-A828-3948-84F5-B13C01713AAF}"/>
+              </a:ext>
+            </a:extLst>
+          </p:cNvPr>
+          <p:cNvPicPr>
+            <a:picLocks noChangeAspect="1"/>
+          </p:cNvPicPr>
+          <p:nvPr/>
+        </p:nvPicPr>
+        <p:blipFill>
+          <a:blip r:embed="rId3"/>
+          <a:stretch>
+            <a:fillRect/>
+          </a:stretch>
+        </p:blipFill>
+        <p:spPr>
+          <a:xfrm>
+            <a:off x="3034277" y="1893134"/>
+            <a:ext cx="2774722" cy="2292999"/>
+          </a:xfrm>
+          <a:prstGeom prst="rect">
+            <a:avLst/>
+          </a:prstGeom>
+        </p:spPr>
+      </p:pic>
+      <p:sp>
+        <p:nvSpPr>
+          <p:cNvPr id="26" name="文本框 25">
+            <a:extLst>
+              <a:ext uri="{FF2B5EF4-FFF2-40B4-BE49-F238E27FC236}">
+                <a16:creationId xmlns:a16="http://schemas.microsoft.com/office/drawing/2014/main" id="{F68E0426-E61A-1B08-A895-365C1785C822}"/>
+              </a:ext>
+            </a:extLst>
+          </p:cNvPr>
+          <p:cNvSpPr txBox="1"/>
+          <p:nvPr/>
+        </p:nvSpPr>
+        <p:spPr>
+          <a:xfrm>
+            <a:off x="2256904" y="6464614"/>
+            <a:ext cx="2665730" cy="261610"/>
+          </a:xfrm>
+          <a:prstGeom prst="rect">
+            <a:avLst/>
+          </a:prstGeom>
+          <a:noFill/>
+        </p:spPr>
+        <p:txBody>
+          <a:bodyPr wrap="square">
+            <a:spAutoFit/>
+          </a:bodyPr>
+          <a:lstStyle/>
+          <a:p>
+            <a:r>
+              <a:rPr lang="zh-CN" altLang="zh-CN" sz="1100" b="0" i="0" spc="29" dirty="0">
+                <a:solidFill>
+                  <a:schemeClr val="tx1"/>
+                </a:solidFill>
+                <a:effectLst/>
+                <a:latin typeface="+mn-lt"/>
+              </a:rPr>
+              <a:t>Source: https://youtu.be/oyTKvsnbCcE</a:t>
+            </a:r>
+            <a:endParaRPr lang="zh-CN" altLang="en-US" sz="1100" dirty="0"/>
+          </a:p>
+        </p:txBody>
+      </p:sp>
+    </p:spTree>
+    <p:extLst>
+      <p:ext uri="{BB962C8B-B14F-4D97-AF65-F5344CB8AC3E}">
+        <p14:creationId xmlns:p14="http://schemas.microsoft.com/office/powerpoint/2010/main" val="3431035551"/>
+      </p:ext>
+    </p:extLst>
+  </p:cSld>
+  <p:clrMapOvr>
+    <a:masterClrMapping/>
+  </p:clrMapOvr>
+</p:sld>
+</file>
+
+<file path=ppt/slides/slide4.xml><?xml version="1.0" encoding="utf-8"?>
+<p:sld xmlns:a="http://schemas.openxmlformats.org/drawingml/2006/main" xmlns:r="http://schemas.openxmlformats.org/officeDocument/2006/relationships" xmlns:p="http://schemas.openxmlformats.org/presentationml/2006/main">
+  <p:cSld>
+    <p:spTree>
+      <p:nvGrpSpPr>
+        <p:cNvPr id="1" name="">
+          <a:extLst>
+            <a:ext uri="{FF2B5EF4-FFF2-40B4-BE49-F238E27FC236}">
+              <a16:creationId xmlns:a16="http://schemas.microsoft.com/office/drawing/2014/main" id="{80D946AE-EF9C-22A0-1EE7-C06028DC68D3}"/>
+            </a:ext>
+          </a:extLst>
+        </p:cNvPr>
+        <p:cNvGrpSpPr/>
+        <p:nvPr/>
+      </p:nvGrpSpPr>
+      <p:grpSpPr>
+        <a:xfrm>
+          <a:off x="0" y="0"/>
+          <a:ext cx="0" cy="0"/>
+          <a:chOff x="0" y="0"/>
+          <a:chExt cx="0" cy="0"/>
+        </a:xfrm>
+      </p:grpSpPr>
+      <p:sp>
+        <p:nvSpPr>
+          <p:cNvPr id="9" name="文本框 8">
+            <a:extLst>
+              <a:ext uri="{FF2B5EF4-FFF2-40B4-BE49-F238E27FC236}">
+                <a16:creationId xmlns:a16="http://schemas.microsoft.com/office/drawing/2014/main" id="{ED674482-EA25-DA50-9857-CD6D21A83E4E}"/>
+              </a:ext>
+            </a:extLst>
+          </p:cNvPr>
+          <p:cNvSpPr txBox="1"/>
+          <p:nvPr/>
+        </p:nvSpPr>
+        <p:spPr>
+          <a:xfrm>
+            <a:off x="185420" y="242570"/>
+            <a:ext cx="2805576" cy="369332"/>
+          </a:xfrm>
+          <a:prstGeom prst="rect">
+            <a:avLst/>
+          </a:prstGeom>
+          <a:noFill/>
+        </p:spPr>
+        <p:txBody>
+          <a:bodyPr wrap="none" rtlCol="0">
+            <a:spAutoFit/>
+          </a:bodyPr>
+          <a:lstStyle/>
+          <a:p>
+            <a:r>
+              <a:rPr lang="en-US" altLang="zh-CN" b="1" dirty="0"/>
+              <a:t>Foot Placement methods</a:t>
+            </a:r>
+            <a:endParaRPr lang="zh-CN" altLang="en-US" b="1" dirty="0"/>
+          </a:p>
+        </p:txBody>
+      </p:sp>
+      <p:sp>
+        <p:nvSpPr>
+          <p:cNvPr id="3" name="文本框 2">
+            <a:extLst>
+              <a:ext uri="{FF2B5EF4-FFF2-40B4-BE49-F238E27FC236}">
+                <a16:creationId xmlns:a16="http://schemas.microsoft.com/office/drawing/2014/main" id="{E1E67BCE-22EB-7376-6EC3-8E3878B75EB0}"/>
+              </a:ext>
+            </a:extLst>
+          </p:cNvPr>
+          <p:cNvSpPr txBox="1"/>
+          <p:nvPr/>
+        </p:nvSpPr>
+        <p:spPr>
+          <a:xfrm>
+            <a:off x="185420" y="898162"/>
+            <a:ext cx="1486304" cy="369332"/>
+          </a:xfrm>
+          <a:prstGeom prst="rect">
+            <a:avLst/>
+          </a:prstGeom>
+          <a:noFill/>
+        </p:spPr>
+        <p:txBody>
+          <a:bodyPr wrap="none" rtlCol="0">
+            <a:spAutoFit/>
+          </a:bodyPr>
+          <a:lstStyle/>
+          <a:p>
+            <a:r>
+              <a:rPr lang="en-US" altLang="zh-CN" dirty="0"/>
+              <a:t>1. Open loop</a:t>
+            </a:r>
+            <a:endParaRPr lang="zh-CN" altLang="en-US" dirty="0"/>
+          </a:p>
+        </p:txBody>
+      </p:sp>
+      <mc:AlternateContent xmlns:mc="http://schemas.openxmlformats.org/markup-compatibility/2006">
+        <mc:Choice xmlns:a14="http://schemas.microsoft.com/office/drawing/2010/main" Requires="a14">
+          <p:sp>
+            <p:nvSpPr>
+              <p:cNvPr id="7" name="文本框 6">
+                <a:extLst>
+                  <a:ext uri="{FF2B5EF4-FFF2-40B4-BE49-F238E27FC236}">
+                    <a16:creationId xmlns:a16="http://schemas.microsoft.com/office/drawing/2014/main" id="{C04776EA-4E42-1208-3110-B0918724EC83}"/>
+                  </a:ext>
+                </a:extLst>
+              </p:cNvPr>
+              <p:cNvSpPr txBox="1"/>
+              <p:nvPr/>
+            </p:nvSpPr>
+            <p:spPr>
+              <a:xfrm>
+                <a:off x="4134925" y="898162"/>
+                <a:ext cx="750526" cy="281937"/>
+              </a:xfrm>
+              <a:prstGeom prst="rect">
+                <a:avLst/>
+              </a:prstGeom>
+              <a:noFill/>
+            </p:spPr>
+            <p:txBody>
+              <a:bodyPr wrap="none" lIns="0" tIns="0" rIns="0" bIns="0" rtlCol="0">
+                <a:spAutoFit/>
+              </a:bodyPr>
+              <a:lstStyle/>
+              <a:p>
+                <a:pPr/>
+                <a14:m>
+                  <m:oMathPara xmlns:m="http://schemas.openxmlformats.org/officeDocument/2006/math">
+                    <m:oMath>
+                      <m:r>
+                        <a:rPr lang="en-US" altLang="zh-CN" b="0" i="1" smtClean="0">
+                          <a:latin typeface="Cambria Math" panose="02040503050406030204" pitchFamily="18" charset="0"/>
+                        </a:rPr>
+                        <m:t>𝑝</m:t>
+                      </m:r>
+                      <m:r>
+                        <a:rPr lang="en-US" altLang="zh-CN" b="0" i="1" smtClean="0">
+                          <a:latin typeface="Cambria Math" panose="02040503050406030204" pitchFamily="18" charset="0"/>
+                        </a:rPr>
+                        <m:t>=</m:t>
+                      </m:r>
+                      <m:sSup>
+                        <m:sSupPr>
+                          <m:ctrlPr>
+                            <a:rPr lang="en-US" altLang="zh-CN" b="0" i="1" smtClean="0">
+                              <a:latin typeface="Cambria Math" panose="02040503050406030204" pitchFamily="18" charset="0"/>
+                            </a:rPr>
+                          </m:ctrlPr>
+                        </m:sSupPr>
+                        <m:e>
+                          <m:r>
+                            <a:rPr lang="en-US" altLang="zh-CN" b="0" i="1" smtClean="0">
+                              <a:latin typeface="Cambria Math" panose="02040503050406030204" pitchFamily="18" charset="0"/>
+                            </a:rPr>
+                            <m:t>𝑝</m:t>
+                          </m:r>
+                        </m:e>
+                        <m:sup>
+                          <m:r>
+                            <a:rPr lang="en-US" altLang="zh-CN" b="0" i="1" smtClean="0">
+                              <a:latin typeface="Cambria Math" panose="02040503050406030204" pitchFamily="18" charset="0"/>
+                            </a:rPr>
+                            <m:t>𝑑</m:t>
+                          </m:r>
+                        </m:sup>
+                      </m:sSup>
+                    </m:oMath>
+                  </m:oMathPara>
+                </a14:m>
+                <a:endParaRPr lang="zh-CN" altLang="en-US" dirty="0"/>
+              </a:p>
+            </p:txBody>
+          </p:sp>
+        </mc:Choice>
+        <mc:Fallback>
+          <p:sp>
+            <p:nvSpPr>
+              <p:cNvPr id="7" name="文本框 6">
+                <a:extLst>
+                  <a:ext uri="{FF2B5EF4-FFF2-40B4-BE49-F238E27FC236}">
+                    <a16:creationId xmlns:a16="http://schemas.microsoft.com/office/drawing/2014/main" id="{C04776EA-4E42-1208-3110-B0918724EC83}"/>
+                  </a:ext>
+                </a:extLst>
+              </p:cNvPr>
+              <p:cNvSpPr txBox="1">
+                <a:spLocks noRot="1" noChangeAspect="1" noMove="1" noResize="1" noEditPoints="1" noAdjustHandles="1" noChangeArrowheads="1" noChangeShapeType="1" noTextEdit="1"/>
+              </p:cNvSpPr>
+              <p:nvPr/>
+            </p:nvSpPr>
+            <p:spPr>
+              <a:xfrm>
+                <a:off x="4134925" y="898162"/>
+                <a:ext cx="750526" cy="281937"/>
+              </a:xfrm>
+              <a:prstGeom prst="rect">
+                <a:avLst/>
+              </a:prstGeom>
+              <a:blipFill>
+                <a:blip r:embed="rId2"/>
+                <a:stretch>
+                  <a:fillRect l="-6504" t="-2128" r="-813" b="-23404"/>
+                </a:stretch>
+              </a:blipFill>
+            </p:spPr>
+            <p:txBody>
+              <a:bodyPr/>
+              <a:lstStyle/>
+              <a:p>
+                <a:r>
+                  <a:rPr lang="zh-CN" altLang="en-US">
+                    <a:noFill/>
+                  </a:rPr>
+                  <a:t> </a:t>
+                </a:r>
+              </a:p>
+            </p:txBody>
+          </p:sp>
+        </mc:Fallback>
+      </mc:AlternateContent>
+      <p:sp>
+        <p:nvSpPr>
+          <p:cNvPr id="13" name="文本框 12">
+            <a:extLst>
+              <a:ext uri="{FF2B5EF4-FFF2-40B4-BE49-F238E27FC236}">
+                <a16:creationId xmlns:a16="http://schemas.microsoft.com/office/drawing/2014/main" id="{E98CAE0B-7DF3-055E-D920-1040B2578032}"/>
+              </a:ext>
+            </a:extLst>
+          </p:cNvPr>
+          <p:cNvSpPr txBox="1"/>
+          <p:nvPr/>
+        </p:nvSpPr>
+        <p:spPr>
+          <a:xfrm>
+            <a:off x="185420" y="1717312"/>
+            <a:ext cx="2893741" cy="369332"/>
+          </a:xfrm>
+          <a:prstGeom prst="rect">
+            <a:avLst/>
+          </a:prstGeom>
+          <a:noFill/>
+        </p:spPr>
+        <p:txBody>
+          <a:bodyPr wrap="none" rtlCol="0">
+            <a:spAutoFit/>
+          </a:bodyPr>
+          <a:lstStyle/>
+          <a:p>
+            <a:r>
+              <a:rPr lang="en-US" altLang="zh-CN" dirty="0"/>
+              <a:t>2. Raibert Heuristic Method</a:t>
+            </a:r>
+            <a:endParaRPr lang="zh-CN" altLang="en-US" dirty="0"/>
+          </a:p>
+        </p:txBody>
+      </p:sp>
+      <p:sp>
+        <p:nvSpPr>
+          <p:cNvPr id="15" name="文本框 14">
+            <a:extLst>
+              <a:ext uri="{FF2B5EF4-FFF2-40B4-BE49-F238E27FC236}">
+                <a16:creationId xmlns:a16="http://schemas.microsoft.com/office/drawing/2014/main" id="{603CA60D-AB84-FBC5-4EB5-656BE5ED8354}"/>
+              </a:ext>
+            </a:extLst>
+          </p:cNvPr>
+          <p:cNvSpPr txBox="1"/>
+          <p:nvPr/>
+        </p:nvSpPr>
+        <p:spPr>
+          <a:xfrm>
+            <a:off x="185420" y="2582629"/>
+            <a:ext cx="3704860" cy="369332"/>
+          </a:xfrm>
+          <a:prstGeom prst="rect">
+            <a:avLst/>
+          </a:prstGeom>
+          <a:noFill/>
+        </p:spPr>
+        <p:txBody>
+          <a:bodyPr wrap="none" rtlCol="0">
+            <a:spAutoFit/>
+          </a:bodyPr>
+          <a:lstStyle/>
+          <a:p>
+            <a:r>
+              <a:rPr lang="en-US" altLang="zh-CN" dirty="0"/>
+              <a:t>3. Linear inverted pendulum mode</a:t>
+            </a:r>
+            <a:endParaRPr lang="zh-CN" altLang="en-US" dirty="0"/>
+          </a:p>
+        </p:txBody>
+      </p:sp>
+      <mc:AlternateContent xmlns:mc="http://schemas.openxmlformats.org/markup-compatibility/2006">
+        <mc:Choice xmlns:a14="http://schemas.microsoft.com/office/drawing/2010/main" Requires="a14">
+          <p:sp>
+            <p:nvSpPr>
+              <p:cNvPr id="17" name="文本框 16">
+                <a:extLst>
+                  <a:ext uri="{FF2B5EF4-FFF2-40B4-BE49-F238E27FC236}">
+                    <a16:creationId xmlns:a16="http://schemas.microsoft.com/office/drawing/2014/main" id="{28467A15-EBD8-01B1-0E79-A3E89B1CD85A}"/>
+                  </a:ext>
+                </a:extLst>
+              </p:cNvPr>
+              <p:cNvSpPr txBox="1"/>
+              <p:nvPr/>
+            </p:nvSpPr>
+            <p:spPr>
+              <a:xfrm>
+                <a:off x="4134925" y="1592118"/>
+                <a:ext cx="2186688" cy="578492"/>
+              </a:xfrm>
+              <a:prstGeom prst="rect">
+                <a:avLst/>
+              </a:prstGeom>
+              <a:noFill/>
+            </p:spPr>
+            <p:txBody>
+              <a:bodyPr wrap="none" lIns="0" tIns="0" rIns="0" bIns="0" rtlCol="0">
+                <a:spAutoFit/>
+              </a:bodyPr>
+              <a:lstStyle/>
+              <a:p>
+                <a:pPr/>
+                <a14:m>
+                  <m:oMathPara xmlns:m="http://schemas.openxmlformats.org/officeDocument/2006/math">
+                    <m:oMath>
+                      <m:r>
+                        <a:rPr lang="en-US" altLang="zh-CN" b="0" i="1" smtClean="0">
+                          <a:latin typeface="Cambria Math" panose="02040503050406030204" pitchFamily="18" charset="0"/>
+                        </a:rPr>
+                        <m:t>𝑝</m:t>
+                      </m:r>
+                      <m:r>
+                        <a:rPr lang="en-US" altLang="zh-CN" b="0" i="1" smtClean="0">
+                          <a:latin typeface="Cambria Math" panose="02040503050406030204" pitchFamily="18" charset="0"/>
+                        </a:rPr>
+                        <m:t>=</m:t>
+                      </m:r>
+                      <m:f>
+                        <m:fPr>
+                          <m:ctrlPr>
+                            <a:rPr lang="en-US" altLang="zh-CN" b="0" i="1" smtClean="0">
+                              <a:latin typeface="Cambria Math" panose="02040503050406030204" pitchFamily="18" charset="0"/>
+                            </a:rPr>
+                          </m:ctrlPr>
+                        </m:fPr>
+                        <m:num>
+                          <m:sSup>
+                            <m:sSupPr>
+                              <m:ctrlPr>
+                                <a:rPr lang="en-US" altLang="zh-CN" b="0" i="1" smtClean="0">
+                                  <a:latin typeface="Cambria Math" panose="02040503050406030204" pitchFamily="18" charset="0"/>
+                                </a:rPr>
+                              </m:ctrlPr>
+                            </m:sSupPr>
+                            <m:e>
+                              <m:r>
+                                <a:rPr lang="en-US" altLang="zh-CN" b="0" i="1" smtClean="0">
+                                  <a:latin typeface="Cambria Math" panose="02040503050406030204" pitchFamily="18" charset="0"/>
+                                </a:rPr>
+                                <m:t>𝑣</m:t>
+                              </m:r>
+                            </m:e>
+                            <m:sup>
+                              <m:r>
+                                <a:rPr lang="en-US" altLang="zh-CN" b="0" i="1" smtClean="0">
+                                  <a:latin typeface="Cambria Math" panose="02040503050406030204" pitchFamily="18" charset="0"/>
+                                </a:rPr>
+                                <m:t>𝑑</m:t>
+                              </m:r>
+                            </m:sup>
+                          </m:sSup>
+                        </m:num>
+                        <m:den>
+                          <m:r>
+                            <a:rPr lang="en-US" altLang="zh-CN" b="0" i="1" smtClean="0">
+                              <a:latin typeface="Cambria Math" panose="02040503050406030204" pitchFamily="18" charset="0"/>
+                            </a:rPr>
+                            <m:t>2</m:t>
+                          </m:r>
+                        </m:den>
+                      </m:f>
+                      <m:r>
+                        <a:rPr lang="en-US" altLang="zh-CN" b="0" i="1" smtClean="0">
+                          <a:latin typeface="Cambria Math" panose="02040503050406030204" pitchFamily="18" charset="0"/>
+                        </a:rPr>
+                        <m:t>+</m:t>
+                      </m:r>
+                      <m:sSub>
+                        <m:sSubPr>
+                          <m:ctrlPr>
+                            <a:rPr lang="en-US" altLang="zh-CN" b="0" i="1" smtClean="0">
+                              <a:latin typeface="Cambria Math" panose="02040503050406030204" pitchFamily="18" charset="0"/>
+                            </a:rPr>
+                          </m:ctrlPr>
+                        </m:sSubPr>
+                        <m:e>
+                          <m:r>
+                            <a:rPr lang="en-US" altLang="zh-CN" b="0" i="1" smtClean="0">
+                              <a:latin typeface="Cambria Math" panose="02040503050406030204" pitchFamily="18" charset="0"/>
+                            </a:rPr>
+                            <m:t>𝐾</m:t>
+                          </m:r>
+                        </m:e>
+                        <m:sub>
+                          <m:r>
+                            <a:rPr lang="en-US" altLang="zh-CN" b="0" i="1" smtClean="0">
+                              <a:latin typeface="Cambria Math" panose="02040503050406030204" pitchFamily="18" charset="0"/>
+                            </a:rPr>
+                            <m:t>𝑣</m:t>
+                          </m:r>
+                        </m:sub>
+                      </m:sSub>
+                      <m:r>
+                        <a:rPr lang="en-US" altLang="zh-CN" b="0" i="1" smtClean="0">
+                          <a:latin typeface="Cambria Math" panose="02040503050406030204" pitchFamily="18" charset="0"/>
+                        </a:rPr>
+                        <m:t>(</m:t>
+                      </m:r>
+                      <m:r>
+                        <a:rPr lang="en-US" altLang="zh-CN" b="0" i="1" smtClean="0">
+                          <a:latin typeface="Cambria Math" panose="02040503050406030204" pitchFamily="18" charset="0"/>
+                        </a:rPr>
+                        <m:t>𝑣</m:t>
+                      </m:r>
+                      <m:r>
+                        <a:rPr lang="en-US" altLang="zh-CN" b="0" i="1" smtClean="0">
+                          <a:latin typeface="Cambria Math" panose="02040503050406030204" pitchFamily="18" charset="0"/>
+                        </a:rPr>
+                        <m:t>−</m:t>
+                      </m:r>
+                      <m:sSup>
+                        <m:sSupPr>
+                          <m:ctrlPr>
+                            <a:rPr lang="en-US" altLang="zh-CN" b="0" i="1" smtClean="0">
+                              <a:latin typeface="Cambria Math" panose="02040503050406030204" pitchFamily="18" charset="0"/>
+                            </a:rPr>
+                          </m:ctrlPr>
+                        </m:sSupPr>
+                        <m:e>
+                          <m:r>
+                            <a:rPr lang="en-US" altLang="zh-CN" b="0" i="1" smtClean="0">
+                              <a:latin typeface="Cambria Math" panose="02040503050406030204" pitchFamily="18" charset="0"/>
+                            </a:rPr>
+                            <m:t>𝑣</m:t>
+                          </m:r>
+                        </m:e>
+                        <m:sup>
+                          <m:r>
+                            <a:rPr lang="en-US" altLang="zh-CN" b="0" i="1" smtClean="0">
+                              <a:latin typeface="Cambria Math" panose="02040503050406030204" pitchFamily="18" charset="0"/>
+                            </a:rPr>
+                            <m:t>𝑑</m:t>
+                          </m:r>
+                        </m:sup>
+                      </m:sSup>
+                      <m:r>
+                        <a:rPr lang="en-US" altLang="zh-CN" b="0" i="1" smtClean="0">
+                          <a:latin typeface="Cambria Math" panose="02040503050406030204" pitchFamily="18" charset="0"/>
+                        </a:rPr>
+                        <m:t>)</m:t>
+                      </m:r>
+                    </m:oMath>
+                  </m:oMathPara>
+                </a14:m>
+                <a:endParaRPr lang="zh-CN" altLang="en-US" dirty="0"/>
+              </a:p>
+            </p:txBody>
+          </p:sp>
+        </mc:Choice>
+        <mc:Fallback>
+          <p:sp>
+            <p:nvSpPr>
+              <p:cNvPr id="17" name="文本框 16">
+                <a:extLst>
+                  <a:ext uri="{FF2B5EF4-FFF2-40B4-BE49-F238E27FC236}">
+                    <a16:creationId xmlns:a16="http://schemas.microsoft.com/office/drawing/2014/main" id="{28467A15-EBD8-01B1-0E79-A3E89B1CD85A}"/>
+                  </a:ext>
+                </a:extLst>
+              </p:cNvPr>
+              <p:cNvSpPr txBox="1">
+                <a:spLocks noRot="1" noChangeAspect="1" noMove="1" noResize="1" noEditPoints="1" noAdjustHandles="1" noChangeArrowheads="1" noChangeShapeType="1" noTextEdit="1"/>
+              </p:cNvSpPr>
+              <p:nvPr/>
+            </p:nvSpPr>
+            <p:spPr>
+              <a:xfrm>
+                <a:off x="4134925" y="1592118"/>
+                <a:ext cx="2186688" cy="578492"/>
+              </a:xfrm>
+              <a:prstGeom prst="rect">
+                <a:avLst/>
+              </a:prstGeom>
+              <a:blipFill>
+                <a:blip r:embed="rId3"/>
+                <a:stretch>
+                  <a:fillRect/>
+                </a:stretch>
+              </a:blipFill>
+            </p:spPr>
+            <p:txBody>
+              <a:bodyPr/>
+              <a:lstStyle/>
+              <a:p>
+                <a:r>
+                  <a:rPr lang="zh-CN" altLang="en-US">
+                    <a:noFill/>
+                  </a:rPr>
+                  <a:t> </a:t>
+                </a:r>
+              </a:p>
+            </p:txBody>
+          </p:sp>
+        </mc:Fallback>
+      </mc:AlternateContent>
+      <mc:AlternateContent xmlns:mc="http://schemas.openxmlformats.org/markup-compatibility/2006">
+        <mc:Choice xmlns:a14="http://schemas.microsoft.com/office/drawing/2010/main" Requires="a14">
+          <p:sp>
+            <p:nvSpPr>
+              <p:cNvPr id="20" name="文本框 19">
+                <a:extLst>
+                  <a:ext uri="{FF2B5EF4-FFF2-40B4-BE49-F238E27FC236}">
+                    <a16:creationId xmlns:a16="http://schemas.microsoft.com/office/drawing/2014/main" id="{7BA29339-443E-021C-4B80-873B1B6744C5}"/>
+                  </a:ext>
+                </a:extLst>
+              </p:cNvPr>
+              <p:cNvSpPr txBox="1"/>
+              <p:nvPr/>
+            </p:nvSpPr>
+            <p:spPr>
+              <a:xfrm>
+                <a:off x="4134925" y="2486064"/>
+                <a:ext cx="980140" cy="559769"/>
+              </a:xfrm>
+              <a:prstGeom prst="rect">
+                <a:avLst/>
+              </a:prstGeom>
+              <a:noFill/>
+            </p:spPr>
+            <p:txBody>
+              <a:bodyPr wrap="none" lIns="0" tIns="0" rIns="0" bIns="0" rtlCol="0">
+                <a:spAutoFit/>
+              </a:bodyPr>
+              <a:lstStyle/>
+              <a:p>
+                <a:pPr/>
+                <a14:m>
+                  <m:oMathPara xmlns:m="http://schemas.openxmlformats.org/officeDocument/2006/math">
+                    <m:oMath>
+                      <m:r>
+                        <a:rPr lang="en-US" altLang="zh-CN" b="0" i="1" smtClean="0">
+                          <a:latin typeface="Cambria Math" panose="02040503050406030204" pitchFamily="18" charset="0"/>
+                        </a:rPr>
+                        <m:t>𝑝</m:t>
+                      </m:r>
+                      <m:r>
+                        <a:rPr lang="en-US" altLang="zh-CN" b="0" i="1" smtClean="0">
+                          <a:latin typeface="Cambria Math" panose="02040503050406030204" pitchFamily="18" charset="0"/>
+                        </a:rPr>
+                        <m:t>=</m:t>
+                      </m:r>
+                      <m:f>
+                        <m:fPr>
+                          <m:ctrlPr>
+                            <a:rPr lang="en-US" altLang="zh-CN" b="0" i="1" smtClean="0">
+                              <a:latin typeface="Cambria Math" panose="02040503050406030204" pitchFamily="18" charset="0"/>
+                            </a:rPr>
+                          </m:ctrlPr>
+                        </m:fPr>
+                        <m:num>
+                          <m:sSup>
+                            <m:sSupPr>
+                              <m:ctrlPr>
+                                <a:rPr lang="en-US" altLang="zh-CN" b="0" i="1" smtClean="0">
+                                  <a:latin typeface="Cambria Math" panose="02040503050406030204" pitchFamily="18" charset="0"/>
+                                </a:rPr>
+                              </m:ctrlPr>
+                            </m:sSupPr>
+                            <m:e>
+                              <m:r>
+                                <a:rPr lang="en-US" altLang="zh-CN" b="0" i="1" smtClean="0">
+                                  <a:latin typeface="Cambria Math" panose="02040503050406030204" pitchFamily="18" charset="0"/>
+                                </a:rPr>
+                                <m:t>𝑣</m:t>
+                              </m:r>
+                            </m:e>
+                            <m:sup>
+                              <m:r>
+                                <a:rPr lang="en-US" altLang="zh-CN" b="0" i="1" smtClean="0">
+                                  <a:latin typeface="Cambria Math" panose="02040503050406030204" pitchFamily="18" charset="0"/>
+                                </a:rPr>
+                                <m:t>𝑑</m:t>
+                              </m:r>
+                            </m:sup>
+                          </m:sSup>
+                        </m:num>
+                        <m:den>
+                          <m:r>
+                            <a:rPr lang="en-US" altLang="zh-CN" b="0" i="1" smtClean="0">
+                              <a:latin typeface="Cambria Math" panose="02040503050406030204" pitchFamily="18" charset="0"/>
+                            </a:rPr>
+                            <m:t>2</m:t>
+                          </m:r>
+                        </m:den>
+                      </m:f>
+                      <m:r>
+                        <a:rPr lang="en-US" altLang="zh-CN" b="0" i="1" smtClean="0">
+                          <a:latin typeface="Cambria Math" panose="02040503050406030204" pitchFamily="18" charset="0"/>
+                        </a:rPr>
+                        <m:t>+</m:t>
+                      </m:r>
+                    </m:oMath>
+                  </m:oMathPara>
+                </a14:m>
+                <a:endParaRPr lang="zh-CN" altLang="en-US" dirty="0"/>
+              </a:p>
+            </p:txBody>
+          </p:sp>
+        </mc:Choice>
+        <mc:Fallback>
+          <p:sp>
+            <p:nvSpPr>
+              <p:cNvPr id="20" name="文本框 19">
+                <a:extLst>
+                  <a:ext uri="{FF2B5EF4-FFF2-40B4-BE49-F238E27FC236}">
+                    <a16:creationId xmlns:a16="http://schemas.microsoft.com/office/drawing/2014/main" id="{7BA29339-443E-021C-4B80-873B1B6744C5}"/>
+                  </a:ext>
+                </a:extLst>
+              </p:cNvPr>
+              <p:cNvSpPr txBox="1">
+                <a:spLocks noRot="1" noChangeAspect="1" noMove="1" noResize="1" noEditPoints="1" noAdjustHandles="1" noChangeArrowheads="1" noChangeShapeType="1" noTextEdit="1"/>
+              </p:cNvSpPr>
+              <p:nvPr/>
+            </p:nvSpPr>
+            <p:spPr>
+              <a:xfrm>
+                <a:off x="4134925" y="2486064"/>
+                <a:ext cx="980140" cy="559769"/>
+              </a:xfrm>
+              <a:prstGeom prst="rect">
+                <a:avLst/>
+              </a:prstGeom>
+              <a:blipFill>
+                <a:blip r:embed="rId4"/>
+                <a:stretch>
+                  <a:fillRect/>
+                </a:stretch>
+              </a:blipFill>
+            </p:spPr>
+            <p:txBody>
+              <a:bodyPr/>
+              <a:lstStyle/>
+              <a:p>
+                <a:r>
+                  <a:rPr lang="zh-CN" altLang="en-US">
+                    <a:noFill/>
+                  </a:rPr>
+                  <a:t> </a:t>
+                </a:r>
+              </a:p>
+            </p:txBody>
+          </p:sp>
+        </mc:Fallback>
+      </mc:AlternateContent>
+      <p:sp>
+        <p:nvSpPr>
+          <p:cNvPr id="23" name="文本框 22">
+            <a:extLst>
+              <a:ext uri="{FF2B5EF4-FFF2-40B4-BE49-F238E27FC236}">
+                <a16:creationId xmlns:a16="http://schemas.microsoft.com/office/drawing/2014/main" id="{99A08A0D-DF28-F826-0432-D14068D5C5EA}"/>
+              </a:ext>
+            </a:extLst>
+          </p:cNvPr>
+          <p:cNvSpPr txBox="1"/>
+          <p:nvPr/>
+        </p:nvSpPr>
+        <p:spPr>
+          <a:xfrm>
+            <a:off x="185420" y="4730508"/>
+            <a:ext cx="3256020" cy="369332"/>
+          </a:xfrm>
+          <a:prstGeom prst="rect">
+            <a:avLst/>
+          </a:prstGeom>
+          <a:noFill/>
+        </p:spPr>
+        <p:txBody>
+          <a:bodyPr wrap="none" rtlCol="0">
+            <a:spAutoFit/>
+          </a:bodyPr>
+          <a:lstStyle/>
+          <a:p>
+            <a:r>
+              <a:rPr lang="en-US" altLang="zh-CN" dirty="0"/>
+              <a:t>4. Optimization-based method</a:t>
+            </a:r>
+            <a:endParaRPr lang="zh-CN" altLang="en-US" dirty="0"/>
+          </a:p>
+        </p:txBody>
+      </p:sp>
+      <p:sp>
+        <p:nvSpPr>
+          <p:cNvPr id="24" name="文本框 23">
+            <a:extLst>
+              <a:ext uri="{FF2B5EF4-FFF2-40B4-BE49-F238E27FC236}">
+                <a16:creationId xmlns:a16="http://schemas.microsoft.com/office/drawing/2014/main" id="{BB56A6E0-C119-E464-3770-C3097CC2FDDF}"/>
+              </a:ext>
+            </a:extLst>
+          </p:cNvPr>
+          <p:cNvSpPr txBox="1"/>
+          <p:nvPr/>
+        </p:nvSpPr>
+        <p:spPr>
+          <a:xfrm>
+            <a:off x="622300" y="3721374"/>
+            <a:ext cx="3066865" cy="369332"/>
+          </a:xfrm>
+          <a:prstGeom prst="rect">
+            <a:avLst/>
+          </a:prstGeom>
+          <a:noFill/>
+        </p:spPr>
+        <p:txBody>
+          <a:bodyPr wrap="none" rtlCol="0">
+            <a:spAutoFit/>
+          </a:bodyPr>
+          <a:lstStyle/>
+          <a:p>
+            <a:r>
+              <a:rPr lang="en-US" altLang="zh-CN" dirty="0"/>
+              <a:t>+ Parameterized curve fitting</a:t>
+            </a:r>
+            <a:endParaRPr lang="zh-CN" altLang="en-US" dirty="0"/>
+          </a:p>
+        </p:txBody>
+      </p:sp>
+    </p:spTree>
+    <p:extLst>
+      <p:ext uri="{BB962C8B-B14F-4D97-AF65-F5344CB8AC3E}">
+        <p14:creationId xmlns:p14="http://schemas.microsoft.com/office/powerpoint/2010/main" val="1691852086"/>
+      </p:ext>
+    </p:extLst>
+  </p:cSld>
+  <p:clrMapOvr>
+    <a:masterClrMapping/>
+  </p:clrMapOvr>
+</p:sld>
+</file>
+
+<file path=ppt/slides/slide5.xml><?xml version="1.0" encoding="utf-8"?>
+<p:sld xmlns:a="http://schemas.openxmlformats.org/drawingml/2006/main" xmlns:r="http://schemas.openxmlformats.org/officeDocument/2006/relationships" xmlns:p="http://schemas.openxmlformats.org/presentationml/2006/main">
+  <p:cSld>
+    <p:spTree>
+      <p:nvGrpSpPr>
+        <p:cNvPr id="1" name="">
+          <a:extLst>
+            <a:ext uri="{FF2B5EF4-FFF2-40B4-BE49-F238E27FC236}">
+              <a16:creationId xmlns:a16="http://schemas.microsoft.com/office/drawing/2014/main" id="{9F91D841-F4FB-4B38-DADF-8E846184F251}"/>
+            </a:ext>
+          </a:extLst>
+        </p:cNvPr>
+        <p:cNvGrpSpPr/>
+        <p:nvPr/>
+      </p:nvGrpSpPr>
+      <p:grpSpPr>
+        <a:xfrm>
+          <a:off x="0" y="0"/>
+          <a:ext cx="0" cy="0"/>
+          <a:chOff x="0" y="0"/>
+          <a:chExt cx="0" cy="0"/>
+        </a:xfrm>
+      </p:grpSpPr>
+      <p:sp>
+        <p:nvSpPr>
+          <p:cNvPr id="9" name="文本框 8">
+            <a:extLst>
+              <a:ext uri="{FF2B5EF4-FFF2-40B4-BE49-F238E27FC236}">
+                <a16:creationId xmlns:a16="http://schemas.microsoft.com/office/drawing/2014/main" id="{D1D645B3-8BE5-34A7-1C43-3C8E107D4A76}"/>
+              </a:ext>
+            </a:extLst>
+          </p:cNvPr>
+          <p:cNvSpPr txBox="1"/>
+          <p:nvPr/>
+        </p:nvSpPr>
+        <p:spPr>
+          <a:xfrm>
+            <a:off x="185420" y="242570"/>
+            <a:ext cx="2576346" cy="369332"/>
+          </a:xfrm>
+          <a:prstGeom prst="rect">
+            <a:avLst/>
+          </a:prstGeom>
+          <a:noFill/>
+        </p:spPr>
+        <p:txBody>
+          <a:bodyPr wrap="none" rtlCol="0">
+            <a:spAutoFit/>
+          </a:bodyPr>
+          <a:lstStyle/>
+          <a:p>
+            <a:r>
+              <a:rPr lang="en-US" altLang="zh-CN" b="1" dirty="0"/>
+              <a:t>Controller Formulation</a:t>
+            </a:r>
+            <a:endParaRPr lang="zh-CN" altLang="en-US" b="1" dirty="0"/>
+          </a:p>
+        </p:txBody>
+      </p:sp>
+      <p:sp>
+        <p:nvSpPr>
+          <p:cNvPr id="2" name="文本框 1">
+            <a:extLst>
+              <a:ext uri="{FF2B5EF4-FFF2-40B4-BE49-F238E27FC236}">
+                <a16:creationId xmlns:a16="http://schemas.microsoft.com/office/drawing/2014/main" id="{0836F9C8-C82C-EAC0-9D64-7A89439A0955}"/>
+              </a:ext>
+            </a:extLst>
+          </p:cNvPr>
+          <p:cNvSpPr txBox="1"/>
+          <p:nvPr/>
+        </p:nvSpPr>
+        <p:spPr>
+          <a:xfrm>
+            <a:off x="185420" y="882650"/>
+            <a:ext cx="3419526" cy="369332"/>
+          </a:xfrm>
+          <a:prstGeom prst="rect">
+            <a:avLst/>
+          </a:prstGeom>
+          <a:noFill/>
+        </p:spPr>
+        <p:txBody>
+          <a:bodyPr wrap="none" rtlCol="0">
+            <a:spAutoFit/>
+          </a:bodyPr>
+          <a:lstStyle/>
+          <a:p>
+            <a:r>
+              <a:rPr lang="en-US" altLang="zh-CN" dirty="0"/>
+              <a:t>MPC controller for torso motion</a:t>
+            </a:r>
+            <a:endParaRPr lang="zh-CN" altLang="en-US" dirty="0"/>
+          </a:p>
+        </p:txBody>
+      </p:sp>
+      <p:sp>
+        <p:nvSpPr>
+          <p:cNvPr id="11" name="文本框 10">
+            <a:extLst>
+              <a:ext uri="{FF2B5EF4-FFF2-40B4-BE49-F238E27FC236}">
+                <a16:creationId xmlns:a16="http://schemas.microsoft.com/office/drawing/2014/main" id="{03E24CDE-0A4B-594D-55CB-9701630885B1}"/>
+              </a:ext>
+            </a:extLst>
+          </p:cNvPr>
+          <p:cNvSpPr txBox="1"/>
+          <p:nvPr/>
+        </p:nvSpPr>
+        <p:spPr>
+          <a:xfrm>
+            <a:off x="203537" y="1631950"/>
+            <a:ext cx="2664512" cy="369332"/>
+          </a:xfrm>
+          <a:prstGeom prst="rect">
+            <a:avLst/>
+          </a:prstGeom>
+          <a:noFill/>
+        </p:spPr>
+        <p:txBody>
+          <a:bodyPr wrap="none" rtlCol="0">
+            <a:spAutoFit/>
+          </a:bodyPr>
+          <a:lstStyle/>
+          <a:p>
+            <a:r>
+              <a:rPr lang="en-US" altLang="zh-CN" dirty="0"/>
+              <a:t>Discrete dynamics model</a:t>
+            </a:r>
+            <a:endParaRPr lang="zh-CN" altLang="en-US" dirty="0"/>
+          </a:p>
+        </p:txBody>
+      </p:sp>
+      <p:sp>
+        <p:nvSpPr>
+          <p:cNvPr id="14" name="文本框 13">
+            <a:extLst>
+              <a:ext uri="{FF2B5EF4-FFF2-40B4-BE49-F238E27FC236}">
+                <a16:creationId xmlns:a16="http://schemas.microsoft.com/office/drawing/2014/main" id="{2CC1782B-3E78-126A-AFDD-FC6C0B5DAD38}"/>
+              </a:ext>
+            </a:extLst>
+          </p:cNvPr>
+          <p:cNvSpPr txBox="1"/>
+          <p:nvPr/>
+        </p:nvSpPr>
+        <p:spPr>
+          <a:xfrm>
+            <a:off x="203537" y="2323584"/>
+            <a:ext cx="2682145" cy="369332"/>
+          </a:xfrm>
+          <a:prstGeom prst="rect">
+            <a:avLst/>
+          </a:prstGeom>
+          <a:noFill/>
+        </p:spPr>
+        <p:txBody>
+          <a:bodyPr wrap="none" rtlCol="0">
+            <a:spAutoFit/>
+          </a:bodyPr>
+          <a:lstStyle/>
+          <a:p>
+            <a:r>
+              <a:rPr lang="en-US" altLang="zh-CN" dirty="0"/>
+              <a:t>Optimization formulation</a:t>
+            </a:r>
+            <a:endParaRPr lang="zh-CN" altLang="en-US" dirty="0"/>
+          </a:p>
+        </p:txBody>
+      </p:sp>
+      <p:sp>
+        <p:nvSpPr>
+          <p:cNvPr id="18" name="文本框 17">
+            <a:extLst>
+              <a:ext uri="{FF2B5EF4-FFF2-40B4-BE49-F238E27FC236}">
+                <a16:creationId xmlns:a16="http://schemas.microsoft.com/office/drawing/2014/main" id="{59983BE2-0E92-8B7E-E7C8-4DDB76735D76}"/>
+              </a:ext>
+            </a:extLst>
+          </p:cNvPr>
+          <p:cNvSpPr txBox="1"/>
+          <p:nvPr/>
+        </p:nvSpPr>
+        <p:spPr>
+          <a:xfrm>
+            <a:off x="203537" y="3015218"/>
+            <a:ext cx="1806905" cy="369332"/>
+          </a:xfrm>
+          <a:prstGeom prst="rect">
+            <a:avLst/>
+          </a:prstGeom>
+          <a:noFill/>
+        </p:spPr>
+        <p:txBody>
+          <a:bodyPr wrap="none" rtlCol="0">
+            <a:spAutoFit/>
+          </a:bodyPr>
+          <a:lstStyle/>
+          <a:p>
+            <a:r>
+              <a:rPr lang="en-US" altLang="zh-CN" dirty="0"/>
+              <a:t>Phase constraint</a:t>
+            </a:r>
+            <a:endParaRPr lang="zh-CN" altLang="en-US" dirty="0"/>
+          </a:p>
+        </p:txBody>
+      </p:sp>
+    </p:spTree>
+    <p:extLst>
+      <p:ext uri="{BB962C8B-B14F-4D97-AF65-F5344CB8AC3E}">
+        <p14:creationId xmlns:p14="http://schemas.microsoft.com/office/powerpoint/2010/main" val="428668732"/>
+      </p:ext>
+    </p:extLst>
+  </p:cSld>
+  <p:clrMapOvr>
+    <a:masterClrMapping/>
+  </p:clrMapOvr>
+</p:sld>
+</file>
+
+<file path=ppt/slides/slide6.xml><?xml version="1.0" encoding="utf-8"?>
+<p:sld xmlns:a="http://schemas.openxmlformats.org/drawingml/2006/main" xmlns:r="http://schemas.openxmlformats.org/officeDocument/2006/relationships" xmlns:p="http://schemas.openxmlformats.org/presentationml/2006/main">
+  <p:cSld>
+    <p:spTree>
+      <p:nvGrpSpPr>
+        <p:cNvPr id="1" name="">
+          <a:extLst>
+            <a:ext uri="{FF2B5EF4-FFF2-40B4-BE49-F238E27FC236}">
+              <a16:creationId xmlns:a16="http://schemas.microsoft.com/office/drawing/2014/main" id="{A62382F8-1C94-97E6-A9B9-168C9C10037E}"/>
+            </a:ext>
+          </a:extLst>
+        </p:cNvPr>
+        <p:cNvGrpSpPr/>
+        <p:nvPr/>
+      </p:nvGrpSpPr>
+      <p:grpSpPr>
+        <a:xfrm>
+          <a:off x="0" y="0"/>
+          <a:ext cx="0" cy="0"/>
+          <a:chOff x="0" y="0"/>
+          <a:chExt cx="0" cy="0"/>
+        </a:xfrm>
+      </p:grpSpPr>
+      <p:sp>
+        <p:nvSpPr>
+          <p:cNvPr id="9" name="文本框 8">
+            <a:extLst>
+              <a:ext uri="{FF2B5EF4-FFF2-40B4-BE49-F238E27FC236}">
+                <a16:creationId xmlns:a16="http://schemas.microsoft.com/office/drawing/2014/main" id="{A1196BF4-5DDD-0197-1B59-1DAE04CBAFBD}"/>
+              </a:ext>
+            </a:extLst>
+          </p:cNvPr>
+          <p:cNvSpPr txBox="1"/>
+          <p:nvPr/>
+        </p:nvSpPr>
+        <p:spPr>
+          <a:xfrm>
+            <a:off x="185420" y="242570"/>
+            <a:ext cx="2576346" cy="369332"/>
+          </a:xfrm>
+          <a:prstGeom prst="rect">
+            <a:avLst/>
+          </a:prstGeom>
+          <a:noFill/>
+        </p:spPr>
+        <p:txBody>
+          <a:bodyPr wrap="none" rtlCol="0">
+            <a:spAutoFit/>
+          </a:bodyPr>
+          <a:lstStyle/>
+          <a:p>
+            <a:r>
+              <a:rPr lang="en-US" altLang="zh-CN" b="1" dirty="0"/>
+              <a:t>Controller Formulation</a:t>
+            </a:r>
+            <a:endParaRPr lang="zh-CN" altLang="en-US" b="1" dirty="0"/>
+          </a:p>
+        </p:txBody>
+      </p:sp>
+      <p:sp>
+        <p:nvSpPr>
+          <p:cNvPr id="2" name="文本框 1">
+            <a:extLst>
+              <a:ext uri="{FF2B5EF4-FFF2-40B4-BE49-F238E27FC236}">
+                <a16:creationId xmlns:a16="http://schemas.microsoft.com/office/drawing/2014/main" id="{3406AADE-EA16-5800-A391-93909E86F3C1}"/>
+              </a:ext>
+            </a:extLst>
+          </p:cNvPr>
+          <p:cNvSpPr txBox="1"/>
+          <p:nvPr/>
+        </p:nvSpPr>
+        <p:spPr>
+          <a:xfrm>
+            <a:off x="185420" y="882650"/>
+            <a:ext cx="3047629" cy="369332"/>
+          </a:xfrm>
+          <a:prstGeom prst="rect">
+            <a:avLst/>
+          </a:prstGeom>
+          <a:noFill/>
+        </p:spPr>
+        <p:txBody>
+          <a:bodyPr wrap="none" rtlCol="0">
+            <a:spAutoFit/>
+          </a:bodyPr>
+          <a:lstStyle/>
+          <a:p>
+            <a:r>
+              <a:rPr lang="en-US" altLang="zh-CN" dirty="0"/>
+              <a:t>PD controller for joint torque</a:t>
+            </a:r>
+            <a:endParaRPr lang="zh-CN" altLang="en-US" dirty="0"/>
+          </a:p>
+        </p:txBody>
+      </p:sp>
+      <p:sp>
+        <p:nvSpPr>
+          <p:cNvPr id="4" name="文本框 3">
+            <a:extLst>
+              <a:ext uri="{FF2B5EF4-FFF2-40B4-BE49-F238E27FC236}">
+                <a16:creationId xmlns:a16="http://schemas.microsoft.com/office/drawing/2014/main" id="{D9489834-0DE3-ED81-0B42-65518C668A63}"/>
+              </a:ext>
+            </a:extLst>
+          </p:cNvPr>
+          <p:cNvSpPr txBox="1"/>
+          <p:nvPr/>
+        </p:nvSpPr>
+        <p:spPr>
+          <a:xfrm>
+            <a:off x="185420" y="1606550"/>
+            <a:ext cx="1207382" cy="369332"/>
+          </a:xfrm>
+          <a:prstGeom prst="rect">
+            <a:avLst/>
+          </a:prstGeom>
+          <a:noFill/>
+        </p:spPr>
+        <p:txBody>
+          <a:bodyPr wrap="none" rtlCol="0">
+            <a:spAutoFit/>
+          </a:bodyPr>
+          <a:lstStyle/>
+          <a:p>
+            <a:r>
+              <a:rPr lang="en-US" altLang="zh-CN" dirty="0"/>
+              <a:t>Stance leg</a:t>
+            </a:r>
+            <a:endParaRPr lang="zh-CN" altLang="en-US" dirty="0"/>
+          </a:p>
+        </p:txBody>
+      </p:sp>
+      <p:sp>
+        <p:nvSpPr>
+          <p:cNvPr id="6" name="文本框 5">
+            <a:extLst>
+              <a:ext uri="{FF2B5EF4-FFF2-40B4-BE49-F238E27FC236}">
+                <a16:creationId xmlns:a16="http://schemas.microsoft.com/office/drawing/2014/main" id="{BBF33458-2284-74DC-2250-CCEDB6643B5D}"/>
+              </a:ext>
+            </a:extLst>
+          </p:cNvPr>
+          <p:cNvSpPr txBox="1"/>
+          <p:nvPr/>
+        </p:nvSpPr>
+        <p:spPr>
+          <a:xfrm>
+            <a:off x="185420" y="2298184"/>
+            <a:ext cx="1141659" cy="369332"/>
+          </a:xfrm>
+          <a:prstGeom prst="rect">
+            <a:avLst/>
+          </a:prstGeom>
+          <a:noFill/>
+        </p:spPr>
+        <p:txBody>
+          <a:bodyPr wrap="none" rtlCol="0">
+            <a:spAutoFit/>
+          </a:bodyPr>
+          <a:lstStyle/>
+          <a:p>
+            <a:r>
+              <a:rPr lang="en-US" altLang="zh-CN" dirty="0"/>
+              <a:t>Swing leg</a:t>
+            </a:r>
+            <a:endParaRPr lang="zh-CN" altLang="en-US" dirty="0"/>
+          </a:p>
+        </p:txBody>
+      </p:sp>
+    </p:spTree>
+    <p:extLst>
+      <p:ext uri="{BB962C8B-B14F-4D97-AF65-F5344CB8AC3E}">
+        <p14:creationId xmlns:p14="http://schemas.microsoft.com/office/powerpoint/2010/main" val="2099233214"/>
+      </p:ext>
+    </p:extLst>
+  </p:cSld>
+  <p:clrMapOvr>
+    <a:masterClrMapping/>
+  </p:clrMapOvr>
+</p:sld>
+</file>
+
+<file path=ppt/slides/slide7.xml><?xml version="1.0" encoding="utf-8"?>
+<p:sld xmlns:a="http://schemas.openxmlformats.org/drawingml/2006/main" xmlns:r="http://schemas.openxmlformats.org/officeDocument/2006/relationships" xmlns:p="http://schemas.openxmlformats.org/presentationml/2006/main">
+  <p:cSld>
+    <p:spTree>
+      <p:nvGrpSpPr>
+        <p:cNvPr id="1" name="">
+          <a:extLst>
+            <a:ext uri="{FF2B5EF4-FFF2-40B4-BE49-F238E27FC236}">
+              <a16:creationId xmlns:a16="http://schemas.microsoft.com/office/drawing/2014/main" id="{99DFE33E-8344-119C-2418-749B7DB7889D}"/>
+            </a:ext>
+          </a:extLst>
+        </p:cNvPr>
+        <p:cNvGrpSpPr/>
+        <p:nvPr/>
+      </p:nvGrpSpPr>
+      <p:grpSpPr>
+        <a:xfrm>
+          <a:off x="0" y="0"/>
+          <a:ext cx="0" cy="0"/>
+          <a:chOff x="0" y="0"/>
+          <a:chExt cx="0" cy="0"/>
+        </a:xfrm>
+      </p:grpSpPr>
+      <p:sp>
+        <p:nvSpPr>
+          <p:cNvPr id="9" name="文本框 8">
+            <a:extLst>
+              <a:ext uri="{FF2B5EF4-FFF2-40B4-BE49-F238E27FC236}">
+                <a16:creationId xmlns:a16="http://schemas.microsoft.com/office/drawing/2014/main" id="{475F9863-7733-2B8F-1844-DF520329875A}"/>
+              </a:ext>
+            </a:extLst>
+          </p:cNvPr>
+          <p:cNvSpPr txBox="1"/>
+          <p:nvPr/>
+        </p:nvSpPr>
+        <p:spPr>
+          <a:xfrm>
+            <a:off x="185420" y="242570"/>
+            <a:ext cx="958917" cy="369332"/>
+          </a:xfrm>
+          <a:prstGeom prst="rect">
+            <a:avLst/>
+          </a:prstGeom>
+          <a:noFill/>
+        </p:spPr>
+        <p:txBody>
+          <a:bodyPr wrap="none" rtlCol="0">
+            <a:spAutoFit/>
+          </a:bodyPr>
+          <a:lstStyle/>
+          <a:p>
+            <a:r>
+              <a:rPr lang="en-US" altLang="zh-CN" b="1" dirty="0"/>
+              <a:t>Metrics</a:t>
+            </a:r>
+            <a:endParaRPr lang="zh-CN" altLang="en-US" b="1" dirty="0"/>
+          </a:p>
+        </p:txBody>
+      </p:sp>
+      <p:sp>
+        <p:nvSpPr>
+          <p:cNvPr id="2" name="文本框 1">
+            <a:extLst>
+              <a:ext uri="{FF2B5EF4-FFF2-40B4-BE49-F238E27FC236}">
+                <a16:creationId xmlns:a16="http://schemas.microsoft.com/office/drawing/2014/main" id="{7CAFDED4-51A8-AAAD-DD8B-28C44396D0B9}"/>
+              </a:ext>
+            </a:extLst>
+          </p:cNvPr>
+          <p:cNvSpPr txBox="1"/>
+          <p:nvPr/>
+        </p:nvSpPr>
+        <p:spPr>
+          <a:xfrm>
+            <a:off x="185420" y="1746250"/>
+            <a:ext cx="1960793" cy="369332"/>
+          </a:xfrm>
+          <a:prstGeom prst="rect">
+            <a:avLst/>
+          </a:prstGeom>
+          <a:noFill/>
+        </p:spPr>
+        <p:txBody>
+          <a:bodyPr wrap="none" rtlCol="0">
+            <a:spAutoFit/>
+          </a:bodyPr>
+          <a:lstStyle/>
+          <a:p>
+            <a:r>
+              <a:rPr lang="en-US" altLang="zh-CN" dirty="0"/>
+              <a:t>Poincare segment</a:t>
+            </a:r>
+            <a:endParaRPr lang="zh-CN" altLang="en-US" dirty="0"/>
+          </a:p>
+        </p:txBody>
+      </p:sp>
+      <p:sp>
+        <p:nvSpPr>
+          <p:cNvPr id="4" name="文本框 3">
+            <a:extLst>
+              <a:ext uri="{FF2B5EF4-FFF2-40B4-BE49-F238E27FC236}">
+                <a16:creationId xmlns:a16="http://schemas.microsoft.com/office/drawing/2014/main" id="{44E30E36-B425-86E1-46CA-4B7363BD71CE}"/>
+              </a:ext>
+            </a:extLst>
+          </p:cNvPr>
+          <p:cNvSpPr txBox="1"/>
+          <p:nvPr/>
+        </p:nvSpPr>
+        <p:spPr>
+          <a:xfrm>
+            <a:off x="185420" y="901700"/>
+            <a:ext cx="1895071" cy="369332"/>
+          </a:xfrm>
+          <a:prstGeom prst="rect">
+            <a:avLst/>
+          </a:prstGeom>
+          <a:noFill/>
+        </p:spPr>
+        <p:txBody>
+          <a:bodyPr wrap="none" rtlCol="0">
+            <a:spAutoFit/>
+          </a:bodyPr>
+          <a:lstStyle/>
+          <a:p>
+            <a:r>
+              <a:rPr lang="en-US" altLang="zh-CN" dirty="0"/>
+              <a:t>Augmented state</a:t>
+            </a:r>
+            <a:endParaRPr lang="zh-CN" altLang="en-US" dirty="0"/>
+          </a:p>
+        </p:txBody>
+      </p:sp>
+      <p:sp>
+        <p:nvSpPr>
+          <p:cNvPr id="6" name="文本框 5">
+            <a:extLst>
+              <a:ext uri="{FF2B5EF4-FFF2-40B4-BE49-F238E27FC236}">
+                <a16:creationId xmlns:a16="http://schemas.microsoft.com/office/drawing/2014/main" id="{5DA82056-7644-2741-6DDC-691F8B08CDF9}"/>
+              </a:ext>
+            </a:extLst>
+          </p:cNvPr>
+          <p:cNvSpPr txBox="1"/>
+          <p:nvPr/>
+        </p:nvSpPr>
+        <p:spPr>
+          <a:xfrm>
+            <a:off x="185420" y="2590800"/>
+            <a:ext cx="1346844" cy="369332"/>
+          </a:xfrm>
+          <a:prstGeom prst="rect">
+            <a:avLst/>
+          </a:prstGeom>
+          <a:noFill/>
+        </p:spPr>
+        <p:txBody>
+          <a:bodyPr wrap="none" rtlCol="0">
+            <a:spAutoFit/>
+          </a:bodyPr>
+          <a:lstStyle/>
+          <a:p>
+            <a:r>
+              <a:rPr lang="en-US" altLang="zh-CN" dirty="0"/>
+              <a:t>Return map</a:t>
+            </a:r>
+            <a:endParaRPr lang="zh-CN" altLang="en-US" dirty="0"/>
+          </a:p>
+        </p:txBody>
+      </p:sp>
+      <p:sp>
+        <p:nvSpPr>
+          <p:cNvPr id="8" name="文本框 7">
+            <a:extLst>
+              <a:ext uri="{FF2B5EF4-FFF2-40B4-BE49-F238E27FC236}">
+                <a16:creationId xmlns:a16="http://schemas.microsoft.com/office/drawing/2014/main" id="{AFE9C30C-6A7E-E9C3-5B90-29856BF0E84B}"/>
+              </a:ext>
+            </a:extLst>
+          </p:cNvPr>
+          <p:cNvSpPr txBox="1"/>
+          <p:nvPr/>
+        </p:nvSpPr>
+        <p:spPr>
+          <a:xfrm>
+            <a:off x="185420" y="3435350"/>
+            <a:ext cx="1923925" cy="369332"/>
+          </a:xfrm>
+          <a:prstGeom prst="rect">
+            <a:avLst/>
+          </a:prstGeom>
+          <a:noFill/>
+        </p:spPr>
+        <p:txBody>
+          <a:bodyPr wrap="none" rtlCol="0">
+            <a:spAutoFit/>
+          </a:bodyPr>
+          <a:lstStyle/>
+          <a:p>
+            <a:r>
+              <a:rPr lang="en-US" altLang="zh-CN" dirty="0" err="1"/>
+              <a:t>Floquet</a:t>
+            </a:r>
+            <a:r>
+              <a:rPr lang="en-US" altLang="zh-CN" dirty="0"/>
+              <a:t> multiplier</a:t>
+            </a:r>
+            <a:endParaRPr lang="zh-CN" altLang="en-US" dirty="0"/>
+          </a:p>
+        </p:txBody>
+      </p:sp>
+    </p:spTree>
+    <p:extLst>
+      <p:ext uri="{BB962C8B-B14F-4D97-AF65-F5344CB8AC3E}">
+        <p14:creationId xmlns:p14="http://schemas.microsoft.com/office/powerpoint/2010/main" val="1144713039"/>
+      </p:ext>
+    </p:extLst>
+  </p:cSld>
+  <p:clrMapOvr>
+    <a:masterClrMapping/>
+  </p:clrMapOvr>
+</p:sld>
+</file>
+
+<file path=ppt/slides/slide8.xml><?xml version="1.0" encoding="utf-8"?>
+<p:sld xmlns:a="http://schemas.openxmlformats.org/drawingml/2006/main" xmlns:r="http://schemas.openxmlformats.org/officeDocument/2006/relationships" xmlns:p="http://schemas.openxmlformats.org/presentationml/2006/main">
+  <p:cSld>
+    <p:spTree>
+      <p:nvGrpSpPr>
+        <p:cNvPr id="1" name="">
+          <a:extLst>
+            <a:ext uri="{FF2B5EF4-FFF2-40B4-BE49-F238E27FC236}">
+              <a16:creationId xmlns:a16="http://schemas.microsoft.com/office/drawing/2014/main" id="{5C782401-8432-E02B-50EA-20382C5C7AD5}"/>
+            </a:ext>
+          </a:extLst>
+        </p:cNvPr>
+        <p:cNvGrpSpPr/>
+        <p:nvPr/>
+      </p:nvGrpSpPr>
+      <p:grpSpPr>
+        <a:xfrm>
+          <a:off x="0" y="0"/>
+          <a:ext cx="0" cy="0"/>
+          <a:chOff x="0" y="0"/>
+          <a:chExt cx="0" cy="0"/>
+        </a:xfrm>
+      </p:grpSpPr>
+      <p:sp>
+        <p:nvSpPr>
+          <p:cNvPr id="9" name="文本框 8">
+            <a:extLst>
+              <a:ext uri="{FF2B5EF4-FFF2-40B4-BE49-F238E27FC236}">
+                <a16:creationId xmlns:a16="http://schemas.microsoft.com/office/drawing/2014/main" id="{37895967-200D-BBA0-AE23-FB920EE076F0}"/>
+              </a:ext>
+            </a:extLst>
+          </p:cNvPr>
+          <p:cNvSpPr txBox="1"/>
+          <p:nvPr/>
+        </p:nvSpPr>
+        <p:spPr>
+          <a:xfrm>
+            <a:off x="185420" y="242570"/>
+            <a:ext cx="1301959" cy="369332"/>
+          </a:xfrm>
+          <a:prstGeom prst="rect">
+            <a:avLst/>
+          </a:prstGeom>
+          <a:noFill/>
+        </p:spPr>
+        <p:txBody>
+          <a:bodyPr wrap="none" rtlCol="0">
+            <a:spAutoFit/>
+          </a:bodyPr>
+          <a:lstStyle/>
+          <a:p>
+            <a:r>
+              <a:rPr lang="en-US" altLang="zh-CN" b="1" dirty="0"/>
+              <a:t>Tech Stack</a:t>
+            </a:r>
+            <a:endParaRPr lang="zh-CN" altLang="en-US" b="1" dirty="0"/>
+          </a:p>
+        </p:txBody>
+      </p:sp>
+      <p:sp>
+        <p:nvSpPr>
+          <p:cNvPr id="4" name="文本框 3">
+            <a:extLst>
+              <a:ext uri="{FF2B5EF4-FFF2-40B4-BE49-F238E27FC236}">
+                <a16:creationId xmlns:a16="http://schemas.microsoft.com/office/drawing/2014/main" id="{89266749-AFB6-5682-9559-E91F2140D59E}"/>
+              </a:ext>
+            </a:extLst>
+          </p:cNvPr>
+          <p:cNvSpPr txBox="1"/>
+          <p:nvPr/>
+        </p:nvSpPr>
+        <p:spPr>
+          <a:xfrm>
+            <a:off x="185420" y="901700"/>
+            <a:ext cx="1226618" cy="369332"/>
+          </a:xfrm>
+          <a:prstGeom prst="rect">
+            <a:avLst/>
+          </a:prstGeom>
+          <a:noFill/>
+        </p:spPr>
+        <p:txBody>
+          <a:bodyPr wrap="none" rtlCol="0">
+            <a:spAutoFit/>
+          </a:bodyPr>
+          <a:lstStyle/>
+          <a:p>
+            <a:r>
+              <a:rPr lang="en-US" altLang="zh-CN" dirty="0"/>
+              <a:t>Simulation</a:t>
+            </a:r>
+            <a:endParaRPr lang="zh-CN" altLang="en-US" dirty="0"/>
+          </a:p>
+        </p:txBody>
+      </p:sp>
+      <p:sp>
+        <p:nvSpPr>
+          <p:cNvPr id="5" name="文本框 4">
+            <a:extLst>
+              <a:ext uri="{FF2B5EF4-FFF2-40B4-BE49-F238E27FC236}">
+                <a16:creationId xmlns:a16="http://schemas.microsoft.com/office/drawing/2014/main" id="{68894B90-49B2-321A-1B1C-E6B5DA87ABBE}"/>
+              </a:ext>
+            </a:extLst>
+          </p:cNvPr>
+          <p:cNvSpPr txBox="1"/>
+          <p:nvPr/>
+        </p:nvSpPr>
+        <p:spPr>
+          <a:xfrm>
+            <a:off x="185420" y="1492250"/>
+            <a:ext cx="1324402" cy="369332"/>
+          </a:xfrm>
+          <a:prstGeom prst="rect">
+            <a:avLst/>
+          </a:prstGeom>
+          <a:noFill/>
+        </p:spPr>
+        <p:txBody>
+          <a:bodyPr wrap="none" rtlCol="0">
+            <a:spAutoFit/>
+          </a:bodyPr>
+          <a:lstStyle/>
+          <a:p>
+            <a:r>
+              <a:rPr lang="en-US" altLang="zh-CN" dirty="0"/>
+              <a:t>MPC Solver</a:t>
+            </a:r>
+            <a:endParaRPr lang="zh-CN" altLang="en-US" dirty="0"/>
+          </a:p>
+        </p:txBody>
+      </p:sp>
+    </p:spTree>
+    <p:extLst>
+      <p:ext uri="{BB962C8B-B14F-4D97-AF65-F5344CB8AC3E}">
+        <p14:creationId xmlns:p14="http://schemas.microsoft.com/office/powerpoint/2010/main" val="4205608091"/>
       </p:ext>
     </p:extLst>
   </p:cSld>

</xml_diff>

<commit_message>
nov 1 liwei pre skeleton v2
</commit_message>
<xml_diff>
--- a/pre.pptx
+++ b/pre.pptx
@@ -6,13 +6,14 @@
   </p:sldMasterIdLst>
   <p:sldIdLst>
     <p:sldId id="256" r:id="rId2"/>
-    <p:sldId id="257" r:id="rId3"/>
-    <p:sldId id="258" r:id="rId4"/>
-    <p:sldId id="259" r:id="rId5"/>
-    <p:sldId id="260" r:id="rId6"/>
-    <p:sldId id="261" r:id="rId7"/>
-    <p:sldId id="262" r:id="rId8"/>
-    <p:sldId id="263" r:id="rId9"/>
+    <p:sldId id="264" r:id="rId3"/>
+    <p:sldId id="265" r:id="rId4"/>
+    <p:sldId id="258" r:id="rId5"/>
+    <p:sldId id="257" r:id="rId6"/>
+    <p:sldId id="260" r:id="rId7"/>
+    <p:sldId id="259" r:id="rId8"/>
+    <p:sldId id="262" r:id="rId9"/>
+    <p:sldId id="263" r:id="rId10"/>
   </p:sldIdLst>
   <p:sldSz cx="12192000" cy="6858000"/>
   <p:notesSz cx="6858000" cy="9144000"/>
@@ -266,7 +267,7 @@
           <a:p>
             <a:fld id="{6AC4C883-4F8E-D34E-94FD-1282DC67D150}" type="datetimeFigureOut">
               <a:rPr kumimoji="1" lang="zh-CN" altLang="en-US" smtClean="0"/>
-              <a:t>2026/10/31</a:t>
+              <a:t>2026/11/1</a:t>
             </a:fld>
             <a:endParaRPr kumimoji="1" lang="zh-CN" altLang="en-US"/>
           </a:p>
@@ -464,7 +465,7 @@
           <a:p>
             <a:fld id="{6AC4C883-4F8E-D34E-94FD-1282DC67D150}" type="datetimeFigureOut">
               <a:rPr kumimoji="1" lang="zh-CN" altLang="en-US" smtClean="0"/>
-              <a:t>2026/10/31</a:t>
+              <a:t>2026/11/1</a:t>
             </a:fld>
             <a:endParaRPr kumimoji="1" lang="zh-CN" altLang="en-US"/>
           </a:p>
@@ -672,7 +673,7 @@
           <a:p>
             <a:fld id="{6AC4C883-4F8E-D34E-94FD-1282DC67D150}" type="datetimeFigureOut">
               <a:rPr kumimoji="1" lang="zh-CN" altLang="en-US" smtClean="0"/>
-              <a:t>2026/10/31</a:t>
+              <a:t>2026/11/1</a:t>
             </a:fld>
             <a:endParaRPr kumimoji="1" lang="zh-CN" altLang="en-US"/>
           </a:p>
@@ -870,7 +871,7 @@
           <a:p>
             <a:fld id="{6AC4C883-4F8E-D34E-94FD-1282DC67D150}" type="datetimeFigureOut">
               <a:rPr kumimoji="1" lang="zh-CN" altLang="en-US" smtClean="0"/>
-              <a:t>2026/10/31</a:t>
+              <a:t>2026/11/1</a:t>
             </a:fld>
             <a:endParaRPr kumimoji="1" lang="zh-CN" altLang="en-US"/>
           </a:p>
@@ -1145,7 +1146,7 @@
           <a:p>
             <a:fld id="{6AC4C883-4F8E-D34E-94FD-1282DC67D150}" type="datetimeFigureOut">
               <a:rPr kumimoji="1" lang="zh-CN" altLang="en-US" smtClean="0"/>
-              <a:t>2026/10/31</a:t>
+              <a:t>2026/11/1</a:t>
             </a:fld>
             <a:endParaRPr kumimoji="1" lang="zh-CN" altLang="en-US"/>
           </a:p>
@@ -1410,7 +1411,7 @@
           <a:p>
             <a:fld id="{6AC4C883-4F8E-D34E-94FD-1282DC67D150}" type="datetimeFigureOut">
               <a:rPr kumimoji="1" lang="zh-CN" altLang="en-US" smtClean="0"/>
-              <a:t>2026/10/31</a:t>
+              <a:t>2026/11/1</a:t>
             </a:fld>
             <a:endParaRPr kumimoji="1" lang="zh-CN" altLang="en-US"/>
           </a:p>
@@ -1822,7 +1823,7 @@
           <a:p>
             <a:fld id="{6AC4C883-4F8E-D34E-94FD-1282DC67D150}" type="datetimeFigureOut">
               <a:rPr kumimoji="1" lang="zh-CN" altLang="en-US" smtClean="0"/>
-              <a:t>2026/10/31</a:t>
+              <a:t>2026/11/1</a:t>
             </a:fld>
             <a:endParaRPr kumimoji="1" lang="zh-CN" altLang="en-US"/>
           </a:p>
@@ -1963,7 +1964,7 @@
           <a:p>
             <a:fld id="{6AC4C883-4F8E-D34E-94FD-1282DC67D150}" type="datetimeFigureOut">
               <a:rPr kumimoji="1" lang="zh-CN" altLang="en-US" smtClean="0"/>
-              <a:t>2026/10/31</a:t>
+              <a:t>2026/11/1</a:t>
             </a:fld>
             <a:endParaRPr kumimoji="1" lang="zh-CN" altLang="en-US"/>
           </a:p>
@@ -2076,7 +2077,7 @@
           <a:p>
             <a:fld id="{6AC4C883-4F8E-D34E-94FD-1282DC67D150}" type="datetimeFigureOut">
               <a:rPr kumimoji="1" lang="zh-CN" altLang="en-US" smtClean="0"/>
-              <a:t>2026/10/31</a:t>
+              <a:t>2026/11/1</a:t>
             </a:fld>
             <a:endParaRPr kumimoji="1" lang="zh-CN" altLang="en-US"/>
           </a:p>
@@ -2387,7 +2388,7 @@
           <a:p>
             <a:fld id="{6AC4C883-4F8E-D34E-94FD-1282DC67D150}" type="datetimeFigureOut">
               <a:rPr kumimoji="1" lang="zh-CN" altLang="en-US" smtClean="0"/>
-              <a:t>2026/10/31</a:t>
+              <a:t>2026/11/1</a:t>
             </a:fld>
             <a:endParaRPr kumimoji="1" lang="zh-CN" altLang="en-US"/>
           </a:p>
@@ -2675,7 +2676,7 @@
           <a:p>
             <a:fld id="{6AC4C883-4F8E-D34E-94FD-1282DC67D150}" type="datetimeFigureOut">
               <a:rPr kumimoji="1" lang="zh-CN" altLang="en-US" smtClean="0"/>
-              <a:t>2026/10/31</a:t>
+              <a:t>2026/11/1</a:t>
             </a:fld>
             <a:endParaRPr kumimoji="1" lang="zh-CN" altLang="en-US"/>
           </a:p>
@@ -2916,7 +2917,7 @@
           <a:p>
             <a:fld id="{6AC4C883-4F8E-D34E-94FD-1282DC67D150}" type="datetimeFigureOut">
               <a:rPr kumimoji="1" lang="zh-CN" altLang="en-US" smtClean="0"/>
-              <a:t>2026/10/31</a:t>
+              <a:t>2026/11/1</a:t>
             </a:fld>
             <a:endParaRPr kumimoji="1" lang="zh-CN" altLang="en-US"/>
           </a:p>
@@ -3430,6 +3431,1604 @@
   <p:cSld>
     <p:spTree>
       <p:nvGrpSpPr>
+        <p:cNvPr id="1" name="">
+          <a:extLst>
+            <a:ext uri="{FF2B5EF4-FFF2-40B4-BE49-F238E27FC236}">
+              <a16:creationId xmlns:a16="http://schemas.microsoft.com/office/drawing/2014/main" id="{ACE58832-41E6-688B-F9AC-1F8A1DF0BADD}"/>
+            </a:ext>
+          </a:extLst>
+        </p:cNvPr>
+        <p:cNvGrpSpPr/>
+        <p:nvPr/>
+      </p:nvGrpSpPr>
+      <p:grpSpPr>
+        <a:xfrm>
+          <a:off x="0" y="0"/>
+          <a:ext cx="0" cy="0"/>
+          <a:chOff x="0" y="0"/>
+          <a:chExt cx="0" cy="0"/>
+        </a:xfrm>
+      </p:grpSpPr>
+      <p:sp>
+        <p:nvSpPr>
+          <p:cNvPr id="9" name="文本框 8">
+            <a:extLst>
+              <a:ext uri="{FF2B5EF4-FFF2-40B4-BE49-F238E27FC236}">
+                <a16:creationId xmlns:a16="http://schemas.microsoft.com/office/drawing/2014/main" id="{6FBFAD94-0498-6D61-E69E-5ADFBC1DD8A0}"/>
+              </a:ext>
+            </a:extLst>
+          </p:cNvPr>
+          <p:cNvSpPr txBox="1"/>
+          <p:nvPr/>
+        </p:nvSpPr>
+        <p:spPr>
+          <a:xfrm>
+            <a:off x="185420" y="242570"/>
+            <a:ext cx="1920719" cy="369332"/>
+          </a:xfrm>
+          <a:prstGeom prst="rect">
+            <a:avLst/>
+          </a:prstGeom>
+          <a:noFill/>
+        </p:spPr>
+        <p:txBody>
+          <a:bodyPr wrap="none" rtlCol="0">
+            <a:spAutoFit/>
+          </a:bodyPr>
+          <a:lstStyle/>
+          <a:p>
+            <a:r>
+              <a:rPr lang="en-US" altLang="zh-CN" b="1" dirty="0"/>
+              <a:t>Objects of Study</a:t>
+            </a:r>
+            <a:endParaRPr lang="zh-CN" altLang="en-US" b="1" dirty="0"/>
+          </a:p>
+        </p:txBody>
+      </p:sp>
+      <p:sp>
+        <p:nvSpPr>
+          <p:cNvPr id="5" name="文本框 4">
+            <a:extLst>
+              <a:ext uri="{FF2B5EF4-FFF2-40B4-BE49-F238E27FC236}">
+                <a16:creationId xmlns:a16="http://schemas.microsoft.com/office/drawing/2014/main" id="{1AF40700-C2F6-F9AE-3DEB-614A304FF6B7}"/>
+              </a:ext>
+            </a:extLst>
+          </p:cNvPr>
+          <p:cNvSpPr txBox="1"/>
+          <p:nvPr/>
+        </p:nvSpPr>
+        <p:spPr>
+          <a:xfrm>
+            <a:off x="2256904" y="6272879"/>
+            <a:ext cx="4725672" cy="261610"/>
+          </a:xfrm>
+          <a:prstGeom prst="rect">
+            <a:avLst/>
+          </a:prstGeom>
+          <a:noFill/>
+        </p:spPr>
+        <p:txBody>
+          <a:bodyPr wrap="square">
+            <a:spAutoFit/>
+          </a:bodyPr>
+          <a:lstStyle/>
+          <a:p>
+            <a:r>
+              <a:rPr lang="zh-CN" altLang="zh-CN" sz="1100" b="0" i="0" spc="29" dirty="0">
+                <a:solidFill>
+                  <a:schemeClr val="tx1"/>
+                </a:solidFill>
+                <a:effectLst/>
+                <a:latin typeface="+mn-lt"/>
+              </a:rPr>
+              <a:t>Source: </a:t>
+            </a:r>
+            <a:r>
+              <a:rPr lang="en-US" altLang="zh-CN" sz="1100" spc="29" dirty="0"/>
+              <a:t>https://www.animatornotebook.com/learn/quadrupeds-gaits</a:t>
+            </a:r>
+            <a:endParaRPr lang="zh-CN" altLang="en-US" sz="1100" dirty="0"/>
+          </a:p>
+        </p:txBody>
+      </p:sp>
+      <p:pic>
+        <p:nvPicPr>
+          <p:cNvPr id="6" name="图片 5" descr="Footfall_trot.png">
+            <a:extLst>
+              <a:ext uri="{FF2B5EF4-FFF2-40B4-BE49-F238E27FC236}">
+                <a16:creationId xmlns:a16="http://schemas.microsoft.com/office/drawing/2014/main" id="{89F51C2F-BAD1-BC3F-8B16-5FD8AB45BB6B}"/>
+              </a:ext>
+            </a:extLst>
+          </p:cNvPr>
+          <p:cNvPicPr>
+            <a:picLocks noChangeAspect="1"/>
+          </p:cNvPicPr>
+          <p:nvPr/>
+        </p:nvPicPr>
+        <p:blipFill>
+          <a:blip r:embed="rId2"/>
+          <a:stretch>
+            <a:fillRect/>
+          </a:stretch>
+        </p:blipFill>
+        <p:spPr>
+          <a:xfrm>
+            <a:off x="2106139" y="3244334"/>
+            <a:ext cx="7116339" cy="1779085"/>
+          </a:xfrm>
+          <a:prstGeom prst="rect">
+            <a:avLst/>
+          </a:prstGeom>
+        </p:spPr>
+      </p:pic>
+      <p:sp>
+        <p:nvSpPr>
+          <p:cNvPr id="11" name="文本框 10">
+            <a:extLst>
+              <a:ext uri="{FF2B5EF4-FFF2-40B4-BE49-F238E27FC236}">
+                <a16:creationId xmlns:a16="http://schemas.microsoft.com/office/drawing/2014/main" id="{73315462-AA9A-DD0B-0B05-5536ED00DC9C}"/>
+              </a:ext>
+            </a:extLst>
+          </p:cNvPr>
+          <p:cNvSpPr txBox="1"/>
+          <p:nvPr/>
+        </p:nvSpPr>
+        <p:spPr>
+          <a:xfrm>
+            <a:off x="185420" y="1072041"/>
+            <a:ext cx="2202847" cy="369332"/>
+          </a:xfrm>
+          <a:prstGeom prst="rect">
+            <a:avLst/>
+          </a:prstGeom>
+          <a:noFill/>
+        </p:spPr>
+        <p:txBody>
+          <a:bodyPr wrap="none" rtlCol="0">
+            <a:spAutoFit/>
+          </a:bodyPr>
+          <a:lstStyle/>
+          <a:p>
+            <a:r>
+              <a:rPr lang="en-US" altLang="zh-CN" dirty="0"/>
+              <a:t>Unitree Quadrupeds</a:t>
+            </a:r>
+            <a:endParaRPr lang="zh-CN" altLang="en-US" dirty="0"/>
+          </a:p>
+        </p:txBody>
+      </p:sp>
+      <p:sp>
+        <p:nvSpPr>
+          <p:cNvPr id="18" name="文本框 17">
+            <a:extLst>
+              <a:ext uri="{FF2B5EF4-FFF2-40B4-BE49-F238E27FC236}">
+                <a16:creationId xmlns:a16="http://schemas.microsoft.com/office/drawing/2014/main" id="{E721BFB4-AF62-96A6-FB34-861252DCDF41}"/>
+              </a:ext>
+            </a:extLst>
+          </p:cNvPr>
+          <p:cNvSpPr txBox="1"/>
+          <p:nvPr/>
+        </p:nvSpPr>
+        <p:spPr>
+          <a:xfrm>
+            <a:off x="185419" y="3059668"/>
+            <a:ext cx="974947" cy="369332"/>
+          </a:xfrm>
+          <a:prstGeom prst="rect">
+            <a:avLst/>
+          </a:prstGeom>
+          <a:noFill/>
+        </p:spPr>
+        <p:txBody>
+          <a:bodyPr wrap="none" rtlCol="0">
+            <a:spAutoFit/>
+          </a:bodyPr>
+          <a:lstStyle/>
+          <a:p>
+            <a:r>
+              <a:rPr lang="en-US" altLang="zh-CN" dirty="0"/>
+              <a:t>Trotting</a:t>
+            </a:r>
+            <a:endParaRPr lang="zh-CN" altLang="en-US" dirty="0"/>
+          </a:p>
+        </p:txBody>
+      </p:sp>
+      <p:pic>
+        <p:nvPicPr>
+          <p:cNvPr id="22" name="图片 21" descr="Robot Dog Go2_Quadruped_Robot Dog Company | Unitree Robotics">
+            <a:extLst>
+              <a:ext uri="{FF2B5EF4-FFF2-40B4-BE49-F238E27FC236}">
+                <a16:creationId xmlns:a16="http://schemas.microsoft.com/office/drawing/2014/main" id="{2AD90A7E-2D87-F67A-04A2-E136E892F3AF}"/>
+              </a:ext>
+            </a:extLst>
+          </p:cNvPr>
+          <p:cNvPicPr>
+            <a:picLocks noChangeAspect="1"/>
+          </p:cNvPicPr>
+          <p:nvPr/>
+        </p:nvPicPr>
+        <p:blipFill>
+          <a:blip r:embed="rId3"/>
+          <a:stretch>
+            <a:fillRect/>
+          </a:stretch>
+        </p:blipFill>
+        <p:spPr>
+          <a:xfrm>
+            <a:off x="2819124" y="647761"/>
+            <a:ext cx="2774722" cy="2292999"/>
+          </a:xfrm>
+          <a:prstGeom prst="rect">
+            <a:avLst/>
+          </a:prstGeom>
+        </p:spPr>
+      </p:pic>
+      <p:sp>
+        <p:nvSpPr>
+          <p:cNvPr id="26" name="文本框 25">
+            <a:extLst>
+              <a:ext uri="{FF2B5EF4-FFF2-40B4-BE49-F238E27FC236}">
+                <a16:creationId xmlns:a16="http://schemas.microsoft.com/office/drawing/2014/main" id="{2D175345-8F09-8D6B-BF11-3BD1EE7BBCAB}"/>
+              </a:ext>
+            </a:extLst>
+          </p:cNvPr>
+          <p:cNvSpPr txBox="1"/>
+          <p:nvPr/>
+        </p:nvSpPr>
+        <p:spPr>
+          <a:xfrm>
+            <a:off x="2256904" y="6464614"/>
+            <a:ext cx="2665730" cy="261610"/>
+          </a:xfrm>
+          <a:prstGeom prst="rect">
+            <a:avLst/>
+          </a:prstGeom>
+          <a:noFill/>
+        </p:spPr>
+        <p:txBody>
+          <a:bodyPr wrap="square">
+            <a:spAutoFit/>
+          </a:bodyPr>
+          <a:lstStyle/>
+          <a:p>
+            <a:r>
+              <a:rPr lang="zh-CN" altLang="zh-CN" sz="1100" b="0" i="0" spc="29" dirty="0">
+                <a:solidFill>
+                  <a:schemeClr val="tx1"/>
+                </a:solidFill>
+                <a:effectLst/>
+                <a:latin typeface="+mn-lt"/>
+              </a:rPr>
+              <a:t>Source: https://youtu.be/oyTKvsnbCcE</a:t>
+            </a:r>
+            <a:endParaRPr lang="zh-CN" altLang="en-US" sz="1100" dirty="0"/>
+          </a:p>
+        </p:txBody>
+      </p:sp>
+    </p:spTree>
+    <p:extLst>
+      <p:ext uri="{BB962C8B-B14F-4D97-AF65-F5344CB8AC3E}">
+        <p14:creationId xmlns:p14="http://schemas.microsoft.com/office/powerpoint/2010/main" val="3003723000"/>
+      </p:ext>
+    </p:extLst>
+  </p:cSld>
+  <p:clrMapOvr>
+    <a:masterClrMapping/>
+  </p:clrMapOvr>
+</p:sld>
+</file>
+
+<file path=ppt/slides/slide3.xml><?xml version="1.0" encoding="utf-8"?>
+<p:sld xmlns:a="http://schemas.openxmlformats.org/drawingml/2006/main" xmlns:r="http://schemas.openxmlformats.org/officeDocument/2006/relationships" xmlns:p="http://schemas.openxmlformats.org/presentationml/2006/main">
+  <p:cSld>
+    <p:spTree>
+      <p:nvGrpSpPr>
+        <p:cNvPr id="1" name="">
+          <a:extLst>
+            <a:ext uri="{FF2B5EF4-FFF2-40B4-BE49-F238E27FC236}">
+              <a16:creationId xmlns:a16="http://schemas.microsoft.com/office/drawing/2014/main" id="{2EB8CD01-6E52-268E-24A9-CB21FE039064}"/>
+            </a:ext>
+          </a:extLst>
+        </p:cNvPr>
+        <p:cNvGrpSpPr/>
+        <p:nvPr/>
+      </p:nvGrpSpPr>
+      <p:grpSpPr>
+        <a:xfrm>
+          <a:off x="0" y="0"/>
+          <a:ext cx="0" cy="0"/>
+          <a:chOff x="0" y="0"/>
+          <a:chExt cx="0" cy="0"/>
+        </a:xfrm>
+      </p:grpSpPr>
+      <p:sp>
+        <p:nvSpPr>
+          <p:cNvPr id="9" name="文本框 8">
+            <a:extLst>
+              <a:ext uri="{FF2B5EF4-FFF2-40B4-BE49-F238E27FC236}">
+                <a16:creationId xmlns:a16="http://schemas.microsoft.com/office/drawing/2014/main" id="{43D29835-F18E-1D3F-588A-7A0725C121E6}"/>
+              </a:ext>
+            </a:extLst>
+          </p:cNvPr>
+          <p:cNvSpPr txBox="1"/>
+          <p:nvPr/>
+        </p:nvSpPr>
+        <p:spPr>
+          <a:xfrm>
+            <a:off x="185420" y="242570"/>
+            <a:ext cx="1334020" cy="369332"/>
+          </a:xfrm>
+          <a:prstGeom prst="rect">
+            <a:avLst/>
+          </a:prstGeom>
+          <a:noFill/>
+        </p:spPr>
+        <p:txBody>
+          <a:bodyPr wrap="none" rtlCol="0">
+            <a:spAutoFit/>
+          </a:bodyPr>
+          <a:lstStyle/>
+          <a:p>
+            <a:r>
+              <a:rPr lang="en-US" altLang="zh-CN" b="1" dirty="0"/>
+              <a:t>Motivation</a:t>
+            </a:r>
+            <a:endParaRPr lang="zh-CN" altLang="en-US" b="1" dirty="0"/>
+          </a:p>
+        </p:txBody>
+      </p:sp>
+      <p:sp>
+        <p:nvSpPr>
+          <p:cNvPr id="20" name="矩形 19">
+            <a:extLst>
+              <a:ext uri="{FF2B5EF4-FFF2-40B4-BE49-F238E27FC236}">
+                <a16:creationId xmlns:a16="http://schemas.microsoft.com/office/drawing/2014/main" id="{9832BE07-5A66-0581-A71F-EADC33FDE762}"/>
+              </a:ext>
+            </a:extLst>
+          </p:cNvPr>
+          <p:cNvSpPr/>
+          <p:nvPr/>
+        </p:nvSpPr>
+        <p:spPr>
+          <a:xfrm>
+            <a:off x="4557624" y="1173819"/>
+            <a:ext cx="1510240" cy="800100"/>
+          </a:xfrm>
+          <a:prstGeom prst="rect">
+            <a:avLst/>
+          </a:prstGeom>
+        </p:spPr>
+        <p:style>
+          <a:lnRef idx="2">
+            <a:schemeClr val="accent1">
+              <a:shade val="15000"/>
+            </a:schemeClr>
+          </a:lnRef>
+          <a:fillRef idx="1">
+            <a:schemeClr val="accent1"/>
+          </a:fillRef>
+          <a:effectRef idx="0">
+            <a:schemeClr val="accent1"/>
+          </a:effectRef>
+          <a:fontRef idx="minor">
+            <a:schemeClr val="lt1"/>
+          </a:fontRef>
+        </p:style>
+        <p:txBody>
+          <a:bodyPr rtlCol="0" anchor="ctr"/>
+          <a:lstStyle/>
+          <a:p>
+            <a:pPr algn="ctr"/>
+            <a:r>
+              <a:rPr lang="en-US" altLang="zh-CN" dirty="0"/>
+              <a:t>Body motion planner</a:t>
+            </a:r>
+            <a:endParaRPr lang="zh-CN" altLang="en-US" dirty="0"/>
+          </a:p>
+        </p:txBody>
+      </p:sp>
+      <p:sp>
+        <p:nvSpPr>
+          <p:cNvPr id="21" name="文本框 20">
+            <a:extLst>
+              <a:ext uri="{FF2B5EF4-FFF2-40B4-BE49-F238E27FC236}">
+                <a16:creationId xmlns:a16="http://schemas.microsoft.com/office/drawing/2014/main" id="{C5D74C8B-5BB0-0B11-D391-525287ECDDC4}"/>
+              </a:ext>
+            </a:extLst>
+          </p:cNvPr>
+          <p:cNvSpPr txBox="1"/>
+          <p:nvPr/>
+        </p:nvSpPr>
+        <p:spPr>
+          <a:xfrm>
+            <a:off x="2887194" y="346627"/>
+            <a:ext cx="5617831" cy="646331"/>
+          </a:xfrm>
+          <a:prstGeom prst="rect">
+            <a:avLst/>
+          </a:prstGeom>
+          <a:noFill/>
+        </p:spPr>
+        <p:txBody>
+          <a:bodyPr wrap="square" rtlCol="0">
+            <a:spAutoFit/>
+          </a:bodyPr>
+          <a:lstStyle/>
+          <a:p>
+            <a:r>
+              <a:rPr lang="en-US" altLang="zh-CN" dirty="0"/>
+              <a:t>Simplify</a:t>
+            </a:r>
+            <a:r>
+              <a:rPr lang="zh-CN" altLang="en-US" dirty="0"/>
+              <a:t> </a:t>
+            </a:r>
+            <a:r>
+              <a:rPr lang="en-US" altLang="zh-CN" dirty="0"/>
+              <a:t>torso motion as unconstrained single rigid-body motion subject to ground force from </a:t>
+            </a:r>
+            <a:r>
+              <a:rPr lang="en-US" altLang="zh-CN" b="1" dirty="0"/>
+              <a:t>stance leg</a:t>
+            </a:r>
+            <a:endParaRPr lang="zh-CN" altLang="en-US" b="1" dirty="0"/>
+          </a:p>
+        </p:txBody>
+      </p:sp>
+      <p:sp>
+        <p:nvSpPr>
+          <p:cNvPr id="23" name="矩形 22">
+            <a:extLst>
+              <a:ext uri="{FF2B5EF4-FFF2-40B4-BE49-F238E27FC236}">
+                <a16:creationId xmlns:a16="http://schemas.microsoft.com/office/drawing/2014/main" id="{9ED70FA2-F724-55A9-95AA-F3C56B57F2EE}"/>
+              </a:ext>
+            </a:extLst>
+          </p:cNvPr>
+          <p:cNvSpPr/>
+          <p:nvPr/>
+        </p:nvSpPr>
+        <p:spPr>
+          <a:xfrm>
+            <a:off x="1480646" y="3362526"/>
+            <a:ext cx="1350733" cy="800100"/>
+          </a:xfrm>
+          <a:prstGeom prst="rect">
+            <a:avLst/>
+          </a:prstGeom>
+        </p:spPr>
+        <p:style>
+          <a:lnRef idx="2">
+            <a:schemeClr val="accent1">
+              <a:shade val="15000"/>
+            </a:schemeClr>
+          </a:lnRef>
+          <a:fillRef idx="1">
+            <a:schemeClr val="accent1"/>
+          </a:fillRef>
+          <a:effectRef idx="0">
+            <a:schemeClr val="accent1"/>
+          </a:effectRef>
+          <a:fontRef idx="minor">
+            <a:schemeClr val="lt1"/>
+          </a:fontRef>
+        </p:style>
+        <p:txBody>
+          <a:bodyPr rtlCol="0" anchor="ctr"/>
+          <a:lstStyle/>
+          <a:p>
+            <a:pPr algn="ctr"/>
+            <a:r>
+              <a:rPr lang="en-US" altLang="zh-CN" dirty="0"/>
+              <a:t>Gait Scheduler</a:t>
+            </a:r>
+            <a:endParaRPr lang="zh-CN" altLang="en-US" dirty="0"/>
+          </a:p>
+        </p:txBody>
+      </p:sp>
+      <p:sp>
+        <p:nvSpPr>
+          <p:cNvPr id="25" name="文本框 24">
+            <a:extLst>
+              <a:ext uri="{FF2B5EF4-FFF2-40B4-BE49-F238E27FC236}">
+                <a16:creationId xmlns:a16="http://schemas.microsoft.com/office/drawing/2014/main" id="{0F4363BB-9E55-E595-266A-B552F3DD23D5}"/>
+              </a:ext>
+            </a:extLst>
+          </p:cNvPr>
+          <p:cNvSpPr txBox="1"/>
+          <p:nvPr/>
+        </p:nvSpPr>
+        <p:spPr>
+          <a:xfrm>
+            <a:off x="2652112" y="3516295"/>
+            <a:ext cx="3612776" cy="646331"/>
+          </a:xfrm>
+          <a:prstGeom prst="rect">
+            <a:avLst/>
+          </a:prstGeom>
+          <a:noFill/>
+        </p:spPr>
+        <p:txBody>
+          <a:bodyPr wrap="square" rtlCol="0">
+            <a:spAutoFit/>
+          </a:bodyPr>
+          <a:lstStyle/>
+          <a:p>
+            <a:pPr algn="ctr"/>
+            <a:r>
+              <a:rPr lang="en-US" altLang="zh-CN" dirty="0"/>
+              <a:t>Stance/swing phase planning</a:t>
+            </a:r>
+          </a:p>
+          <a:p>
+            <a:pPr algn="ctr"/>
+            <a:r>
+              <a:rPr lang="en-US" altLang="zh-CN" dirty="0"/>
+              <a:t>+ foot trajectory</a:t>
+            </a:r>
+            <a:endParaRPr lang="zh-CN" altLang="en-US" dirty="0"/>
+          </a:p>
+        </p:txBody>
+      </p:sp>
+      <p:sp>
+        <p:nvSpPr>
+          <p:cNvPr id="27" name="矩形 26">
+            <a:extLst>
+              <a:ext uri="{FF2B5EF4-FFF2-40B4-BE49-F238E27FC236}">
+                <a16:creationId xmlns:a16="http://schemas.microsoft.com/office/drawing/2014/main" id="{B90D5D96-BA03-55BD-AEA5-8718437EAA13}"/>
+              </a:ext>
+            </a:extLst>
+          </p:cNvPr>
+          <p:cNvSpPr/>
+          <p:nvPr/>
+        </p:nvSpPr>
+        <p:spPr>
+          <a:xfrm>
+            <a:off x="4637378" y="5240985"/>
+            <a:ext cx="1350733" cy="800100"/>
+          </a:xfrm>
+          <a:prstGeom prst="rect">
+            <a:avLst/>
+          </a:prstGeom>
+        </p:spPr>
+        <p:style>
+          <a:lnRef idx="2">
+            <a:schemeClr val="accent1">
+              <a:shade val="15000"/>
+            </a:schemeClr>
+          </a:lnRef>
+          <a:fillRef idx="1">
+            <a:schemeClr val="accent1"/>
+          </a:fillRef>
+          <a:effectRef idx="0">
+            <a:schemeClr val="accent1"/>
+          </a:effectRef>
+          <a:fontRef idx="minor">
+            <a:schemeClr val="lt1"/>
+          </a:fontRef>
+        </p:style>
+        <p:txBody>
+          <a:bodyPr rtlCol="0" anchor="ctr"/>
+          <a:lstStyle/>
+          <a:p>
+            <a:pPr algn="ctr"/>
+            <a:r>
+              <a:rPr lang="en-US" altLang="zh-CN" dirty="0"/>
+              <a:t>Joint</a:t>
+            </a:r>
+          </a:p>
+          <a:p>
+            <a:pPr algn="ctr"/>
+            <a:r>
+              <a:rPr lang="en-US" altLang="zh-CN" dirty="0"/>
+              <a:t>Controller</a:t>
+            </a:r>
+            <a:endParaRPr lang="zh-CN" altLang="en-US" dirty="0"/>
+          </a:p>
+        </p:txBody>
+      </p:sp>
+      <p:sp>
+        <p:nvSpPr>
+          <p:cNvPr id="29" name="文本框 28">
+            <a:extLst>
+              <a:ext uri="{FF2B5EF4-FFF2-40B4-BE49-F238E27FC236}">
+                <a16:creationId xmlns:a16="http://schemas.microsoft.com/office/drawing/2014/main" id="{BB91C4FE-4356-6A08-0A8F-02958EEBDABB}"/>
+              </a:ext>
+            </a:extLst>
+          </p:cNvPr>
+          <p:cNvSpPr txBox="1"/>
+          <p:nvPr/>
+        </p:nvSpPr>
+        <p:spPr>
+          <a:xfrm>
+            <a:off x="3591337" y="6105145"/>
+            <a:ext cx="3576620" cy="369332"/>
+          </a:xfrm>
+          <a:prstGeom prst="rect">
+            <a:avLst/>
+          </a:prstGeom>
+          <a:noFill/>
+        </p:spPr>
+        <p:txBody>
+          <a:bodyPr wrap="none" rtlCol="0">
+            <a:spAutoFit/>
+          </a:bodyPr>
+          <a:lstStyle/>
+          <a:p>
+            <a:pPr algn="ctr"/>
+            <a:r>
+              <a:rPr lang="en-US" altLang="zh-CN" dirty="0"/>
+              <a:t> Inverse dynamics + PD controller</a:t>
+            </a:r>
+            <a:endParaRPr lang="zh-CN" altLang="en-US" dirty="0"/>
+          </a:p>
+        </p:txBody>
+      </p:sp>
+      <mc:AlternateContent xmlns:mc="http://schemas.openxmlformats.org/markup-compatibility/2006">
+        <mc:Choice xmlns:a14="http://schemas.microsoft.com/office/drawing/2010/main" Requires="a14">
+          <p:sp>
+            <p:nvSpPr>
+              <p:cNvPr id="31" name="文本框 30">
+                <a:extLst>
+                  <a:ext uri="{FF2B5EF4-FFF2-40B4-BE49-F238E27FC236}">
+                    <a16:creationId xmlns:a16="http://schemas.microsoft.com/office/drawing/2014/main" id="{4807A9D6-AD80-77A9-09BC-AA019B7982B1}"/>
+                  </a:ext>
+                </a:extLst>
+              </p:cNvPr>
+              <p:cNvSpPr txBox="1"/>
+              <p:nvPr/>
+            </p:nvSpPr>
+            <p:spPr>
+              <a:xfrm>
+                <a:off x="2966722" y="4652262"/>
+                <a:ext cx="409023" cy="518604"/>
+              </a:xfrm>
+              <a:prstGeom prst="rect">
+                <a:avLst/>
+              </a:prstGeom>
+              <a:noFill/>
+            </p:spPr>
+            <p:txBody>
+              <a:bodyPr wrap="none" lIns="0" tIns="0" rIns="0" bIns="0" rtlCol="0">
+                <a:spAutoFit/>
+              </a:bodyPr>
+              <a:lstStyle/>
+              <a:p>
+                <a:pPr/>
+                <a14:m>
+                  <m:oMathPara xmlns:m="http://schemas.openxmlformats.org/officeDocument/2006/math">
+                    <m:oMath>
+                      <m:r>
+                        <a:rPr lang="en-US" altLang="zh-CN" b="0" i="1" smtClean="0">
+                          <a:latin typeface="Cambria Math" panose="02040503050406030204" pitchFamily="18" charset="0"/>
+                        </a:rPr>
+                        <m:t>~</m:t>
+                      </m:r>
+                      <m:f>
+                        <m:fPr>
+                          <m:ctrlPr>
+                            <a:rPr lang="en-US" altLang="zh-CN" b="0" i="1" smtClean="0">
+                              <a:latin typeface="Cambria Math" panose="02040503050406030204" pitchFamily="18" charset="0"/>
+                            </a:rPr>
+                          </m:ctrlPr>
+                        </m:fPr>
+                        <m:num>
+                          <m:r>
+                            <a:rPr lang="en-US" altLang="zh-CN" b="0" i="1" smtClean="0">
+                              <a:latin typeface="Cambria Math" panose="02040503050406030204" pitchFamily="18" charset="0"/>
+                            </a:rPr>
+                            <m:t>1</m:t>
+                          </m:r>
+                        </m:num>
+                        <m:den>
+                          <m:r>
+                            <a:rPr lang="en-US" altLang="zh-CN" b="0" i="1" smtClean="0">
+                              <a:latin typeface="Cambria Math" panose="02040503050406030204" pitchFamily="18" charset="0"/>
+                            </a:rPr>
+                            <m:t>𝑇</m:t>
+                          </m:r>
+                        </m:den>
+                      </m:f>
+                    </m:oMath>
+                  </m:oMathPara>
+                </a14:m>
+                <a:endParaRPr lang="zh-CN" altLang="en-US" dirty="0"/>
+              </a:p>
+            </p:txBody>
+          </p:sp>
+        </mc:Choice>
+        <mc:Fallback>
+          <p:sp>
+            <p:nvSpPr>
+              <p:cNvPr id="31" name="文本框 30">
+                <a:extLst>
+                  <a:ext uri="{FF2B5EF4-FFF2-40B4-BE49-F238E27FC236}">
+                    <a16:creationId xmlns:a16="http://schemas.microsoft.com/office/drawing/2014/main" id="{4807A9D6-AD80-77A9-09BC-AA019B7982B1}"/>
+                  </a:ext>
+                </a:extLst>
+              </p:cNvPr>
+              <p:cNvSpPr txBox="1">
+                <a:spLocks noRot="1" noChangeAspect="1" noMove="1" noResize="1" noEditPoints="1" noAdjustHandles="1" noChangeArrowheads="1" noChangeShapeType="1" noTextEdit="1"/>
+              </p:cNvSpPr>
+              <p:nvPr/>
+            </p:nvSpPr>
+            <p:spPr>
+              <a:xfrm>
+                <a:off x="2966722" y="4652262"/>
+                <a:ext cx="409023" cy="518604"/>
+              </a:xfrm>
+              <a:prstGeom prst="rect">
+                <a:avLst/>
+              </a:prstGeom>
+              <a:blipFill>
+                <a:blip r:embed="rId2"/>
+                <a:stretch>
+                  <a:fillRect/>
+                </a:stretch>
+              </a:blipFill>
+            </p:spPr>
+            <p:txBody>
+              <a:bodyPr/>
+              <a:lstStyle/>
+              <a:p>
+                <a:r>
+                  <a:rPr lang="zh-CN" altLang="en-US">
+                    <a:noFill/>
+                  </a:rPr>
+                  <a:t> </a:t>
+                </a:r>
+              </a:p>
+            </p:txBody>
+          </p:sp>
+        </mc:Fallback>
+      </mc:AlternateContent>
+      <mc:AlternateContent xmlns:mc="http://schemas.openxmlformats.org/markup-compatibility/2006">
+        <mc:Choice xmlns:a14="http://schemas.microsoft.com/office/drawing/2010/main" Requires="a14">
+          <p:sp>
+            <p:nvSpPr>
+              <p:cNvPr id="33" name="文本框 32">
+                <a:extLst>
+                  <a:ext uri="{FF2B5EF4-FFF2-40B4-BE49-F238E27FC236}">
+                    <a16:creationId xmlns:a16="http://schemas.microsoft.com/office/drawing/2014/main" id="{5E9375DD-D899-8578-0FD3-EC4A1E12F096}"/>
+                  </a:ext>
+                </a:extLst>
+              </p:cNvPr>
+              <p:cNvSpPr txBox="1"/>
+              <p:nvPr/>
+            </p:nvSpPr>
+            <p:spPr>
+              <a:xfrm>
+                <a:off x="2933150" y="2264696"/>
+                <a:ext cx="768608" cy="276999"/>
+              </a:xfrm>
+              <a:prstGeom prst="rect">
+                <a:avLst/>
+              </a:prstGeom>
+              <a:noFill/>
+            </p:spPr>
+            <p:txBody>
+              <a:bodyPr wrap="none" lIns="0" tIns="0" rIns="0" bIns="0" rtlCol="0">
+                <a:spAutoFit/>
+              </a:bodyPr>
+              <a:lstStyle/>
+              <a:p>
+                <a:pPr/>
+                <a14:m>
+                  <m:oMathPara xmlns:m="http://schemas.openxmlformats.org/officeDocument/2006/math">
+                    <m:oMath>
+                      <m:r>
+                        <a:rPr lang="en-US" altLang="zh-CN" b="0" i="1" smtClean="0">
+                          <a:latin typeface="Cambria Math" panose="02040503050406030204" pitchFamily="18" charset="0"/>
+                        </a:rPr>
+                        <m:t>~</m:t>
+                      </m:r>
+                      <m:r>
+                        <a:rPr lang="en-US" altLang="zh-CN" i="1" smtClean="0">
+                          <a:latin typeface="Cambria Math" panose="02040503050406030204" pitchFamily="18" charset="0"/>
+                        </a:rPr>
+                        <m:t>5</m:t>
+                      </m:r>
+                      <m:r>
+                        <a:rPr lang="en-US" altLang="zh-CN" b="0" i="1" smtClean="0">
+                          <a:latin typeface="Cambria Math" panose="02040503050406030204" pitchFamily="18" charset="0"/>
+                        </a:rPr>
+                        <m:t>0</m:t>
+                      </m:r>
+                      <m:r>
+                        <a:rPr lang="en-US" altLang="zh-CN" b="0" i="1" smtClean="0">
+                          <a:latin typeface="Cambria Math" panose="02040503050406030204" pitchFamily="18" charset="0"/>
+                        </a:rPr>
+                        <m:t>𝐻𝑧</m:t>
+                      </m:r>
+                    </m:oMath>
+                  </m:oMathPara>
+                </a14:m>
+                <a:endParaRPr lang="zh-CN" altLang="en-US" dirty="0"/>
+              </a:p>
+            </p:txBody>
+          </p:sp>
+        </mc:Choice>
+        <mc:Fallback>
+          <p:sp>
+            <p:nvSpPr>
+              <p:cNvPr id="33" name="文本框 32">
+                <a:extLst>
+                  <a:ext uri="{FF2B5EF4-FFF2-40B4-BE49-F238E27FC236}">
+                    <a16:creationId xmlns:a16="http://schemas.microsoft.com/office/drawing/2014/main" id="{5E9375DD-D899-8578-0FD3-EC4A1E12F096}"/>
+                  </a:ext>
+                </a:extLst>
+              </p:cNvPr>
+              <p:cNvSpPr txBox="1">
+                <a:spLocks noRot="1" noChangeAspect="1" noMove="1" noResize="1" noEditPoints="1" noAdjustHandles="1" noChangeArrowheads="1" noChangeShapeType="1" noTextEdit="1"/>
+              </p:cNvSpPr>
+              <p:nvPr/>
+            </p:nvSpPr>
+            <p:spPr>
+              <a:xfrm>
+                <a:off x="2933150" y="2264696"/>
+                <a:ext cx="768608" cy="276999"/>
+              </a:xfrm>
+              <a:prstGeom prst="rect">
+                <a:avLst/>
+              </a:prstGeom>
+              <a:blipFill>
+                <a:blip r:embed="rId3"/>
+                <a:stretch>
+                  <a:fillRect l="-794" r="-7143" b="-8889"/>
+                </a:stretch>
+              </a:blipFill>
+            </p:spPr>
+            <p:txBody>
+              <a:bodyPr/>
+              <a:lstStyle/>
+              <a:p>
+                <a:r>
+                  <a:rPr lang="zh-CN" altLang="en-US">
+                    <a:noFill/>
+                  </a:rPr>
+                  <a:t> </a:t>
+                </a:r>
+              </a:p>
+            </p:txBody>
+          </p:sp>
+        </mc:Fallback>
+      </mc:AlternateContent>
+      <mc:AlternateContent xmlns:mc="http://schemas.openxmlformats.org/markup-compatibility/2006">
+        <mc:Choice xmlns:a14="http://schemas.microsoft.com/office/drawing/2010/main" Requires="a14">
+          <p:sp>
+            <p:nvSpPr>
+              <p:cNvPr id="35" name="文本框 34">
+                <a:extLst>
+                  <a:ext uri="{FF2B5EF4-FFF2-40B4-BE49-F238E27FC236}">
+                    <a16:creationId xmlns:a16="http://schemas.microsoft.com/office/drawing/2014/main" id="{B2078818-B8FA-030B-5F65-42BFF43ED899}"/>
+                  </a:ext>
+                </a:extLst>
+              </p:cNvPr>
+              <p:cNvSpPr txBox="1"/>
+              <p:nvPr/>
+            </p:nvSpPr>
+            <p:spPr>
+              <a:xfrm>
+                <a:off x="6856198" y="4888008"/>
+                <a:ext cx="767005" cy="276999"/>
+              </a:xfrm>
+              <a:prstGeom prst="rect">
+                <a:avLst/>
+              </a:prstGeom>
+              <a:noFill/>
+            </p:spPr>
+            <p:txBody>
+              <a:bodyPr wrap="none" lIns="0" tIns="0" rIns="0" bIns="0" rtlCol="0">
+                <a:spAutoFit/>
+              </a:bodyPr>
+              <a:lstStyle/>
+              <a:p>
+                <a:pPr/>
+                <a14:m>
+                  <m:oMathPara xmlns:m="http://schemas.openxmlformats.org/officeDocument/2006/math">
+                    <m:oMath>
+                      <m:r>
+                        <a:rPr lang="en-US" altLang="zh-CN" b="0" i="1" smtClean="0">
+                          <a:latin typeface="Cambria Math" panose="02040503050406030204" pitchFamily="18" charset="0"/>
+                        </a:rPr>
+                        <m:t>~</m:t>
+                      </m:r>
+                      <m:r>
+                        <a:rPr lang="en-US" altLang="zh-CN" i="1" smtClean="0">
+                          <a:latin typeface="Cambria Math" panose="02040503050406030204" pitchFamily="18" charset="0"/>
+                        </a:rPr>
+                        <m:t>1</m:t>
+                      </m:r>
+                      <m:r>
+                        <a:rPr lang="en-US" altLang="zh-CN" b="0" i="1" smtClean="0">
+                          <a:latin typeface="Cambria Math" panose="02040503050406030204" pitchFamily="18" charset="0"/>
+                        </a:rPr>
+                        <m:t>𝑘𝐻𝑧</m:t>
+                      </m:r>
+                    </m:oMath>
+                  </m:oMathPara>
+                </a14:m>
+                <a:endParaRPr lang="zh-CN" altLang="en-US" dirty="0"/>
+              </a:p>
+            </p:txBody>
+          </p:sp>
+        </mc:Choice>
+        <mc:Fallback>
+          <p:sp>
+            <p:nvSpPr>
+              <p:cNvPr id="35" name="文本框 34">
+                <a:extLst>
+                  <a:ext uri="{FF2B5EF4-FFF2-40B4-BE49-F238E27FC236}">
+                    <a16:creationId xmlns:a16="http://schemas.microsoft.com/office/drawing/2014/main" id="{B2078818-B8FA-030B-5F65-42BFF43ED899}"/>
+                  </a:ext>
+                </a:extLst>
+              </p:cNvPr>
+              <p:cNvSpPr txBox="1">
+                <a:spLocks noRot="1" noChangeAspect="1" noMove="1" noResize="1" noEditPoints="1" noAdjustHandles="1" noChangeArrowheads="1" noChangeShapeType="1" noTextEdit="1"/>
+              </p:cNvSpPr>
+              <p:nvPr/>
+            </p:nvSpPr>
+            <p:spPr>
+              <a:xfrm>
+                <a:off x="6856198" y="4888008"/>
+                <a:ext cx="767005" cy="276999"/>
+              </a:xfrm>
+              <a:prstGeom prst="rect">
+                <a:avLst/>
+              </a:prstGeom>
+              <a:blipFill>
+                <a:blip r:embed="rId4"/>
+                <a:stretch>
+                  <a:fillRect l="-1587" r="-6349" b="-8889"/>
+                </a:stretch>
+              </a:blipFill>
+            </p:spPr>
+            <p:txBody>
+              <a:bodyPr/>
+              <a:lstStyle/>
+              <a:p>
+                <a:r>
+                  <a:rPr lang="zh-CN" altLang="en-US">
+                    <a:noFill/>
+                  </a:rPr>
+                  <a:t> </a:t>
+                </a:r>
+              </a:p>
+            </p:txBody>
+          </p:sp>
+        </mc:Fallback>
+      </mc:AlternateContent>
+      <p:sp>
+        <p:nvSpPr>
+          <p:cNvPr id="11" name="弧形 10">
+            <a:extLst>
+              <a:ext uri="{FF2B5EF4-FFF2-40B4-BE49-F238E27FC236}">
+                <a16:creationId xmlns:a16="http://schemas.microsoft.com/office/drawing/2014/main" id="{2F232A10-4D60-5B3E-68BF-2B0CA64C33F4}"/>
+              </a:ext>
+            </a:extLst>
+          </p:cNvPr>
+          <p:cNvSpPr/>
+          <p:nvPr/>
+        </p:nvSpPr>
+        <p:spPr>
+          <a:xfrm>
+            <a:off x="2187389" y="1601017"/>
+            <a:ext cx="6873375" cy="3343724"/>
+          </a:xfrm>
+          <a:prstGeom prst="arc">
+            <a:avLst>
+              <a:gd name="adj1" fmla="val 11021206"/>
+              <a:gd name="adj2" fmla="val 13552831"/>
+            </a:avLst>
+          </a:prstGeom>
+          <a:ln>
+            <a:headEnd type="triangle" w="med" len="med"/>
+            <a:tailEnd type="none" w="med" len="med"/>
+          </a:ln>
+        </p:spPr>
+        <p:style>
+          <a:lnRef idx="2">
+            <a:schemeClr val="accent1"/>
+          </a:lnRef>
+          <a:fillRef idx="0">
+            <a:schemeClr val="accent1"/>
+          </a:fillRef>
+          <a:effectRef idx="1">
+            <a:schemeClr val="accent1"/>
+          </a:effectRef>
+          <a:fontRef idx="minor">
+            <a:schemeClr val="tx1"/>
+          </a:fontRef>
+        </p:style>
+        <p:txBody>
+          <a:bodyPr rtlCol="0" anchor="ctr"/>
+          <a:lstStyle/>
+          <a:p>
+            <a:pPr algn="ctr"/>
+            <a:endParaRPr lang="zh-CN" altLang="en-US"/>
+          </a:p>
+        </p:txBody>
+      </p:sp>
+      <p:sp>
+        <p:nvSpPr>
+          <p:cNvPr id="4" name="文本框 3">
+            <a:extLst>
+              <a:ext uri="{FF2B5EF4-FFF2-40B4-BE49-F238E27FC236}">
+                <a16:creationId xmlns:a16="http://schemas.microsoft.com/office/drawing/2014/main" id="{A5A99423-8671-8E1C-5344-BDDF3DBF92C2}"/>
+              </a:ext>
+            </a:extLst>
+          </p:cNvPr>
+          <p:cNvSpPr txBox="1"/>
+          <p:nvPr/>
+        </p:nvSpPr>
+        <p:spPr>
+          <a:xfrm>
+            <a:off x="1101217" y="2109515"/>
+            <a:ext cx="1707895" cy="646331"/>
+          </a:xfrm>
+          <a:prstGeom prst="rect">
+            <a:avLst/>
+          </a:prstGeom>
+          <a:noFill/>
+        </p:spPr>
+        <p:txBody>
+          <a:bodyPr wrap="square" rtlCol="0">
+            <a:spAutoFit/>
+          </a:bodyPr>
+          <a:lstStyle/>
+          <a:p>
+            <a:r>
+              <a:rPr lang="en-US" altLang="zh-CN" dirty="0"/>
+              <a:t>Planned torso velocity</a:t>
+            </a:r>
+            <a:endParaRPr lang="zh-CN" altLang="en-US" dirty="0"/>
+          </a:p>
+        </p:txBody>
+      </p:sp>
+      <p:sp>
+        <p:nvSpPr>
+          <p:cNvPr id="6" name="弧形 5">
+            <a:extLst>
+              <a:ext uri="{FF2B5EF4-FFF2-40B4-BE49-F238E27FC236}">
+                <a16:creationId xmlns:a16="http://schemas.microsoft.com/office/drawing/2014/main" id="{75AEC6DA-3ABC-0443-8C3C-FDB488920197}"/>
+              </a:ext>
+            </a:extLst>
+          </p:cNvPr>
+          <p:cNvSpPr/>
+          <p:nvPr/>
+        </p:nvSpPr>
+        <p:spPr>
+          <a:xfrm>
+            <a:off x="2063351" y="2335640"/>
+            <a:ext cx="6873375" cy="3343724"/>
+          </a:xfrm>
+          <a:prstGeom prst="arc">
+            <a:avLst>
+              <a:gd name="adj1" fmla="val 7517971"/>
+              <a:gd name="adj2" fmla="val 10470346"/>
+            </a:avLst>
+          </a:prstGeom>
+          <a:ln>
+            <a:headEnd type="triangle" w="med" len="med"/>
+            <a:tailEnd type="none" w="med" len="med"/>
+          </a:ln>
+        </p:spPr>
+        <p:style>
+          <a:lnRef idx="2">
+            <a:schemeClr val="accent1"/>
+          </a:lnRef>
+          <a:fillRef idx="0">
+            <a:schemeClr val="accent1"/>
+          </a:fillRef>
+          <a:effectRef idx="1">
+            <a:schemeClr val="accent1"/>
+          </a:effectRef>
+          <a:fontRef idx="minor">
+            <a:schemeClr val="tx1"/>
+          </a:fontRef>
+        </p:style>
+        <p:txBody>
+          <a:bodyPr rtlCol="0" anchor="ctr"/>
+          <a:lstStyle/>
+          <a:p>
+            <a:pPr algn="ctr"/>
+            <a:endParaRPr lang="zh-CN" altLang="en-US"/>
+          </a:p>
+        </p:txBody>
+      </p:sp>
+      <p:sp>
+        <p:nvSpPr>
+          <p:cNvPr id="8" name="文本框 7">
+            <a:extLst>
+              <a:ext uri="{FF2B5EF4-FFF2-40B4-BE49-F238E27FC236}">
+                <a16:creationId xmlns:a16="http://schemas.microsoft.com/office/drawing/2014/main" id="{B216C0BE-8A78-B22D-B8AC-DEDE41BA14BC}"/>
+              </a:ext>
+            </a:extLst>
+          </p:cNvPr>
+          <p:cNvSpPr txBox="1"/>
+          <p:nvPr/>
+        </p:nvSpPr>
+        <p:spPr>
+          <a:xfrm>
+            <a:off x="1463338" y="5212325"/>
+            <a:ext cx="1707895" cy="369332"/>
+          </a:xfrm>
+          <a:prstGeom prst="rect">
+            <a:avLst/>
+          </a:prstGeom>
+          <a:noFill/>
+        </p:spPr>
+        <p:txBody>
+          <a:bodyPr wrap="square" rtlCol="0">
+            <a:spAutoFit/>
+          </a:bodyPr>
+          <a:lstStyle/>
+          <a:p>
+            <a:r>
+              <a:rPr lang="en-US" altLang="zh-CN" dirty="0"/>
+              <a:t>Foot trajectory</a:t>
+            </a:r>
+            <a:endParaRPr lang="zh-CN" altLang="en-US" dirty="0"/>
+          </a:p>
+        </p:txBody>
+      </p:sp>
+      <p:sp>
+        <p:nvSpPr>
+          <p:cNvPr id="18" name="矩形 17">
+            <a:extLst>
+              <a:ext uri="{FF2B5EF4-FFF2-40B4-BE49-F238E27FC236}">
+                <a16:creationId xmlns:a16="http://schemas.microsoft.com/office/drawing/2014/main" id="{0FD798EC-88F5-4194-216E-5640EE412FF5}"/>
+              </a:ext>
+            </a:extLst>
+          </p:cNvPr>
+          <p:cNvSpPr/>
+          <p:nvPr/>
+        </p:nvSpPr>
+        <p:spPr>
+          <a:xfrm>
+            <a:off x="7834069" y="3362526"/>
+            <a:ext cx="1350733" cy="800100"/>
+          </a:xfrm>
+          <a:prstGeom prst="rect">
+            <a:avLst/>
+          </a:prstGeom>
+        </p:spPr>
+        <p:style>
+          <a:lnRef idx="2">
+            <a:schemeClr val="accent1">
+              <a:shade val="15000"/>
+            </a:schemeClr>
+          </a:lnRef>
+          <a:fillRef idx="1">
+            <a:schemeClr val="accent1"/>
+          </a:fillRef>
+          <a:effectRef idx="0">
+            <a:schemeClr val="accent1"/>
+          </a:effectRef>
+          <a:fontRef idx="minor">
+            <a:schemeClr val="lt1"/>
+          </a:fontRef>
+        </p:style>
+        <p:txBody>
+          <a:bodyPr rtlCol="0" anchor="ctr"/>
+          <a:lstStyle/>
+          <a:p>
+            <a:pPr algn="ctr"/>
+            <a:r>
+              <a:rPr lang="en-US" altLang="zh-CN" dirty="0"/>
+              <a:t>Quadruped</a:t>
+            </a:r>
+            <a:endParaRPr lang="zh-CN" altLang="en-US" dirty="0"/>
+          </a:p>
+        </p:txBody>
+      </p:sp>
+      <p:sp>
+        <p:nvSpPr>
+          <p:cNvPr id="24" name="弧形 23">
+            <a:extLst>
+              <a:ext uri="{FF2B5EF4-FFF2-40B4-BE49-F238E27FC236}">
+                <a16:creationId xmlns:a16="http://schemas.microsoft.com/office/drawing/2014/main" id="{679684E3-DB44-D6C5-CB02-3ECFF1F19E93}"/>
+              </a:ext>
+            </a:extLst>
+          </p:cNvPr>
+          <p:cNvSpPr/>
+          <p:nvPr/>
+        </p:nvSpPr>
+        <p:spPr>
+          <a:xfrm>
+            <a:off x="1631650" y="2417407"/>
+            <a:ext cx="6873375" cy="3343724"/>
+          </a:xfrm>
+          <a:prstGeom prst="arc">
+            <a:avLst>
+              <a:gd name="adj1" fmla="val 220815"/>
+              <a:gd name="adj2" fmla="val 3345563"/>
+            </a:avLst>
+          </a:prstGeom>
+          <a:ln>
+            <a:headEnd type="triangle" w="med" len="med"/>
+            <a:tailEnd type="none" w="med" len="med"/>
+          </a:ln>
+        </p:spPr>
+        <p:style>
+          <a:lnRef idx="2">
+            <a:schemeClr val="accent1"/>
+          </a:lnRef>
+          <a:fillRef idx="0">
+            <a:schemeClr val="accent1"/>
+          </a:fillRef>
+          <a:effectRef idx="1">
+            <a:schemeClr val="accent1"/>
+          </a:effectRef>
+          <a:fontRef idx="minor">
+            <a:schemeClr val="tx1"/>
+          </a:fontRef>
+        </p:style>
+        <p:txBody>
+          <a:bodyPr rtlCol="0" anchor="ctr"/>
+          <a:lstStyle/>
+          <a:p>
+            <a:pPr algn="ctr"/>
+            <a:endParaRPr lang="zh-CN" altLang="en-US"/>
+          </a:p>
+        </p:txBody>
+      </p:sp>
+      <p:sp>
+        <p:nvSpPr>
+          <p:cNvPr id="28" name="弧形 27">
+            <a:extLst>
+              <a:ext uri="{FF2B5EF4-FFF2-40B4-BE49-F238E27FC236}">
+                <a16:creationId xmlns:a16="http://schemas.microsoft.com/office/drawing/2014/main" id="{061A1A01-A27C-019A-0A86-9F57E3146904}"/>
+              </a:ext>
+            </a:extLst>
+          </p:cNvPr>
+          <p:cNvSpPr/>
+          <p:nvPr/>
+        </p:nvSpPr>
+        <p:spPr>
+          <a:xfrm>
+            <a:off x="1693669" y="1755539"/>
+            <a:ext cx="6873375" cy="3343724"/>
+          </a:xfrm>
+          <a:prstGeom prst="arc">
+            <a:avLst>
+              <a:gd name="adj1" fmla="val 18673134"/>
+              <a:gd name="adj2" fmla="val 21069632"/>
+            </a:avLst>
+          </a:prstGeom>
+          <a:ln>
+            <a:headEnd type="triangle" w="med" len="med"/>
+            <a:tailEnd type="none" w="med" len="med"/>
+          </a:ln>
+        </p:spPr>
+        <p:style>
+          <a:lnRef idx="2">
+            <a:schemeClr val="accent1"/>
+          </a:lnRef>
+          <a:fillRef idx="0">
+            <a:schemeClr val="accent1"/>
+          </a:fillRef>
+          <a:effectRef idx="1">
+            <a:schemeClr val="accent1"/>
+          </a:effectRef>
+          <a:fontRef idx="minor">
+            <a:schemeClr val="tx1"/>
+          </a:fontRef>
+        </p:style>
+        <p:txBody>
+          <a:bodyPr rtlCol="0" anchor="ctr"/>
+          <a:lstStyle/>
+          <a:p>
+            <a:pPr algn="ctr"/>
+            <a:endParaRPr lang="zh-CN" altLang="en-US"/>
+          </a:p>
+        </p:txBody>
+      </p:sp>
+      <p:sp>
+        <p:nvSpPr>
+          <p:cNvPr id="32" name="文本框 31">
+            <a:extLst>
+              <a:ext uri="{FF2B5EF4-FFF2-40B4-BE49-F238E27FC236}">
+                <a16:creationId xmlns:a16="http://schemas.microsoft.com/office/drawing/2014/main" id="{89A89CFF-5BA3-5E10-BF4A-2EFE0FFCEB8B}"/>
+              </a:ext>
+            </a:extLst>
+          </p:cNvPr>
+          <p:cNvSpPr txBox="1"/>
+          <p:nvPr/>
+        </p:nvSpPr>
+        <p:spPr>
+          <a:xfrm>
+            <a:off x="7802081" y="5115271"/>
+            <a:ext cx="1707895" cy="369332"/>
+          </a:xfrm>
+          <a:prstGeom prst="rect">
+            <a:avLst/>
+          </a:prstGeom>
+          <a:noFill/>
+        </p:spPr>
+        <p:txBody>
+          <a:bodyPr wrap="square" rtlCol="0">
+            <a:spAutoFit/>
+          </a:bodyPr>
+          <a:lstStyle/>
+          <a:p>
+            <a:r>
+              <a:rPr lang="en-US" altLang="zh-CN" dirty="0"/>
+              <a:t>Joint torque</a:t>
+            </a:r>
+            <a:endParaRPr lang="zh-CN" altLang="en-US" dirty="0"/>
+          </a:p>
+        </p:txBody>
+      </p:sp>
+      <p:sp>
+        <p:nvSpPr>
+          <p:cNvPr id="36" name="文本框 35">
+            <a:extLst>
+              <a:ext uri="{FF2B5EF4-FFF2-40B4-BE49-F238E27FC236}">
+                <a16:creationId xmlns:a16="http://schemas.microsoft.com/office/drawing/2014/main" id="{386A4B88-27C4-6F71-3E3E-52D9506AFBAB}"/>
+              </a:ext>
+            </a:extLst>
+          </p:cNvPr>
+          <p:cNvSpPr txBox="1"/>
+          <p:nvPr/>
+        </p:nvSpPr>
+        <p:spPr>
+          <a:xfrm>
+            <a:off x="7999722" y="2143571"/>
+            <a:ext cx="1707895" cy="369332"/>
+          </a:xfrm>
+          <a:prstGeom prst="rect">
+            <a:avLst/>
+          </a:prstGeom>
+          <a:noFill/>
+        </p:spPr>
+        <p:txBody>
+          <a:bodyPr wrap="square" rtlCol="0">
+            <a:spAutoFit/>
+          </a:bodyPr>
+          <a:lstStyle/>
+          <a:p>
+            <a:r>
+              <a:rPr lang="en-US" altLang="zh-CN" dirty="0"/>
+              <a:t>Real velocity</a:t>
+            </a:r>
+            <a:endParaRPr lang="zh-CN" altLang="en-US" dirty="0"/>
+          </a:p>
+        </p:txBody>
+      </p:sp>
+      <p:sp>
+        <p:nvSpPr>
+          <p:cNvPr id="38" name="弧形 37">
+            <a:extLst>
+              <a:ext uri="{FF2B5EF4-FFF2-40B4-BE49-F238E27FC236}">
+                <a16:creationId xmlns:a16="http://schemas.microsoft.com/office/drawing/2014/main" id="{EF5E736B-E194-BED4-F2E4-810D0D228714}"/>
+              </a:ext>
+            </a:extLst>
+          </p:cNvPr>
+          <p:cNvSpPr/>
+          <p:nvPr/>
+        </p:nvSpPr>
+        <p:spPr>
+          <a:xfrm>
+            <a:off x="1631650" y="2985462"/>
+            <a:ext cx="6873375" cy="2199251"/>
+          </a:xfrm>
+          <a:prstGeom prst="arc">
+            <a:avLst>
+              <a:gd name="adj1" fmla="val 12329361"/>
+              <a:gd name="adj2" fmla="val 20465422"/>
+            </a:avLst>
+          </a:prstGeom>
+          <a:ln>
+            <a:headEnd type="triangle" w="med" len="med"/>
+            <a:tailEnd type="none" w="med" len="med"/>
+          </a:ln>
+        </p:spPr>
+        <p:style>
+          <a:lnRef idx="2">
+            <a:schemeClr val="accent1"/>
+          </a:lnRef>
+          <a:fillRef idx="0">
+            <a:schemeClr val="accent1"/>
+          </a:fillRef>
+          <a:effectRef idx="1">
+            <a:schemeClr val="accent1"/>
+          </a:effectRef>
+          <a:fontRef idx="minor">
+            <a:schemeClr val="tx1"/>
+          </a:fontRef>
+        </p:style>
+        <p:txBody>
+          <a:bodyPr rtlCol="0" anchor="ctr"/>
+          <a:lstStyle/>
+          <a:p>
+            <a:pPr algn="ctr"/>
+            <a:endParaRPr lang="zh-CN" altLang="en-US"/>
+          </a:p>
+        </p:txBody>
+      </p:sp>
+      <p:sp>
+        <p:nvSpPr>
+          <p:cNvPr id="40" name="文本框 39">
+            <a:extLst>
+              <a:ext uri="{FF2B5EF4-FFF2-40B4-BE49-F238E27FC236}">
+                <a16:creationId xmlns:a16="http://schemas.microsoft.com/office/drawing/2014/main" id="{84CEF88B-56E5-6146-B592-BC124C5A8B62}"/>
+              </a:ext>
+            </a:extLst>
+          </p:cNvPr>
+          <p:cNvSpPr txBox="1"/>
+          <p:nvPr/>
+        </p:nvSpPr>
+        <p:spPr>
+          <a:xfrm>
+            <a:off x="4714157" y="2559858"/>
+            <a:ext cx="1707895" cy="369332"/>
+          </a:xfrm>
+          <a:prstGeom prst="rect">
+            <a:avLst/>
+          </a:prstGeom>
+          <a:noFill/>
+        </p:spPr>
+        <p:txBody>
+          <a:bodyPr wrap="square" rtlCol="0">
+            <a:spAutoFit/>
+          </a:bodyPr>
+          <a:lstStyle/>
+          <a:p>
+            <a:r>
+              <a:rPr lang="en-US" altLang="zh-CN" dirty="0"/>
+              <a:t>Real velocity</a:t>
+            </a:r>
+            <a:endParaRPr lang="zh-CN" altLang="en-US" dirty="0"/>
+          </a:p>
+        </p:txBody>
+      </p:sp>
+    </p:spTree>
+    <p:extLst>
+      <p:ext uri="{BB962C8B-B14F-4D97-AF65-F5344CB8AC3E}">
+        <p14:creationId xmlns:p14="http://schemas.microsoft.com/office/powerpoint/2010/main" val="4013469701"/>
+      </p:ext>
+    </p:extLst>
+  </p:cSld>
+  <p:clrMapOvr>
+    <a:masterClrMapping/>
+  </p:clrMapOvr>
+</p:sld>
+</file>
+
+<file path=ppt/slides/slide4.xml><?xml version="1.0" encoding="utf-8"?>
+<p:sld xmlns:a="http://schemas.openxmlformats.org/drawingml/2006/main" xmlns:r="http://schemas.openxmlformats.org/officeDocument/2006/relationships" xmlns:p="http://schemas.openxmlformats.org/presentationml/2006/main">
+  <p:cSld>
+    <p:spTree>
+      <p:nvGrpSpPr>
+        <p:cNvPr id="1" name="">
+          <a:extLst>
+            <a:ext uri="{FF2B5EF4-FFF2-40B4-BE49-F238E27FC236}">
+              <a16:creationId xmlns:a16="http://schemas.microsoft.com/office/drawing/2014/main" id="{C3B1FAB6-CAAE-38E7-1535-4637C824963E}"/>
+            </a:ext>
+          </a:extLst>
+        </p:cNvPr>
+        <p:cNvGrpSpPr/>
+        <p:nvPr/>
+      </p:nvGrpSpPr>
+      <p:grpSpPr>
+        <a:xfrm>
+          <a:off x="0" y="0"/>
+          <a:ext cx="0" cy="0"/>
+          <a:chOff x="0" y="0"/>
+          <a:chExt cx="0" cy="0"/>
+        </a:xfrm>
+      </p:grpSpPr>
+      <p:sp>
+        <p:nvSpPr>
+          <p:cNvPr id="9" name="文本框 8">
+            <a:extLst>
+              <a:ext uri="{FF2B5EF4-FFF2-40B4-BE49-F238E27FC236}">
+                <a16:creationId xmlns:a16="http://schemas.microsoft.com/office/drawing/2014/main" id="{60F819B1-FF07-1AE9-B113-9C23028DB5F8}"/>
+              </a:ext>
+            </a:extLst>
+          </p:cNvPr>
+          <p:cNvSpPr txBox="1"/>
+          <p:nvPr/>
+        </p:nvSpPr>
+        <p:spPr>
+          <a:xfrm>
+            <a:off x="185420" y="242570"/>
+            <a:ext cx="1334020" cy="369332"/>
+          </a:xfrm>
+          <a:prstGeom prst="rect">
+            <a:avLst/>
+          </a:prstGeom>
+          <a:noFill/>
+        </p:spPr>
+        <p:txBody>
+          <a:bodyPr wrap="none" rtlCol="0">
+            <a:spAutoFit/>
+          </a:bodyPr>
+          <a:lstStyle/>
+          <a:p>
+            <a:r>
+              <a:rPr lang="en-US" altLang="zh-CN" b="1" dirty="0"/>
+              <a:t>Motivation</a:t>
+            </a:r>
+            <a:endParaRPr lang="zh-CN" altLang="en-US" b="1" dirty="0"/>
+          </a:p>
+        </p:txBody>
+      </p:sp>
+      <p:sp>
+        <p:nvSpPr>
+          <p:cNvPr id="10" name="文本框 9">
+            <a:extLst>
+              <a:ext uri="{FF2B5EF4-FFF2-40B4-BE49-F238E27FC236}">
+                <a16:creationId xmlns:a16="http://schemas.microsoft.com/office/drawing/2014/main" id="{F1AFA4A2-BD2A-2577-930C-417A5EBA9671}"/>
+              </a:ext>
+            </a:extLst>
+          </p:cNvPr>
+          <p:cNvSpPr txBox="1"/>
+          <p:nvPr/>
+        </p:nvSpPr>
+        <p:spPr>
+          <a:xfrm>
+            <a:off x="185420" y="790853"/>
+            <a:ext cx="2848857" cy="923330"/>
+          </a:xfrm>
+          <a:prstGeom prst="rect">
+            <a:avLst/>
+          </a:prstGeom>
+          <a:noFill/>
+        </p:spPr>
+        <p:txBody>
+          <a:bodyPr wrap="none" rtlCol="0">
+            <a:spAutoFit/>
+          </a:bodyPr>
+          <a:lstStyle/>
+          <a:p>
+            <a:pPr marL="342900" indent="-342900">
+              <a:buAutoNum type="arabicPeriod"/>
+            </a:pPr>
+            <a:r>
+              <a:rPr lang="en-US" altLang="zh-CN" dirty="0"/>
+              <a:t>Foot placement</a:t>
+            </a:r>
+          </a:p>
+          <a:p>
+            <a:pPr marL="342900" indent="-342900">
+              <a:buAutoNum type="arabicPeriod"/>
+            </a:pPr>
+            <a:r>
+              <a:rPr lang="en-US" altLang="zh-CN" dirty="0"/>
+              <a:t>Phase ?</a:t>
+            </a:r>
+          </a:p>
+          <a:p>
+            <a:pPr marL="342900" indent="-342900">
+              <a:buAutoNum type="arabicPeriod"/>
+            </a:pPr>
+            <a:r>
+              <a:rPr lang="en-US" altLang="zh-CN" dirty="0"/>
+              <a:t>Compatible with MPC ?</a:t>
+            </a:r>
+            <a:endParaRPr lang="zh-CN" altLang="en-US" dirty="0"/>
+          </a:p>
+        </p:txBody>
+      </p:sp>
+    </p:spTree>
+    <p:extLst>
+      <p:ext uri="{BB962C8B-B14F-4D97-AF65-F5344CB8AC3E}">
+        <p14:creationId xmlns:p14="http://schemas.microsoft.com/office/powerpoint/2010/main" val="3431035551"/>
+      </p:ext>
+    </p:extLst>
+  </p:cSld>
+  <p:clrMapOvr>
+    <a:masterClrMapping/>
+  </p:clrMapOvr>
+</p:sld>
+</file>
+
+<file path=ppt/slides/slide5.xml><?xml version="1.0" encoding="utf-8"?>
+<p:sld xmlns:a="http://schemas.openxmlformats.org/drawingml/2006/main" xmlns:r="http://schemas.openxmlformats.org/officeDocument/2006/relationships" xmlns:p="http://schemas.openxmlformats.org/presentationml/2006/main">
+  <p:cSld>
+    <p:spTree>
+      <p:nvGrpSpPr>
         <p:cNvPr id="1" name=""/>
         <p:cNvGrpSpPr/>
         <p:nvPr/>
@@ -3442,8 +5041,8 @@
           <a:chExt cx="0" cy="0"/>
         </a:xfrm>
       </p:grpSpPr>
-      <mc:AlternateContent xmlns:mc="http://schemas.openxmlformats.org/markup-compatibility/2006">
-        <mc:Choice xmlns:a14="http://schemas.microsoft.com/office/drawing/2010/main" Requires="a14">
+      <mc:AlternateContent xmlns:mc="http://schemas.openxmlformats.org/markup-compatibility/2006" xmlns:a14="http://schemas.microsoft.com/office/drawing/2010/main">
+        <mc:Choice Requires="a14">
           <p:sp>
             <p:nvSpPr>
               <p:cNvPr id="2" name="文本框 1">
@@ -3472,6 +5071,7 @@
               </a:bodyPr>
               <a:lstStyle/>
               <a:p>
+                <a:pPr/>
                 <a14:m>
                   <m:oMathPara xmlns:m="http://schemas.openxmlformats.org/officeDocument/2006/math">
                     <m:oMath>
@@ -3543,7 +5143,7 @@
             </p:txBody>
           </p:sp>
         </mc:Choice>
-        <mc:Fallback>
+        <mc:Fallback xmlns="">
           <p:sp>
             <p:nvSpPr>
               <p:cNvPr id="2" name="文本框 1">
@@ -3639,7 +5239,7 @@
         <p:spPr>
           <a:xfrm>
             <a:off x="185420" y="790853"/>
-            <a:ext cx="7723589" cy="369332"/>
+            <a:ext cx="7853432" cy="369332"/>
           </a:xfrm>
           <a:prstGeom prst="rect">
             <a:avLst/>
@@ -3654,15 +5254,7 @@
           <a:p>
             <a:r>
               <a:rPr lang="en-US" altLang="zh-CN" dirty="0"/>
-              <a:t>Model </a:t>
-            </a:r>
-            <a:r>
-              <a:rPr lang="en-US" altLang="zh-CN" dirty="0" err="1"/>
-              <a:t>Simplication</a:t>
-            </a:r>
-            <a:r>
-              <a:rPr lang="en-US" altLang="zh-CN" dirty="0"/>
-              <a:t>: Torso (move in generalized coordinates) + massless legs</a:t>
+              <a:t>Model Simplification: Torso (move in generalized coordinates) + massless legs</a:t>
             </a:r>
             <a:endParaRPr lang="zh-CN" altLang="en-US" dirty="0"/>
           </a:p>
@@ -3704,8 +5296,8 @@
           </a:p>
         </p:txBody>
       </p:sp>
-      <mc:AlternateContent xmlns:mc="http://schemas.openxmlformats.org/markup-compatibility/2006">
-        <mc:Choice xmlns:a14="http://schemas.microsoft.com/office/drawing/2010/main" Requires="a14">
+      <mc:AlternateContent xmlns:mc="http://schemas.openxmlformats.org/markup-compatibility/2006" xmlns:a14="http://schemas.microsoft.com/office/drawing/2010/main">
+        <mc:Choice Requires="a14">
           <p:sp>
             <p:nvSpPr>
               <p:cNvPr id="13" name="文本框 12">
@@ -3734,6 +5326,7 @@
               </a:bodyPr>
               <a:lstStyle/>
               <a:p>
+                <a:pPr/>
                 <a14:m>
                   <m:oMathPara xmlns:m="http://schemas.openxmlformats.org/officeDocument/2006/math">
                     <m:oMath>
@@ -3846,7 +5439,7 @@
             </p:txBody>
           </p:sp>
         </mc:Choice>
-        <mc:Fallback>
+        <mc:Fallback xmlns="">
           <p:sp>
             <p:nvSpPr>
               <p:cNvPr id="13" name="文本框 12">
@@ -3944,7 +5537,7 @@
             <p:spPr>
               <a:xfrm>
                 <a:off x="4923633" y="1752600"/>
-                <a:ext cx="1460976" cy="672235"/>
+                <a:ext cx="1942583" cy="672492"/>
               </a:xfrm>
               <a:prstGeom prst="rect">
                 <a:avLst/>
@@ -3957,38 +5550,61 @@
               </a:bodyPr>
               <a:lstStyle/>
               <a:p>
+                <a:pPr/>
                 <a14:m>
                   <m:oMathPara xmlns:m="http://schemas.openxmlformats.org/officeDocument/2006/math">
                     <m:oMath>
+                      <m:f>
+                        <m:fPr>
+                          <m:ctrlPr>
+                            <a:rPr lang="en-US" altLang="zh-CN" b="0" i="1" smtClean="0">
+                              <a:latin typeface="Cambria Math" panose="02040503050406030204" pitchFamily="18" charset="0"/>
+                            </a:rPr>
+                          </m:ctrlPr>
+                        </m:fPr>
+                        <m:num>
+                          <m:r>
+                            <a:rPr lang="en-US" altLang="zh-CN" b="0" i="1" smtClean="0">
+                              <a:latin typeface="Cambria Math" panose="02040503050406030204" pitchFamily="18" charset="0"/>
+                            </a:rPr>
+                            <m:t>𝑑</m:t>
+                          </m:r>
+                        </m:num>
+                        <m:den>
+                          <m:r>
+                            <m:rPr>
+                              <m:sty m:val="p"/>
+                            </m:rPr>
+                            <a:rPr lang="en-US" altLang="zh-CN" b="0" i="1" smtClean="0">
+                              <a:latin typeface="Cambria Math" panose="02040503050406030204" pitchFamily="18" charset="0"/>
+                            </a:rPr>
+                            <m:t>dt</m:t>
+                          </m:r>
+                        </m:den>
+                      </m:f>
+                      <m:r>
+                        <a:rPr lang="en-US" altLang="zh-CN" b="0" i="1" smtClean="0">
+                          <a:latin typeface="Cambria Math" panose="02040503050406030204" pitchFamily="18" charset="0"/>
+                        </a:rPr>
+                        <m:t> (</m:t>
+                      </m:r>
                       <m:r>
                         <a:rPr lang="en-US" altLang="zh-CN" b="0" i="1" smtClean="0">
                           <a:latin typeface="Cambria Math" panose="02040503050406030204" pitchFamily="18" charset="0"/>
                         </a:rPr>
                         <m:t>𝐼</m:t>
                       </m:r>
-                      <m:acc>
-                        <m:accPr>
-                          <m:chr m:val="̇"/>
-                          <m:ctrlPr>
-                            <a:rPr lang="en-US" altLang="zh-CN" b="0" i="1" smtClean="0">
-                              <a:latin typeface="Cambria Math" panose="02040503050406030204" pitchFamily="18" charset="0"/>
-                            </a:rPr>
-                          </m:ctrlPr>
-                        </m:accPr>
-                        <m:e>
-                          <m:r>
-                            <a:rPr lang="en-US" altLang="zh-CN" b="0" i="1" smtClean="0">
-                              <a:latin typeface="Cambria Math" panose="02040503050406030204" pitchFamily="18" charset="0"/>
-                            </a:rPr>
-                            <m:t>𝜔</m:t>
-                          </m:r>
-                        </m:e>
-                      </m:acc>
                       <m:r>
                         <a:rPr lang="en-US" altLang="zh-CN" b="0" i="1" smtClean="0">
                           <a:latin typeface="Cambria Math" panose="02040503050406030204" pitchFamily="18" charset="0"/>
                         </a:rPr>
-                        <m:t>≈</m:t>
+                        <m:t>𝜔</m:t>
+                      </m:r>
+                      <m:r>
+                        <a:rPr lang="en-US" altLang="zh-CN" b="0" i="1" smtClean="0">
+                          <a:latin typeface="Cambria Math" panose="02040503050406030204" pitchFamily="18" charset="0"/>
+                        </a:rPr>
+                        <m:t>)≈</m:t>
                       </m:r>
                       <m:nary>
                         <m:naryPr>
@@ -4106,7 +5722,7 @@
             <p:spPr>
               <a:xfrm>
                 <a:off x="4923633" y="1752600"/>
-                <a:ext cx="1460976" cy="672235"/>
+                <a:ext cx="1942583" cy="672492"/>
               </a:xfrm>
               <a:prstGeom prst="rect">
                 <a:avLst/>
@@ -4149,7 +5765,7 @@
             </p:nvSpPr>
             <p:spPr>
               <a:xfrm>
-                <a:off x="6960562" y="1950217"/>
+                <a:off x="7310447" y="1950217"/>
                 <a:ext cx="1456809" cy="276999"/>
               </a:xfrm>
               <a:prstGeom prst="rect">
@@ -4205,7 +5821,7 @@
             </p:nvSpPr>
             <p:spPr>
               <a:xfrm>
-                <a:off x="6960562" y="1950217"/>
+                <a:off x="7310447" y="1950217"/>
                 <a:ext cx="1456809" cy="276999"/>
               </a:xfrm>
               <a:prstGeom prst="rect">
@@ -4214,7 +5830,7 @@
               <a:blipFill>
                 <a:blip r:embed="rId5"/>
                 <a:stretch>
-                  <a:fillRect l="-5858" t="-28889" r="-9205" b="-51111"/>
+                  <a:fillRect l="-5439" t="-28889" r="-9623" b="-51111"/>
                 </a:stretch>
               </a:blipFill>
             </p:spPr>
@@ -4269,619 +5885,6 @@
           </a:p>
         </p:txBody>
       </p:sp>
-      <p:sp>
-        <p:nvSpPr>
-          <p:cNvPr id="20" name="矩形 19">
-            <a:extLst>
-              <a:ext uri="{FF2B5EF4-FFF2-40B4-BE49-F238E27FC236}">
-                <a16:creationId xmlns:a16="http://schemas.microsoft.com/office/drawing/2014/main" id="{97E03EA7-9881-8568-0D0B-F252878C4445}"/>
-              </a:ext>
-            </a:extLst>
-          </p:cNvPr>
-          <p:cNvSpPr/>
-          <p:nvPr/>
-        </p:nvSpPr>
-        <p:spPr>
-          <a:xfrm>
-            <a:off x="1799433" y="2963502"/>
-            <a:ext cx="1350733" cy="800100"/>
-          </a:xfrm>
-          <a:prstGeom prst="rect">
-            <a:avLst/>
-          </a:prstGeom>
-        </p:spPr>
-        <p:style>
-          <a:lnRef idx="2">
-            <a:schemeClr val="accent1">
-              <a:shade val="15000"/>
-            </a:schemeClr>
-          </a:lnRef>
-          <a:fillRef idx="1">
-            <a:schemeClr val="accent1"/>
-          </a:fillRef>
-          <a:effectRef idx="0">
-            <a:schemeClr val="accent1"/>
-          </a:effectRef>
-          <a:fontRef idx="minor">
-            <a:schemeClr val="lt1"/>
-          </a:fontRef>
-        </p:style>
-        <p:txBody>
-          <a:bodyPr rtlCol="0" anchor="ctr"/>
-          <a:lstStyle/>
-          <a:p>
-            <a:pPr algn="ctr"/>
-            <a:r>
-              <a:rPr lang="en-US" altLang="zh-CN" dirty="0"/>
-              <a:t>MPC</a:t>
-            </a:r>
-            <a:endParaRPr lang="zh-CN" altLang="en-US" dirty="0"/>
-          </a:p>
-        </p:txBody>
-      </p:sp>
-      <p:sp>
-        <p:nvSpPr>
-          <p:cNvPr id="21" name="文本框 20">
-            <a:extLst>
-              <a:ext uri="{FF2B5EF4-FFF2-40B4-BE49-F238E27FC236}">
-                <a16:creationId xmlns:a16="http://schemas.microsoft.com/office/drawing/2014/main" id="{D6F29E9A-90FF-9CDD-DDB0-106FFFEA8E9E}"/>
-              </a:ext>
-            </a:extLst>
-          </p:cNvPr>
-          <p:cNvSpPr txBox="1"/>
-          <p:nvPr/>
-        </p:nvSpPr>
-        <p:spPr>
-          <a:xfrm>
-            <a:off x="4667250" y="3244334"/>
-            <a:ext cx="4196983" cy="369332"/>
-          </a:xfrm>
-          <a:prstGeom prst="rect">
-            <a:avLst/>
-          </a:prstGeom>
-          <a:noFill/>
-        </p:spPr>
-        <p:txBody>
-          <a:bodyPr wrap="none" rtlCol="0">
-            <a:spAutoFit/>
-          </a:bodyPr>
-          <a:lstStyle/>
-          <a:p>
-            <a:r>
-              <a:rPr lang="en-US" altLang="zh-CN" dirty="0"/>
-              <a:t>Torso motion in generalized coordinates</a:t>
-            </a:r>
-            <a:endParaRPr lang="zh-CN" altLang="en-US" dirty="0"/>
-          </a:p>
-        </p:txBody>
-      </p:sp>
-      <p:sp>
-        <p:nvSpPr>
-          <p:cNvPr id="23" name="矩形 22">
-            <a:extLst>
-              <a:ext uri="{FF2B5EF4-FFF2-40B4-BE49-F238E27FC236}">
-                <a16:creationId xmlns:a16="http://schemas.microsoft.com/office/drawing/2014/main" id="{0FDEE4B9-5CB7-F6E9-A4A7-8A4C05D7236A}"/>
-              </a:ext>
-            </a:extLst>
-          </p:cNvPr>
-          <p:cNvSpPr/>
-          <p:nvPr/>
-        </p:nvSpPr>
-        <p:spPr>
-          <a:xfrm>
-            <a:off x="1799433" y="4302269"/>
-            <a:ext cx="1350733" cy="800100"/>
-          </a:xfrm>
-          <a:prstGeom prst="rect">
-            <a:avLst/>
-          </a:prstGeom>
-        </p:spPr>
-        <p:style>
-          <a:lnRef idx="2">
-            <a:schemeClr val="accent1">
-              <a:shade val="15000"/>
-            </a:schemeClr>
-          </a:lnRef>
-          <a:fillRef idx="1">
-            <a:schemeClr val="accent1"/>
-          </a:fillRef>
-          <a:effectRef idx="0">
-            <a:schemeClr val="accent1"/>
-          </a:effectRef>
-          <a:fontRef idx="minor">
-            <a:schemeClr val="lt1"/>
-          </a:fontRef>
-        </p:style>
-        <p:txBody>
-          <a:bodyPr rtlCol="0" anchor="ctr"/>
-          <a:lstStyle/>
-          <a:p>
-            <a:pPr algn="ctr"/>
-            <a:r>
-              <a:rPr lang="en-US" altLang="zh-CN" dirty="0"/>
-              <a:t>Gait Scheduler</a:t>
-            </a:r>
-            <a:endParaRPr lang="zh-CN" altLang="en-US" dirty="0"/>
-          </a:p>
-        </p:txBody>
-      </p:sp>
-      <p:sp>
-        <p:nvSpPr>
-          <p:cNvPr id="25" name="文本框 24">
-            <a:extLst>
-              <a:ext uri="{FF2B5EF4-FFF2-40B4-BE49-F238E27FC236}">
-                <a16:creationId xmlns:a16="http://schemas.microsoft.com/office/drawing/2014/main" id="{456F2E3D-7EA6-9691-8EB2-451CE9BC5C77}"/>
-              </a:ext>
-            </a:extLst>
-          </p:cNvPr>
-          <p:cNvSpPr txBox="1"/>
-          <p:nvPr/>
-        </p:nvSpPr>
-        <p:spPr>
-          <a:xfrm>
-            <a:off x="4978706" y="4379153"/>
-            <a:ext cx="3323347" cy="646331"/>
-          </a:xfrm>
-          <a:prstGeom prst="rect">
-            <a:avLst/>
-          </a:prstGeom>
-          <a:noFill/>
-        </p:spPr>
-        <p:txBody>
-          <a:bodyPr wrap="none" rtlCol="0">
-            <a:spAutoFit/>
-          </a:bodyPr>
-          <a:lstStyle/>
-          <a:p>
-            <a:pPr algn="ctr"/>
-            <a:r>
-              <a:rPr lang="en-US" altLang="zh-CN" dirty="0"/>
-              <a:t>Foot placement + Stance/swing</a:t>
-            </a:r>
-          </a:p>
-          <a:p>
-            <a:pPr algn="ctr"/>
-            <a:r>
-              <a:rPr lang="en-US" altLang="zh-CN" dirty="0"/>
-              <a:t> phase planning</a:t>
-            </a:r>
-            <a:endParaRPr lang="zh-CN" altLang="en-US" dirty="0"/>
-          </a:p>
-        </p:txBody>
-      </p:sp>
-      <p:sp>
-        <p:nvSpPr>
-          <p:cNvPr id="27" name="矩形 26">
-            <a:extLst>
-              <a:ext uri="{FF2B5EF4-FFF2-40B4-BE49-F238E27FC236}">
-                <a16:creationId xmlns:a16="http://schemas.microsoft.com/office/drawing/2014/main" id="{1B9527F5-D015-6FB9-30E1-1D9520694C36}"/>
-              </a:ext>
-            </a:extLst>
-          </p:cNvPr>
-          <p:cNvSpPr/>
-          <p:nvPr/>
-        </p:nvSpPr>
-        <p:spPr>
-          <a:xfrm>
-            <a:off x="1799432" y="5641036"/>
-            <a:ext cx="1350733" cy="800100"/>
-          </a:xfrm>
-          <a:prstGeom prst="rect">
-            <a:avLst/>
-          </a:prstGeom>
-        </p:spPr>
-        <p:style>
-          <a:lnRef idx="2">
-            <a:schemeClr val="accent1">
-              <a:shade val="15000"/>
-            </a:schemeClr>
-          </a:lnRef>
-          <a:fillRef idx="1">
-            <a:schemeClr val="accent1"/>
-          </a:fillRef>
-          <a:effectRef idx="0">
-            <a:schemeClr val="accent1"/>
-          </a:effectRef>
-          <a:fontRef idx="minor">
-            <a:schemeClr val="lt1"/>
-          </a:fontRef>
-        </p:style>
-        <p:txBody>
-          <a:bodyPr rtlCol="0" anchor="ctr"/>
-          <a:lstStyle/>
-          <a:p>
-            <a:pPr algn="ctr"/>
-            <a:r>
-              <a:rPr lang="en-US" altLang="zh-CN" dirty="0"/>
-              <a:t>Joint</a:t>
-            </a:r>
-          </a:p>
-          <a:p>
-            <a:pPr algn="ctr"/>
-            <a:r>
-              <a:rPr lang="en-US" altLang="zh-CN" dirty="0"/>
-              <a:t>Controller</a:t>
-            </a:r>
-            <a:endParaRPr lang="zh-CN" altLang="en-US" dirty="0"/>
-          </a:p>
-        </p:txBody>
-      </p:sp>
-      <p:sp>
-        <p:nvSpPr>
-          <p:cNvPr id="29" name="文本框 28">
-            <a:extLst>
-              <a:ext uri="{FF2B5EF4-FFF2-40B4-BE49-F238E27FC236}">
-                <a16:creationId xmlns:a16="http://schemas.microsoft.com/office/drawing/2014/main" id="{B9607ECC-8E7D-3BDD-1F7F-3B3D1AAA0593}"/>
-              </a:ext>
-            </a:extLst>
-          </p:cNvPr>
-          <p:cNvSpPr txBox="1"/>
-          <p:nvPr/>
-        </p:nvSpPr>
-        <p:spPr>
-          <a:xfrm>
-            <a:off x="5029199" y="5856419"/>
-            <a:ext cx="3451587" cy="369332"/>
-          </a:xfrm>
-          <a:prstGeom prst="rect">
-            <a:avLst/>
-          </a:prstGeom>
-          <a:noFill/>
-        </p:spPr>
-        <p:txBody>
-          <a:bodyPr wrap="none" rtlCol="0">
-            <a:spAutoFit/>
-          </a:bodyPr>
-          <a:lstStyle/>
-          <a:p>
-            <a:pPr algn="ctr"/>
-            <a:r>
-              <a:rPr lang="en-US" altLang="zh-CN" dirty="0"/>
-              <a:t>PD controller + Inverse dynamics</a:t>
-            </a:r>
-            <a:endParaRPr lang="zh-CN" altLang="en-US" dirty="0"/>
-          </a:p>
-        </p:txBody>
-      </p:sp>
-      <mc:AlternateContent xmlns:mc="http://schemas.openxmlformats.org/markup-compatibility/2006">
-        <mc:Choice xmlns:a14="http://schemas.microsoft.com/office/drawing/2010/main" Requires="a14">
-          <p:sp>
-            <p:nvSpPr>
-              <p:cNvPr id="31" name="文本框 30">
-                <a:extLst>
-                  <a:ext uri="{FF2B5EF4-FFF2-40B4-BE49-F238E27FC236}">
-                    <a16:creationId xmlns:a16="http://schemas.microsoft.com/office/drawing/2014/main" id="{A7AFA2D2-2502-CBD7-B930-B207A5063CE4}"/>
-                  </a:ext>
-                </a:extLst>
-              </p:cNvPr>
-              <p:cNvSpPr txBox="1"/>
-              <p:nvPr/>
-            </p:nvSpPr>
-            <p:spPr>
-              <a:xfrm>
-                <a:off x="3778690" y="4433166"/>
-                <a:ext cx="409023" cy="518604"/>
-              </a:xfrm>
-              <a:prstGeom prst="rect">
-                <a:avLst/>
-              </a:prstGeom>
-              <a:noFill/>
-            </p:spPr>
-            <p:txBody>
-              <a:bodyPr wrap="none" lIns="0" tIns="0" rIns="0" bIns="0" rtlCol="0">
-                <a:spAutoFit/>
-              </a:bodyPr>
-              <a:lstStyle/>
-              <a:p>
-                <a14:m>
-                  <m:oMathPara xmlns:m="http://schemas.openxmlformats.org/officeDocument/2006/math">
-                    <m:oMath>
-                      <m:r>
-                        <a:rPr lang="en-US" altLang="zh-CN" b="0" i="1" smtClean="0">
-                          <a:latin typeface="Cambria Math" panose="02040503050406030204" pitchFamily="18" charset="0"/>
-                        </a:rPr>
-                        <m:t>~</m:t>
-                      </m:r>
-                      <m:f>
-                        <m:fPr>
-                          <m:ctrlPr>
-                            <a:rPr lang="en-US" altLang="zh-CN" b="0" i="1" smtClean="0">
-                              <a:latin typeface="Cambria Math" panose="02040503050406030204" pitchFamily="18" charset="0"/>
-                            </a:rPr>
-                          </m:ctrlPr>
-                        </m:fPr>
-                        <m:num>
-                          <m:r>
-                            <a:rPr lang="en-US" altLang="zh-CN" b="0" i="1" smtClean="0">
-                              <a:latin typeface="Cambria Math" panose="02040503050406030204" pitchFamily="18" charset="0"/>
-                            </a:rPr>
-                            <m:t>1</m:t>
-                          </m:r>
-                        </m:num>
-                        <m:den>
-                          <m:r>
-                            <a:rPr lang="en-US" altLang="zh-CN" b="0" i="1" smtClean="0">
-                              <a:latin typeface="Cambria Math" panose="02040503050406030204" pitchFamily="18" charset="0"/>
-                            </a:rPr>
-                            <m:t>𝑇</m:t>
-                          </m:r>
-                        </m:den>
-                      </m:f>
-                    </m:oMath>
-                  </m:oMathPara>
-                </a14:m>
-                <a:endParaRPr lang="zh-CN" altLang="en-US" dirty="0"/>
-              </a:p>
-            </p:txBody>
-          </p:sp>
-        </mc:Choice>
-        <mc:Fallback>
-          <p:sp>
-            <p:nvSpPr>
-              <p:cNvPr id="31" name="文本框 30">
-                <a:extLst>
-                  <a:ext uri="{FF2B5EF4-FFF2-40B4-BE49-F238E27FC236}">
-                    <a16:creationId xmlns:a16="http://schemas.microsoft.com/office/drawing/2014/main" id="{A7AFA2D2-2502-CBD7-B930-B207A5063CE4}"/>
-                  </a:ext>
-                </a:extLst>
-              </p:cNvPr>
-              <p:cNvSpPr txBox="1">
-                <a:spLocks noRot="1" noChangeAspect="1" noMove="1" noResize="1" noEditPoints="1" noAdjustHandles="1" noChangeArrowheads="1" noChangeShapeType="1" noTextEdit="1"/>
-              </p:cNvSpPr>
-              <p:nvPr/>
-            </p:nvSpPr>
-            <p:spPr>
-              <a:xfrm>
-                <a:off x="3778690" y="4433166"/>
-                <a:ext cx="409023" cy="518604"/>
-              </a:xfrm>
-              <a:prstGeom prst="rect">
-                <a:avLst/>
-              </a:prstGeom>
-              <a:blipFill>
-                <a:blip r:embed="rId6"/>
-                <a:stretch>
-                  <a:fillRect/>
-                </a:stretch>
-              </a:blipFill>
-            </p:spPr>
-            <p:txBody>
-              <a:bodyPr/>
-              <a:lstStyle/>
-              <a:p>
-                <a:r>
-                  <a:rPr lang="zh-CN" altLang="en-US">
-                    <a:noFill/>
-                  </a:rPr>
-                  <a:t> </a:t>
-                </a:r>
-              </a:p>
-            </p:txBody>
-          </p:sp>
-        </mc:Fallback>
-      </mc:AlternateContent>
-      <mc:AlternateContent xmlns:mc="http://schemas.openxmlformats.org/markup-compatibility/2006">
-        <mc:Choice xmlns:a14="http://schemas.microsoft.com/office/drawing/2010/main" Requires="a14">
-          <p:sp>
-            <p:nvSpPr>
-              <p:cNvPr id="33" name="文本框 32">
-                <a:extLst>
-                  <a:ext uri="{FF2B5EF4-FFF2-40B4-BE49-F238E27FC236}">
-                    <a16:creationId xmlns:a16="http://schemas.microsoft.com/office/drawing/2014/main" id="{FC65D6C8-4A18-65AE-5DAA-675F7124D2B7}"/>
-                  </a:ext>
-                </a:extLst>
-              </p:cNvPr>
-              <p:cNvSpPr txBox="1"/>
-              <p:nvPr/>
-            </p:nvSpPr>
-            <p:spPr>
-              <a:xfrm>
-                <a:off x="3609043" y="3290501"/>
-                <a:ext cx="768608" cy="276999"/>
-              </a:xfrm>
-              <a:prstGeom prst="rect">
-                <a:avLst/>
-              </a:prstGeom>
-              <a:noFill/>
-            </p:spPr>
-            <p:txBody>
-              <a:bodyPr wrap="none" lIns="0" tIns="0" rIns="0" bIns="0" rtlCol="0">
-                <a:spAutoFit/>
-              </a:bodyPr>
-              <a:lstStyle/>
-              <a:p>
-                <a:pPr/>
-                <a14:m>
-                  <m:oMathPara xmlns:m="http://schemas.openxmlformats.org/officeDocument/2006/math">
-                    <m:oMath>
-                      <m:r>
-                        <a:rPr lang="en-US" altLang="zh-CN" b="0" i="1" smtClean="0">
-                          <a:latin typeface="Cambria Math" panose="02040503050406030204" pitchFamily="18" charset="0"/>
-                        </a:rPr>
-                        <m:t>~</m:t>
-                      </m:r>
-                      <m:r>
-                        <a:rPr lang="en-US" altLang="zh-CN" i="1" smtClean="0">
-                          <a:latin typeface="Cambria Math" panose="02040503050406030204" pitchFamily="18" charset="0"/>
-                        </a:rPr>
-                        <m:t>5</m:t>
-                      </m:r>
-                      <m:r>
-                        <a:rPr lang="en-US" altLang="zh-CN" b="0" i="1" smtClean="0">
-                          <a:latin typeface="Cambria Math" panose="02040503050406030204" pitchFamily="18" charset="0"/>
-                        </a:rPr>
-                        <m:t>0</m:t>
-                      </m:r>
-                      <m:r>
-                        <a:rPr lang="en-US" altLang="zh-CN" b="0" i="1" smtClean="0">
-                          <a:latin typeface="Cambria Math" panose="02040503050406030204" pitchFamily="18" charset="0"/>
-                        </a:rPr>
-                        <m:t>𝐻𝑧</m:t>
-                      </m:r>
-                    </m:oMath>
-                  </m:oMathPara>
-                </a14:m>
-                <a:endParaRPr lang="zh-CN" altLang="en-US" dirty="0"/>
-              </a:p>
-            </p:txBody>
-          </p:sp>
-        </mc:Choice>
-        <mc:Fallback>
-          <p:sp>
-            <p:nvSpPr>
-              <p:cNvPr id="33" name="文本框 32">
-                <a:extLst>
-                  <a:ext uri="{FF2B5EF4-FFF2-40B4-BE49-F238E27FC236}">
-                    <a16:creationId xmlns:a16="http://schemas.microsoft.com/office/drawing/2014/main" id="{FC65D6C8-4A18-65AE-5DAA-675F7124D2B7}"/>
-                  </a:ext>
-                </a:extLst>
-              </p:cNvPr>
-              <p:cNvSpPr txBox="1">
-                <a:spLocks noRot="1" noChangeAspect="1" noMove="1" noResize="1" noEditPoints="1" noAdjustHandles="1" noChangeArrowheads="1" noChangeShapeType="1" noTextEdit="1"/>
-              </p:cNvSpPr>
-              <p:nvPr/>
-            </p:nvSpPr>
-            <p:spPr>
-              <a:xfrm>
-                <a:off x="3609043" y="3290501"/>
-                <a:ext cx="768608" cy="276999"/>
-              </a:xfrm>
-              <a:prstGeom prst="rect">
-                <a:avLst/>
-              </a:prstGeom>
-              <a:blipFill>
-                <a:blip r:embed="rId7"/>
-                <a:stretch>
-                  <a:fillRect l="-794" r="-7143" b="-8889"/>
-                </a:stretch>
-              </a:blipFill>
-            </p:spPr>
-            <p:txBody>
-              <a:bodyPr/>
-              <a:lstStyle/>
-              <a:p>
-                <a:r>
-                  <a:rPr lang="zh-CN" altLang="en-US">
-                    <a:noFill/>
-                  </a:rPr>
-                  <a:t> </a:t>
-                </a:r>
-              </a:p>
-            </p:txBody>
-          </p:sp>
-        </mc:Fallback>
-      </mc:AlternateContent>
-      <mc:AlternateContent xmlns:mc="http://schemas.openxmlformats.org/markup-compatibility/2006">
-        <mc:Choice xmlns:a14="http://schemas.microsoft.com/office/drawing/2010/main" Requires="a14">
-          <p:sp>
-            <p:nvSpPr>
-              <p:cNvPr id="35" name="文本框 34">
-                <a:extLst>
-                  <a:ext uri="{FF2B5EF4-FFF2-40B4-BE49-F238E27FC236}">
-                    <a16:creationId xmlns:a16="http://schemas.microsoft.com/office/drawing/2014/main" id="{401C735D-79A0-878F-56D2-76D4EBE4E919}"/>
-                  </a:ext>
-                </a:extLst>
-              </p:cNvPr>
-              <p:cNvSpPr txBox="1"/>
-              <p:nvPr/>
-            </p:nvSpPr>
-            <p:spPr>
-              <a:xfrm>
-                <a:off x="3598897" y="5902586"/>
-                <a:ext cx="767005" cy="276999"/>
-              </a:xfrm>
-              <a:prstGeom prst="rect">
-                <a:avLst/>
-              </a:prstGeom>
-              <a:noFill/>
-            </p:spPr>
-            <p:txBody>
-              <a:bodyPr wrap="none" lIns="0" tIns="0" rIns="0" bIns="0" rtlCol="0">
-                <a:spAutoFit/>
-              </a:bodyPr>
-              <a:lstStyle/>
-              <a:p>
-                <a:pPr/>
-                <a14:m>
-                  <m:oMathPara xmlns:m="http://schemas.openxmlformats.org/officeDocument/2006/math">
-                    <m:oMath>
-                      <m:r>
-                        <a:rPr lang="en-US" altLang="zh-CN" b="0" i="1" smtClean="0">
-                          <a:latin typeface="Cambria Math" panose="02040503050406030204" pitchFamily="18" charset="0"/>
-                        </a:rPr>
-                        <m:t>~</m:t>
-                      </m:r>
-                      <m:r>
-                        <a:rPr lang="en-US" altLang="zh-CN" i="1" smtClean="0">
-                          <a:latin typeface="Cambria Math" panose="02040503050406030204" pitchFamily="18" charset="0"/>
-                        </a:rPr>
-                        <m:t>1</m:t>
-                      </m:r>
-                      <m:r>
-                        <a:rPr lang="en-US" altLang="zh-CN" b="0" i="1" smtClean="0">
-                          <a:latin typeface="Cambria Math" panose="02040503050406030204" pitchFamily="18" charset="0"/>
-                        </a:rPr>
-                        <m:t>𝑘</m:t>
-                      </m:r>
-                      <m:r>
-                        <a:rPr lang="en-US" altLang="zh-CN" b="0" i="1" smtClean="0">
-                          <a:latin typeface="Cambria Math" panose="02040503050406030204" pitchFamily="18" charset="0"/>
-                        </a:rPr>
-                        <m:t>𝐻𝑧</m:t>
-                      </m:r>
-                    </m:oMath>
-                  </m:oMathPara>
-                </a14:m>
-                <a:endParaRPr lang="zh-CN" altLang="en-US" dirty="0"/>
-              </a:p>
-            </p:txBody>
-          </p:sp>
-        </mc:Choice>
-        <mc:Fallback>
-          <p:sp>
-            <p:nvSpPr>
-              <p:cNvPr id="35" name="文本框 34">
-                <a:extLst>
-                  <a:ext uri="{FF2B5EF4-FFF2-40B4-BE49-F238E27FC236}">
-                    <a16:creationId xmlns:a16="http://schemas.microsoft.com/office/drawing/2014/main" id="{401C735D-79A0-878F-56D2-76D4EBE4E919}"/>
-                  </a:ext>
-                </a:extLst>
-              </p:cNvPr>
-              <p:cNvSpPr txBox="1">
-                <a:spLocks noRot="1" noChangeAspect="1" noMove="1" noResize="1" noEditPoints="1" noAdjustHandles="1" noChangeArrowheads="1" noChangeShapeType="1" noTextEdit="1"/>
-              </p:cNvSpPr>
-              <p:nvPr/>
-            </p:nvSpPr>
-            <p:spPr>
-              <a:xfrm>
-                <a:off x="3598897" y="5902586"/>
-                <a:ext cx="767005" cy="276999"/>
-              </a:xfrm>
-              <a:prstGeom prst="rect">
-                <a:avLst/>
-              </a:prstGeom>
-              <a:blipFill>
-                <a:blip r:embed="rId8"/>
-                <a:stretch>
-                  <a:fillRect l="-794" r="-6349" b="-6522"/>
-                </a:stretch>
-              </a:blipFill>
-            </p:spPr>
-            <p:txBody>
-              <a:bodyPr/>
-              <a:lstStyle/>
-              <a:p>
-                <a:r>
-                  <a:rPr lang="zh-CN" altLang="en-US">
-                    <a:noFill/>
-                  </a:rPr>
-                  <a:t> </a:t>
-                </a:r>
-              </a:p>
-            </p:txBody>
-          </p:sp>
-        </mc:Fallback>
-      </mc:AlternateContent>
     </p:spTree>
     <p:extLst>
       <p:ext uri="{BB962C8B-B14F-4D97-AF65-F5344CB8AC3E}">
@@ -4895,7 +5898,7 @@
 </p:sld>
 </file>
 
-<file path=ppt/slides/slide3.xml><?xml version="1.0" encoding="utf-8"?>
+<file path=ppt/slides/slide6.xml><?xml version="1.0" encoding="utf-8"?>
 <p:sld xmlns:a="http://schemas.openxmlformats.org/drawingml/2006/main" xmlns:r="http://schemas.openxmlformats.org/officeDocument/2006/relationships" xmlns:p="http://schemas.openxmlformats.org/presentationml/2006/main">
   <p:cSld>
     <p:spTree>
@@ -4903,7 +5906,7 @@
         <p:cNvPr id="1" name="">
           <a:extLst>
             <a:ext uri="{FF2B5EF4-FFF2-40B4-BE49-F238E27FC236}">
-              <a16:creationId xmlns:a16="http://schemas.microsoft.com/office/drawing/2014/main" id="{C3B1FAB6-CAAE-38E7-1535-4637C824963E}"/>
+              <a16:creationId xmlns:a16="http://schemas.microsoft.com/office/drawing/2014/main" id="{9F91D841-F4FB-4B38-DADF-8E846184F251}"/>
             </a:ext>
           </a:extLst>
         </p:cNvPr>
@@ -4923,7 +5926,7 @@
           <p:cNvPr id="9" name="文本框 8">
             <a:extLst>
               <a:ext uri="{FF2B5EF4-FFF2-40B4-BE49-F238E27FC236}">
-                <a16:creationId xmlns:a16="http://schemas.microsoft.com/office/drawing/2014/main" id="{60F819B1-FF07-1AE9-B113-9C23028DB5F8}"/>
+                <a16:creationId xmlns:a16="http://schemas.microsoft.com/office/drawing/2014/main" id="{D1D645B3-8BE5-34A7-1C43-3C8E107D4A76}"/>
               </a:ext>
             </a:extLst>
           </p:cNvPr>
@@ -4933,7 +5936,7 @@
         <p:spPr>
           <a:xfrm>
             <a:off x="185420" y="242570"/>
-            <a:ext cx="1334020" cy="369332"/>
+            <a:ext cx="2576346" cy="369332"/>
           </a:xfrm>
           <a:prstGeom prst="rect">
             <a:avLst/>
@@ -4948,7 +5951,7 @@
           <a:p>
             <a:r>
               <a:rPr lang="en-US" altLang="zh-CN" b="1" dirty="0"/>
-              <a:t>Motivation</a:t>
+              <a:t>Controller Formulation</a:t>
             </a:r>
             <a:endParaRPr lang="zh-CN" altLang="en-US" b="1" dirty="0"/>
           </a:p>
@@ -4956,10 +5959,10 @@
       </p:sp>
       <p:sp>
         <p:nvSpPr>
-          <p:cNvPr id="10" name="文本框 9">
-            <a:extLst>
-              <a:ext uri="{FF2B5EF4-FFF2-40B4-BE49-F238E27FC236}">
-                <a16:creationId xmlns:a16="http://schemas.microsoft.com/office/drawing/2014/main" id="{F1AFA4A2-BD2A-2577-930C-417A5EBA9671}"/>
+          <p:cNvPr id="2" name="文本框 1">
+            <a:extLst>
+              <a:ext uri="{FF2B5EF4-FFF2-40B4-BE49-F238E27FC236}">
+                <a16:creationId xmlns:a16="http://schemas.microsoft.com/office/drawing/2014/main" id="{0836F9C8-C82C-EAC0-9D64-7A89439A0955}"/>
               </a:ext>
             </a:extLst>
           </p:cNvPr>
@@ -4968,8 +5971,8 @@
         </p:nvSpPr>
         <p:spPr>
           <a:xfrm>
-            <a:off x="185420" y="790853"/>
-            <a:ext cx="2848857" cy="923330"/>
+            <a:off x="185420" y="882650"/>
+            <a:ext cx="3419526" cy="369332"/>
           </a:xfrm>
           <a:prstGeom prst="rect">
             <a:avLst/>
@@ -4982,30 +5985,9 @@
           </a:bodyPr>
           <a:lstStyle/>
           <a:p>
-            <a:pPr marL="342900" indent="-342900">
-              <a:buAutoNum type="arabicPeriod"/>
-            </a:pPr>
             <a:r>
               <a:rPr lang="en-US" altLang="zh-CN" dirty="0"/>
-              <a:t>Foot placement</a:t>
-            </a:r>
-          </a:p>
-          <a:p>
-            <a:pPr marL="342900" indent="-342900">
-              <a:buAutoNum type="arabicPeriod"/>
-            </a:pPr>
-            <a:r>
-              <a:rPr lang="en-US" altLang="zh-CN" dirty="0"/>
-              <a:t>Phase ?</a:t>
-            </a:r>
-          </a:p>
-          <a:p>
-            <a:pPr marL="342900" indent="-342900">
-              <a:buAutoNum type="arabicPeriod"/>
-            </a:pPr>
-            <a:r>
-              <a:rPr lang="en-US" altLang="zh-CN" dirty="0"/>
-              <a:t>Compatible with MPC ?</a:t>
+              <a:t>MPC controller for torso motion</a:t>
             </a:r>
             <a:endParaRPr lang="zh-CN" altLang="en-US" dirty="0"/>
           </a:p>
@@ -5013,10 +5995,10 @@
       </p:sp>
       <p:sp>
         <p:nvSpPr>
-          <p:cNvPr id="5" name="文本框 4">
-            <a:extLst>
-              <a:ext uri="{FF2B5EF4-FFF2-40B4-BE49-F238E27FC236}">
-                <a16:creationId xmlns:a16="http://schemas.microsoft.com/office/drawing/2014/main" id="{83CF1CC3-39AF-17B0-C8F7-4AE33316CF0E}"/>
+          <p:cNvPr id="11" name="文本框 10">
+            <a:extLst>
+              <a:ext uri="{FF2B5EF4-FFF2-40B4-BE49-F238E27FC236}">
+                <a16:creationId xmlns:a16="http://schemas.microsoft.com/office/drawing/2014/main" id="{03E24CDE-0A4B-594D-55CB-9701630885B1}"/>
               </a:ext>
             </a:extLst>
           </p:cNvPr>
@@ -5025,8 +6007,8 @@
         </p:nvSpPr>
         <p:spPr>
           <a:xfrm>
-            <a:off x="2256904" y="6272879"/>
-            <a:ext cx="4725672" cy="261610"/>
+            <a:off x="203537" y="1631950"/>
+            <a:ext cx="2664512" cy="369332"/>
           </a:xfrm>
           <a:prstGeom prst="rect">
             <a:avLst/>
@@ -5034,75 +6016,35 @@
           <a:noFill/>
         </p:spPr>
         <p:txBody>
-          <a:bodyPr wrap="square">
+          <a:bodyPr wrap="none" rtlCol="0">
             <a:spAutoFit/>
           </a:bodyPr>
           <a:lstStyle/>
           <a:p>
             <a:r>
-              <a:rPr lang="zh-CN" altLang="zh-CN" sz="1100" b="0" i="0" spc="29" dirty="0">
-                <a:solidFill>
-                  <a:schemeClr val="tx1"/>
-                </a:solidFill>
-                <a:effectLst/>
-                <a:latin typeface="+mn-lt"/>
-              </a:rPr>
-              <a:t>Source: </a:t>
-            </a:r>
-            <a:r>
-              <a:rPr lang="en-US" altLang="zh-CN" sz="1100" spc="29" dirty="0"/>
-              <a:t>https://www.animatornotebook.com/learn/quadrupeds-gaits</a:t>
-            </a:r>
-            <a:endParaRPr lang="zh-CN" altLang="en-US" sz="1100" dirty="0"/>
-          </a:p>
-        </p:txBody>
-      </p:sp>
-      <p:pic>
-        <p:nvPicPr>
-          <p:cNvPr id="6" name="图片 5" descr="Footfall_trot.png">
-            <a:extLst>
-              <a:ext uri="{FF2B5EF4-FFF2-40B4-BE49-F238E27FC236}">
-                <a16:creationId xmlns:a16="http://schemas.microsoft.com/office/drawing/2014/main" id="{F8FDEAC9-88F4-1798-1E46-573E5C5DA6EB}"/>
-              </a:ext>
-            </a:extLst>
-          </p:cNvPr>
-          <p:cNvPicPr>
-            <a:picLocks noChangeAspect="1"/>
-          </p:cNvPicPr>
+              <a:rPr lang="en-US" altLang="zh-CN" dirty="0"/>
+              <a:t>Discrete dynamics model</a:t>
+            </a:r>
+            <a:endParaRPr lang="zh-CN" altLang="en-US" dirty="0"/>
+          </a:p>
+        </p:txBody>
+      </p:sp>
+      <p:sp>
+        <p:nvSpPr>
+          <p:cNvPr id="14" name="文本框 13">
+            <a:extLst>
+              <a:ext uri="{FF2B5EF4-FFF2-40B4-BE49-F238E27FC236}">
+                <a16:creationId xmlns:a16="http://schemas.microsoft.com/office/drawing/2014/main" id="{2CC1782B-3E78-126A-AFDD-FC6C0B5DAD38}"/>
+              </a:ext>
+            </a:extLst>
+          </p:cNvPr>
+          <p:cNvSpPr txBox="1"/>
           <p:nvPr/>
-        </p:nvPicPr>
-        <p:blipFill>
-          <a:blip r:embed="rId2"/>
-          <a:stretch>
-            <a:fillRect/>
-          </a:stretch>
-        </p:blipFill>
+        </p:nvSpPr>
         <p:spPr>
           <a:xfrm>
-            <a:off x="2106139" y="4254274"/>
-            <a:ext cx="7116339" cy="1779085"/>
-          </a:xfrm>
-          <a:prstGeom prst="rect">
-            <a:avLst/>
-          </a:prstGeom>
-        </p:spPr>
-      </p:pic>
-      <p:sp>
-        <p:nvSpPr>
-          <p:cNvPr id="8" name="文本框 7">
-            <a:extLst>
-              <a:ext uri="{FF2B5EF4-FFF2-40B4-BE49-F238E27FC236}">
-                <a16:creationId xmlns:a16="http://schemas.microsoft.com/office/drawing/2014/main" id="{ABE01369-B902-EF4D-B180-D55C3863A337}"/>
-              </a:ext>
-            </a:extLst>
-          </p:cNvPr>
-          <p:cNvSpPr txBox="1"/>
-          <p:nvPr/>
-        </p:nvSpPr>
-        <p:spPr>
-          <a:xfrm>
-            <a:off x="185420" y="2103120"/>
-            <a:ext cx="1920719" cy="369332"/>
+            <a:off x="203537" y="2323584"/>
+            <a:ext cx="2682145" cy="369332"/>
           </a:xfrm>
           <a:prstGeom prst="rect">
             <a:avLst/>
@@ -5116,19 +6058,19 @@
           <a:lstStyle/>
           <a:p>
             <a:r>
-              <a:rPr lang="en-US" altLang="zh-CN" b="1" dirty="0"/>
-              <a:t>Objects of Study</a:t>
-            </a:r>
-            <a:endParaRPr lang="zh-CN" altLang="en-US" b="1" dirty="0"/>
-          </a:p>
-        </p:txBody>
-      </p:sp>
-      <p:sp>
-        <p:nvSpPr>
-          <p:cNvPr id="11" name="文本框 10">
-            <a:extLst>
-              <a:ext uri="{FF2B5EF4-FFF2-40B4-BE49-F238E27FC236}">
-                <a16:creationId xmlns:a16="http://schemas.microsoft.com/office/drawing/2014/main" id="{C9AF6D05-D90D-82A4-3237-BCE0B4496297}"/>
+              <a:rPr lang="en-US" altLang="zh-CN" dirty="0"/>
+              <a:t>Optimization formulation</a:t>
+            </a:r>
+            <a:endParaRPr lang="zh-CN" altLang="en-US" dirty="0"/>
+          </a:p>
+        </p:txBody>
+      </p:sp>
+      <p:sp>
+        <p:nvSpPr>
+          <p:cNvPr id="18" name="文本框 17">
+            <a:extLst>
+              <a:ext uri="{FF2B5EF4-FFF2-40B4-BE49-F238E27FC236}">
+                <a16:creationId xmlns:a16="http://schemas.microsoft.com/office/drawing/2014/main" id="{59983BE2-0E92-8B7E-E7C8-4DDB76735D76}"/>
               </a:ext>
             </a:extLst>
           </p:cNvPr>
@@ -5137,8 +6079,8 @@
         </p:nvSpPr>
         <p:spPr>
           <a:xfrm>
-            <a:off x="185420" y="2676723"/>
-            <a:ext cx="2202847" cy="369332"/>
+            <a:off x="203537" y="3015218"/>
+            <a:ext cx="1806905" cy="369332"/>
           </a:xfrm>
           <a:prstGeom prst="rect">
             <a:avLst/>
@@ -5153,124 +6095,16 @@
           <a:p>
             <a:r>
               <a:rPr lang="en-US" altLang="zh-CN" dirty="0"/>
-              <a:t>Unitree Quadrupeds</a:t>
+              <a:t>Phase constraint</a:t>
             </a:r>
             <a:endParaRPr lang="zh-CN" altLang="en-US" dirty="0"/>
-          </a:p>
-        </p:txBody>
-      </p:sp>
-      <p:sp>
-        <p:nvSpPr>
-          <p:cNvPr id="18" name="文本框 17">
-            <a:extLst>
-              <a:ext uri="{FF2B5EF4-FFF2-40B4-BE49-F238E27FC236}">
-                <a16:creationId xmlns:a16="http://schemas.microsoft.com/office/drawing/2014/main" id="{E4EEBBD8-1E6B-363F-87BD-2A89DFC30FF9}"/>
-              </a:ext>
-            </a:extLst>
-          </p:cNvPr>
-          <p:cNvSpPr txBox="1"/>
-          <p:nvPr/>
-        </p:nvSpPr>
-        <p:spPr>
-          <a:xfrm>
-            <a:off x="185419" y="4057746"/>
-            <a:ext cx="974947" cy="369332"/>
-          </a:xfrm>
-          <a:prstGeom prst="rect">
-            <a:avLst/>
-          </a:prstGeom>
-          <a:noFill/>
-        </p:spPr>
-        <p:txBody>
-          <a:bodyPr wrap="none" rtlCol="0">
-            <a:spAutoFit/>
-          </a:bodyPr>
-          <a:lstStyle/>
-          <a:p>
-            <a:r>
-              <a:rPr lang="en-US" altLang="zh-CN" dirty="0"/>
-              <a:t>Trotting</a:t>
-            </a:r>
-            <a:endParaRPr lang="zh-CN" altLang="en-US" dirty="0"/>
-          </a:p>
-        </p:txBody>
-      </p:sp>
-      <p:pic>
-        <p:nvPicPr>
-          <p:cNvPr id="22" name="图片 21" descr="Robot Dog Go2_Quadruped_Robot Dog Company | Unitree Robotics">
-            <a:extLst>
-              <a:ext uri="{FF2B5EF4-FFF2-40B4-BE49-F238E27FC236}">
-                <a16:creationId xmlns:a16="http://schemas.microsoft.com/office/drawing/2014/main" id="{ACEC7929-A828-3948-84F5-B13C01713AAF}"/>
-              </a:ext>
-            </a:extLst>
-          </p:cNvPr>
-          <p:cNvPicPr>
-            <a:picLocks noChangeAspect="1"/>
-          </p:cNvPicPr>
-          <p:nvPr/>
-        </p:nvPicPr>
-        <p:blipFill>
-          <a:blip r:embed="rId3"/>
-          <a:stretch>
-            <a:fillRect/>
-          </a:stretch>
-        </p:blipFill>
-        <p:spPr>
-          <a:xfrm>
-            <a:off x="3034277" y="1893134"/>
-            <a:ext cx="2774722" cy="2292999"/>
-          </a:xfrm>
-          <a:prstGeom prst="rect">
-            <a:avLst/>
-          </a:prstGeom>
-        </p:spPr>
-      </p:pic>
-      <p:sp>
-        <p:nvSpPr>
-          <p:cNvPr id="26" name="文本框 25">
-            <a:extLst>
-              <a:ext uri="{FF2B5EF4-FFF2-40B4-BE49-F238E27FC236}">
-                <a16:creationId xmlns:a16="http://schemas.microsoft.com/office/drawing/2014/main" id="{F68E0426-E61A-1B08-A895-365C1785C822}"/>
-              </a:ext>
-            </a:extLst>
-          </p:cNvPr>
-          <p:cNvSpPr txBox="1"/>
-          <p:nvPr/>
-        </p:nvSpPr>
-        <p:spPr>
-          <a:xfrm>
-            <a:off x="2256904" y="6464614"/>
-            <a:ext cx="2665730" cy="261610"/>
-          </a:xfrm>
-          <a:prstGeom prst="rect">
-            <a:avLst/>
-          </a:prstGeom>
-          <a:noFill/>
-        </p:spPr>
-        <p:txBody>
-          <a:bodyPr wrap="square">
-            <a:spAutoFit/>
-          </a:bodyPr>
-          <a:lstStyle/>
-          <a:p>
-            <a:r>
-              <a:rPr lang="zh-CN" altLang="zh-CN" sz="1100" b="0" i="0" spc="29" dirty="0">
-                <a:solidFill>
-                  <a:schemeClr val="tx1"/>
-                </a:solidFill>
-                <a:effectLst/>
-                <a:latin typeface="+mn-lt"/>
-              </a:rPr>
-              <a:t>Source: https://youtu.be/oyTKvsnbCcE</a:t>
-            </a:r>
-            <a:endParaRPr lang="zh-CN" altLang="en-US" sz="1100" dirty="0"/>
           </a:p>
         </p:txBody>
       </p:sp>
     </p:spTree>
     <p:extLst>
       <p:ext uri="{BB962C8B-B14F-4D97-AF65-F5344CB8AC3E}">
-        <p14:creationId xmlns:p14="http://schemas.microsoft.com/office/powerpoint/2010/main" val="3431035551"/>
+        <p14:creationId xmlns:p14="http://schemas.microsoft.com/office/powerpoint/2010/main" val="428668732"/>
       </p:ext>
     </p:extLst>
   </p:cSld>
@@ -5280,7 +6114,7 @@
 </p:sld>
 </file>
 
-<file path=ppt/slides/slide4.xml><?xml version="1.0" encoding="utf-8"?>
+<file path=ppt/slides/slide7.xml><?xml version="1.0" encoding="utf-8"?>
 <p:sld xmlns:a="http://schemas.openxmlformats.org/drawingml/2006/main" xmlns:r="http://schemas.openxmlformats.org/officeDocument/2006/relationships" xmlns:p="http://schemas.openxmlformats.org/presentationml/2006/main">
   <p:cSld>
     <p:spTree>
@@ -5375,8 +6209,8 @@
           </a:p>
         </p:txBody>
       </p:sp>
-      <mc:AlternateContent xmlns:mc="http://schemas.openxmlformats.org/markup-compatibility/2006">
-        <mc:Choice xmlns:a14="http://schemas.microsoft.com/office/drawing/2010/main" Requires="a14">
+      <mc:AlternateContent xmlns:mc="http://schemas.openxmlformats.org/markup-compatibility/2006" xmlns:a14="http://schemas.microsoft.com/office/drawing/2010/main">
+        <mc:Choice Requires="a14">
           <p:sp>
             <p:nvSpPr>
               <p:cNvPr id="7" name="文本框 6">
@@ -5454,7 +6288,7 @@
             </p:txBody>
           </p:sp>
         </mc:Choice>
-        <mc:Fallback>
+        <mc:Fallback xmlns="">
           <p:sp>
             <p:nvSpPr>
               <p:cNvPr id="7" name="文本框 6">
@@ -5571,8 +6405,8 @@
           </a:p>
         </p:txBody>
       </p:sp>
-      <mc:AlternateContent xmlns:mc="http://schemas.openxmlformats.org/markup-compatibility/2006">
-        <mc:Choice xmlns:a14="http://schemas.microsoft.com/office/drawing/2010/main" Requires="a14">
+      <mc:AlternateContent xmlns:mc="http://schemas.openxmlformats.org/markup-compatibility/2006" xmlns:a14="http://schemas.microsoft.com/office/drawing/2010/main">
+        <mc:Choice Requires="a14">
           <p:sp>
             <p:nvSpPr>
               <p:cNvPr id="17" name="文本框 16">
@@ -5749,7 +6583,7 @@
             </p:txBody>
           </p:sp>
         </mc:Choice>
-        <mc:Fallback>
+        <mc:Fallback xmlns="">
           <p:sp>
             <p:nvSpPr>
               <p:cNvPr id="17" name="文本框 16">
@@ -5794,8 +6628,8 @@
           </p:sp>
         </mc:Fallback>
       </mc:AlternateContent>
-      <mc:AlternateContent xmlns:mc="http://schemas.openxmlformats.org/markup-compatibility/2006">
-        <mc:Choice xmlns:a14="http://schemas.microsoft.com/office/drawing/2010/main" Requires="a14">
+      <mc:AlternateContent xmlns:mc="http://schemas.openxmlformats.org/markup-compatibility/2006" xmlns:a14="http://schemas.microsoft.com/office/drawing/2010/main">
+        <mc:Choice Requires="a14">
           <p:sp>
             <p:nvSpPr>
               <p:cNvPr id="20" name="文本框 19">
@@ -5898,7 +6732,7 @@
             </p:txBody>
           </p:sp>
         </mc:Choice>
-        <mc:Fallback>
+        <mc:Fallback xmlns="">
           <p:sp>
             <p:nvSpPr>
               <p:cNvPr id="20" name="文本框 19">
@@ -6028,403 +6862,7 @@
 </p:sld>
 </file>
 
-<file path=ppt/slides/slide5.xml><?xml version="1.0" encoding="utf-8"?>
-<p:sld xmlns:a="http://schemas.openxmlformats.org/drawingml/2006/main" xmlns:r="http://schemas.openxmlformats.org/officeDocument/2006/relationships" xmlns:p="http://schemas.openxmlformats.org/presentationml/2006/main">
-  <p:cSld>
-    <p:spTree>
-      <p:nvGrpSpPr>
-        <p:cNvPr id="1" name="">
-          <a:extLst>
-            <a:ext uri="{FF2B5EF4-FFF2-40B4-BE49-F238E27FC236}">
-              <a16:creationId xmlns:a16="http://schemas.microsoft.com/office/drawing/2014/main" id="{9F91D841-F4FB-4B38-DADF-8E846184F251}"/>
-            </a:ext>
-          </a:extLst>
-        </p:cNvPr>
-        <p:cNvGrpSpPr/>
-        <p:nvPr/>
-      </p:nvGrpSpPr>
-      <p:grpSpPr>
-        <a:xfrm>
-          <a:off x="0" y="0"/>
-          <a:ext cx="0" cy="0"/>
-          <a:chOff x="0" y="0"/>
-          <a:chExt cx="0" cy="0"/>
-        </a:xfrm>
-      </p:grpSpPr>
-      <p:sp>
-        <p:nvSpPr>
-          <p:cNvPr id="9" name="文本框 8">
-            <a:extLst>
-              <a:ext uri="{FF2B5EF4-FFF2-40B4-BE49-F238E27FC236}">
-                <a16:creationId xmlns:a16="http://schemas.microsoft.com/office/drawing/2014/main" id="{D1D645B3-8BE5-34A7-1C43-3C8E107D4A76}"/>
-              </a:ext>
-            </a:extLst>
-          </p:cNvPr>
-          <p:cNvSpPr txBox="1"/>
-          <p:nvPr/>
-        </p:nvSpPr>
-        <p:spPr>
-          <a:xfrm>
-            <a:off x="185420" y="242570"/>
-            <a:ext cx="2576346" cy="369332"/>
-          </a:xfrm>
-          <a:prstGeom prst="rect">
-            <a:avLst/>
-          </a:prstGeom>
-          <a:noFill/>
-        </p:spPr>
-        <p:txBody>
-          <a:bodyPr wrap="none" rtlCol="0">
-            <a:spAutoFit/>
-          </a:bodyPr>
-          <a:lstStyle/>
-          <a:p>
-            <a:r>
-              <a:rPr lang="en-US" altLang="zh-CN" b="1" dirty="0"/>
-              <a:t>Controller Formulation</a:t>
-            </a:r>
-            <a:endParaRPr lang="zh-CN" altLang="en-US" b="1" dirty="0"/>
-          </a:p>
-        </p:txBody>
-      </p:sp>
-      <p:sp>
-        <p:nvSpPr>
-          <p:cNvPr id="2" name="文本框 1">
-            <a:extLst>
-              <a:ext uri="{FF2B5EF4-FFF2-40B4-BE49-F238E27FC236}">
-                <a16:creationId xmlns:a16="http://schemas.microsoft.com/office/drawing/2014/main" id="{0836F9C8-C82C-EAC0-9D64-7A89439A0955}"/>
-              </a:ext>
-            </a:extLst>
-          </p:cNvPr>
-          <p:cNvSpPr txBox="1"/>
-          <p:nvPr/>
-        </p:nvSpPr>
-        <p:spPr>
-          <a:xfrm>
-            <a:off x="185420" y="882650"/>
-            <a:ext cx="3419526" cy="369332"/>
-          </a:xfrm>
-          <a:prstGeom prst="rect">
-            <a:avLst/>
-          </a:prstGeom>
-          <a:noFill/>
-        </p:spPr>
-        <p:txBody>
-          <a:bodyPr wrap="none" rtlCol="0">
-            <a:spAutoFit/>
-          </a:bodyPr>
-          <a:lstStyle/>
-          <a:p>
-            <a:r>
-              <a:rPr lang="en-US" altLang="zh-CN" dirty="0"/>
-              <a:t>MPC controller for torso motion</a:t>
-            </a:r>
-            <a:endParaRPr lang="zh-CN" altLang="en-US" dirty="0"/>
-          </a:p>
-        </p:txBody>
-      </p:sp>
-      <p:sp>
-        <p:nvSpPr>
-          <p:cNvPr id="11" name="文本框 10">
-            <a:extLst>
-              <a:ext uri="{FF2B5EF4-FFF2-40B4-BE49-F238E27FC236}">
-                <a16:creationId xmlns:a16="http://schemas.microsoft.com/office/drawing/2014/main" id="{03E24CDE-0A4B-594D-55CB-9701630885B1}"/>
-              </a:ext>
-            </a:extLst>
-          </p:cNvPr>
-          <p:cNvSpPr txBox="1"/>
-          <p:nvPr/>
-        </p:nvSpPr>
-        <p:spPr>
-          <a:xfrm>
-            <a:off x="203537" y="1631950"/>
-            <a:ext cx="2664512" cy="369332"/>
-          </a:xfrm>
-          <a:prstGeom prst="rect">
-            <a:avLst/>
-          </a:prstGeom>
-          <a:noFill/>
-        </p:spPr>
-        <p:txBody>
-          <a:bodyPr wrap="none" rtlCol="0">
-            <a:spAutoFit/>
-          </a:bodyPr>
-          <a:lstStyle/>
-          <a:p>
-            <a:r>
-              <a:rPr lang="en-US" altLang="zh-CN" dirty="0"/>
-              <a:t>Discrete dynamics model</a:t>
-            </a:r>
-            <a:endParaRPr lang="zh-CN" altLang="en-US" dirty="0"/>
-          </a:p>
-        </p:txBody>
-      </p:sp>
-      <p:sp>
-        <p:nvSpPr>
-          <p:cNvPr id="14" name="文本框 13">
-            <a:extLst>
-              <a:ext uri="{FF2B5EF4-FFF2-40B4-BE49-F238E27FC236}">
-                <a16:creationId xmlns:a16="http://schemas.microsoft.com/office/drawing/2014/main" id="{2CC1782B-3E78-126A-AFDD-FC6C0B5DAD38}"/>
-              </a:ext>
-            </a:extLst>
-          </p:cNvPr>
-          <p:cNvSpPr txBox="1"/>
-          <p:nvPr/>
-        </p:nvSpPr>
-        <p:spPr>
-          <a:xfrm>
-            <a:off x="203537" y="2323584"/>
-            <a:ext cx="2682145" cy="369332"/>
-          </a:xfrm>
-          <a:prstGeom prst="rect">
-            <a:avLst/>
-          </a:prstGeom>
-          <a:noFill/>
-        </p:spPr>
-        <p:txBody>
-          <a:bodyPr wrap="none" rtlCol="0">
-            <a:spAutoFit/>
-          </a:bodyPr>
-          <a:lstStyle/>
-          <a:p>
-            <a:r>
-              <a:rPr lang="en-US" altLang="zh-CN" dirty="0"/>
-              <a:t>Optimization formulation</a:t>
-            </a:r>
-            <a:endParaRPr lang="zh-CN" altLang="en-US" dirty="0"/>
-          </a:p>
-        </p:txBody>
-      </p:sp>
-      <p:sp>
-        <p:nvSpPr>
-          <p:cNvPr id="18" name="文本框 17">
-            <a:extLst>
-              <a:ext uri="{FF2B5EF4-FFF2-40B4-BE49-F238E27FC236}">
-                <a16:creationId xmlns:a16="http://schemas.microsoft.com/office/drawing/2014/main" id="{59983BE2-0E92-8B7E-E7C8-4DDB76735D76}"/>
-              </a:ext>
-            </a:extLst>
-          </p:cNvPr>
-          <p:cNvSpPr txBox="1"/>
-          <p:nvPr/>
-        </p:nvSpPr>
-        <p:spPr>
-          <a:xfrm>
-            <a:off x="203537" y="3015218"/>
-            <a:ext cx="1806905" cy="369332"/>
-          </a:xfrm>
-          <a:prstGeom prst="rect">
-            <a:avLst/>
-          </a:prstGeom>
-          <a:noFill/>
-        </p:spPr>
-        <p:txBody>
-          <a:bodyPr wrap="none" rtlCol="0">
-            <a:spAutoFit/>
-          </a:bodyPr>
-          <a:lstStyle/>
-          <a:p>
-            <a:r>
-              <a:rPr lang="en-US" altLang="zh-CN" dirty="0"/>
-              <a:t>Phase constraint</a:t>
-            </a:r>
-            <a:endParaRPr lang="zh-CN" altLang="en-US" dirty="0"/>
-          </a:p>
-        </p:txBody>
-      </p:sp>
-    </p:spTree>
-    <p:extLst>
-      <p:ext uri="{BB962C8B-B14F-4D97-AF65-F5344CB8AC3E}">
-        <p14:creationId xmlns:p14="http://schemas.microsoft.com/office/powerpoint/2010/main" val="428668732"/>
-      </p:ext>
-    </p:extLst>
-  </p:cSld>
-  <p:clrMapOvr>
-    <a:masterClrMapping/>
-  </p:clrMapOvr>
-</p:sld>
-</file>
-
-<file path=ppt/slides/slide6.xml><?xml version="1.0" encoding="utf-8"?>
-<p:sld xmlns:a="http://schemas.openxmlformats.org/drawingml/2006/main" xmlns:r="http://schemas.openxmlformats.org/officeDocument/2006/relationships" xmlns:p="http://schemas.openxmlformats.org/presentationml/2006/main">
-  <p:cSld>
-    <p:spTree>
-      <p:nvGrpSpPr>
-        <p:cNvPr id="1" name="">
-          <a:extLst>
-            <a:ext uri="{FF2B5EF4-FFF2-40B4-BE49-F238E27FC236}">
-              <a16:creationId xmlns:a16="http://schemas.microsoft.com/office/drawing/2014/main" id="{A62382F8-1C94-97E6-A9B9-168C9C10037E}"/>
-            </a:ext>
-          </a:extLst>
-        </p:cNvPr>
-        <p:cNvGrpSpPr/>
-        <p:nvPr/>
-      </p:nvGrpSpPr>
-      <p:grpSpPr>
-        <a:xfrm>
-          <a:off x="0" y="0"/>
-          <a:ext cx="0" cy="0"/>
-          <a:chOff x="0" y="0"/>
-          <a:chExt cx="0" cy="0"/>
-        </a:xfrm>
-      </p:grpSpPr>
-      <p:sp>
-        <p:nvSpPr>
-          <p:cNvPr id="9" name="文本框 8">
-            <a:extLst>
-              <a:ext uri="{FF2B5EF4-FFF2-40B4-BE49-F238E27FC236}">
-                <a16:creationId xmlns:a16="http://schemas.microsoft.com/office/drawing/2014/main" id="{A1196BF4-5DDD-0197-1B59-1DAE04CBAFBD}"/>
-              </a:ext>
-            </a:extLst>
-          </p:cNvPr>
-          <p:cNvSpPr txBox="1"/>
-          <p:nvPr/>
-        </p:nvSpPr>
-        <p:spPr>
-          <a:xfrm>
-            <a:off x="185420" y="242570"/>
-            <a:ext cx="2576346" cy="369332"/>
-          </a:xfrm>
-          <a:prstGeom prst="rect">
-            <a:avLst/>
-          </a:prstGeom>
-          <a:noFill/>
-        </p:spPr>
-        <p:txBody>
-          <a:bodyPr wrap="none" rtlCol="0">
-            <a:spAutoFit/>
-          </a:bodyPr>
-          <a:lstStyle/>
-          <a:p>
-            <a:r>
-              <a:rPr lang="en-US" altLang="zh-CN" b="1" dirty="0"/>
-              <a:t>Controller Formulation</a:t>
-            </a:r>
-            <a:endParaRPr lang="zh-CN" altLang="en-US" b="1" dirty="0"/>
-          </a:p>
-        </p:txBody>
-      </p:sp>
-      <p:sp>
-        <p:nvSpPr>
-          <p:cNvPr id="2" name="文本框 1">
-            <a:extLst>
-              <a:ext uri="{FF2B5EF4-FFF2-40B4-BE49-F238E27FC236}">
-                <a16:creationId xmlns:a16="http://schemas.microsoft.com/office/drawing/2014/main" id="{3406AADE-EA16-5800-A391-93909E86F3C1}"/>
-              </a:ext>
-            </a:extLst>
-          </p:cNvPr>
-          <p:cNvSpPr txBox="1"/>
-          <p:nvPr/>
-        </p:nvSpPr>
-        <p:spPr>
-          <a:xfrm>
-            <a:off x="185420" y="882650"/>
-            <a:ext cx="3047629" cy="369332"/>
-          </a:xfrm>
-          <a:prstGeom prst="rect">
-            <a:avLst/>
-          </a:prstGeom>
-          <a:noFill/>
-        </p:spPr>
-        <p:txBody>
-          <a:bodyPr wrap="none" rtlCol="0">
-            <a:spAutoFit/>
-          </a:bodyPr>
-          <a:lstStyle/>
-          <a:p>
-            <a:r>
-              <a:rPr lang="en-US" altLang="zh-CN" dirty="0"/>
-              <a:t>PD controller for joint torque</a:t>
-            </a:r>
-            <a:endParaRPr lang="zh-CN" altLang="en-US" dirty="0"/>
-          </a:p>
-        </p:txBody>
-      </p:sp>
-      <p:sp>
-        <p:nvSpPr>
-          <p:cNvPr id="4" name="文本框 3">
-            <a:extLst>
-              <a:ext uri="{FF2B5EF4-FFF2-40B4-BE49-F238E27FC236}">
-                <a16:creationId xmlns:a16="http://schemas.microsoft.com/office/drawing/2014/main" id="{D9489834-0DE3-ED81-0B42-65518C668A63}"/>
-              </a:ext>
-            </a:extLst>
-          </p:cNvPr>
-          <p:cNvSpPr txBox="1"/>
-          <p:nvPr/>
-        </p:nvSpPr>
-        <p:spPr>
-          <a:xfrm>
-            <a:off x="185420" y="1606550"/>
-            <a:ext cx="1207382" cy="369332"/>
-          </a:xfrm>
-          <a:prstGeom prst="rect">
-            <a:avLst/>
-          </a:prstGeom>
-          <a:noFill/>
-        </p:spPr>
-        <p:txBody>
-          <a:bodyPr wrap="none" rtlCol="0">
-            <a:spAutoFit/>
-          </a:bodyPr>
-          <a:lstStyle/>
-          <a:p>
-            <a:r>
-              <a:rPr lang="en-US" altLang="zh-CN" dirty="0"/>
-              <a:t>Stance leg</a:t>
-            </a:r>
-            <a:endParaRPr lang="zh-CN" altLang="en-US" dirty="0"/>
-          </a:p>
-        </p:txBody>
-      </p:sp>
-      <p:sp>
-        <p:nvSpPr>
-          <p:cNvPr id="6" name="文本框 5">
-            <a:extLst>
-              <a:ext uri="{FF2B5EF4-FFF2-40B4-BE49-F238E27FC236}">
-                <a16:creationId xmlns:a16="http://schemas.microsoft.com/office/drawing/2014/main" id="{BBF33458-2284-74DC-2250-CCEDB6643B5D}"/>
-              </a:ext>
-            </a:extLst>
-          </p:cNvPr>
-          <p:cNvSpPr txBox="1"/>
-          <p:nvPr/>
-        </p:nvSpPr>
-        <p:spPr>
-          <a:xfrm>
-            <a:off x="185420" y="2298184"/>
-            <a:ext cx="1141659" cy="369332"/>
-          </a:xfrm>
-          <a:prstGeom prst="rect">
-            <a:avLst/>
-          </a:prstGeom>
-          <a:noFill/>
-        </p:spPr>
-        <p:txBody>
-          <a:bodyPr wrap="none" rtlCol="0">
-            <a:spAutoFit/>
-          </a:bodyPr>
-          <a:lstStyle/>
-          <a:p>
-            <a:r>
-              <a:rPr lang="en-US" altLang="zh-CN" dirty="0"/>
-              <a:t>Swing leg</a:t>
-            </a:r>
-            <a:endParaRPr lang="zh-CN" altLang="en-US" dirty="0"/>
-          </a:p>
-        </p:txBody>
-      </p:sp>
-    </p:spTree>
-    <p:extLst>
-      <p:ext uri="{BB962C8B-B14F-4D97-AF65-F5344CB8AC3E}">
-        <p14:creationId xmlns:p14="http://schemas.microsoft.com/office/powerpoint/2010/main" val="2099233214"/>
-      </p:ext>
-    </p:extLst>
-  </p:cSld>
-  <p:clrMapOvr>
-    <a:masterClrMapping/>
-  </p:clrMapOvr>
-</p:sld>
-</file>
-
-<file path=ppt/slides/slide7.xml><?xml version="1.0" encoding="utf-8"?>
+<file path=ppt/slides/slide8.xml><?xml version="1.0" encoding="utf-8"?>
 <p:sld xmlns:a="http://schemas.openxmlformats.org/drawingml/2006/main" xmlns:r="http://schemas.openxmlformats.org/officeDocument/2006/relationships" xmlns:p="http://schemas.openxmlformats.org/presentationml/2006/main">
   <p:cSld>
     <p:spTree>
@@ -6644,7 +7082,7 @@
 </p:sld>
 </file>
 
-<file path=ppt/slides/slide8.xml><?xml version="1.0" encoding="utf-8"?>
+<file path=ppt/slides/slide9.xml><?xml version="1.0" encoding="utf-8"?>
 <p:sld xmlns:a="http://schemas.openxmlformats.org/drawingml/2006/main" xmlns:r="http://schemas.openxmlformats.org/officeDocument/2006/relationships" xmlns:p="http://schemas.openxmlformats.org/presentationml/2006/main">
   <p:cSld>
     <p:spTree>

</xml_diff>